<commit_message>
docs: finalize function architecture submission
Publish the final integrated Chapters 6-7 report, concise contribution wording, N/A entries, trace slides and model-derived product release. Include the rubric/manual checklist, 64 model checks, 34 Python and 3 JavaScript checks, and HTTP/browser evidence.
</commit_message>
<xml_diff>
--- a/docs/architecture-definition-function/StockLens_Function_Tracing.pptx
+++ b/docs/architecture-definition-function/StockLens_Function_Tracing.pptx
@@ -2,14 +2,14 @@
 <file path=ppt/presentation.xml><?xml version="1.0" encoding="utf-8"?>
 <p:presentation xmlns:p="http://schemas.openxmlformats.org/presentationml/2006/main">
   <p:sldMasterIdLst>
-    <p:sldMasterId xmlns:r="http://schemas.openxmlformats.org/officeDocument/2006/relationships" id="2147483648" r:id="R9b7da985d0214445"/>
+    <p:sldMasterId xmlns:r="http://schemas.openxmlformats.org/officeDocument/2006/relationships" id="2147483648" r:id="Rf2580b59d4724f36"/>
   </p:sldMasterIdLst>
   <p:notesMasterIdLst>
-    <p:notesMasterId xmlns:r="http://schemas.openxmlformats.org/officeDocument/2006/relationships" r:id="Rd0d9fd84bce84fd1"/>
+    <p:notesMasterId xmlns:r="http://schemas.openxmlformats.org/officeDocument/2006/relationships" r:id="Rb5dd875b886f49a1"/>
   </p:notesMasterIdLst>
   <p:sldIdLst>
-    <p:sldId xmlns:r="http://schemas.openxmlformats.org/officeDocument/2006/relationships" id="256" r:id="R639dd3ee3f62498d"/>
-    <p:sldId xmlns:r="http://schemas.openxmlformats.org/officeDocument/2006/relationships" id="257" r:id="R9a0554176b7a4f29"/>
+    <p:sldId xmlns:r="http://schemas.openxmlformats.org/officeDocument/2006/relationships" id="256" r:id="Rfe9160700d1d4db4"/>
+    <p:sldId xmlns:r="http://schemas.openxmlformats.org/officeDocument/2006/relationships" id="257" r:id="R61a5d2e4bc1641f6"/>
   </p:sldIdLst>
   <p:sldSz cx="14287500" cy="10477500"/>
   <p:notesSz cx="6858000" cy="9144000"/>
@@ -560,7 +560,7 @@
           <p:cNvPr id="3" name="Title">
             <a:extLst xmlns:a="http://schemas.openxmlformats.org/drawingml/2006/main">
               <a:ext uri="{FF2B5EF4-FFF2-40B4-BE49-F238E27FC236}">
-                <a16:creationId xmlns:a16="http://schemas.microsoft.com/office/drawing/2014/main" id="{1BC1B7AB-FC61-4126-B3FD-99EFDC42D1C3}"/>
+                <a16:creationId xmlns:a16="http://schemas.microsoft.com/office/drawing/2014/main" id="{F100D3E0-F279-472B-8C1E-B9167FA723DE}"/>
               </a:ext>
             </a:extLst>
           </p:cNvPr>
@@ -789,7 +789,7 @@
           <p:cNvPr id="2" name="Subtitle">
             <a:extLst xmlns:a="http://schemas.openxmlformats.org/drawingml/2006/main">
               <a:ext uri="{FF2B5EF4-FFF2-40B4-BE49-F238E27FC236}">
-                <a16:creationId xmlns:a16="http://schemas.microsoft.com/office/drawing/2014/main" id="{DDD07344-1F8B-4E02-89EC-FC37A045FADC}"/>
+                <a16:creationId xmlns:a16="http://schemas.microsoft.com/office/drawing/2014/main" id="{E8B6FE0C-1C47-4E1B-8264-DB9FE8468118}"/>
               </a:ext>
             </a:extLst>
           </p:cNvPr>
@@ -1035,7 +1035,7 @@
           <p:cNvPr id="2" name="Section title">
             <a:extLst xmlns:a="http://schemas.openxmlformats.org/drawingml/2006/main">
               <a:ext uri="{FF2B5EF4-FFF2-40B4-BE49-F238E27FC236}">
-                <a16:creationId xmlns:a16="http://schemas.microsoft.com/office/drawing/2014/main" id="{25F19829-B9E0-4E9E-BDF2-AEA82463BDFD}"/>
+                <a16:creationId xmlns:a16="http://schemas.microsoft.com/office/drawing/2014/main" id="{65E654D3-795B-43C1-A6F2-056273E5B898}"/>
               </a:ext>
             </a:extLst>
           </p:cNvPr>
@@ -1281,7 +1281,7 @@
           <p:cNvPr id="3" name="Title">
             <a:extLst xmlns:a="http://schemas.openxmlformats.org/drawingml/2006/main">
               <a:ext uri="{FF2B5EF4-FFF2-40B4-BE49-F238E27FC236}">
-                <a16:creationId xmlns:a16="http://schemas.microsoft.com/office/drawing/2014/main" id="{D37E673F-F166-4B4F-86F6-3162D35B7696}"/>
+                <a16:creationId xmlns:a16="http://schemas.microsoft.com/office/drawing/2014/main" id="{26C7029D-AECB-4C02-A127-40CB54863CFA}"/>
               </a:ext>
             </a:extLst>
           </p:cNvPr>
@@ -1510,7 +1510,7 @@
           <p:cNvPr id="2" name="Body">
             <a:extLst xmlns:a="http://schemas.openxmlformats.org/drawingml/2006/main">
               <a:ext uri="{FF2B5EF4-FFF2-40B4-BE49-F238E27FC236}">
-                <a16:creationId xmlns:a16="http://schemas.microsoft.com/office/drawing/2014/main" id="{DD2FEC95-2C02-4926-8AF3-610CA4E5107C}"/>
+                <a16:creationId xmlns:a16="http://schemas.microsoft.com/office/drawing/2014/main" id="{E297B435-CCC2-43FA-8C56-C9E13A17EDA3}"/>
               </a:ext>
             </a:extLst>
           </p:cNvPr>
@@ -1756,7 +1756,7 @@
           <p:cNvPr id="4" name="Title">
             <a:extLst xmlns:a="http://schemas.openxmlformats.org/drawingml/2006/main">
               <a:ext uri="{FF2B5EF4-FFF2-40B4-BE49-F238E27FC236}">
-                <a16:creationId xmlns:a16="http://schemas.microsoft.com/office/drawing/2014/main" id="{16432458-0EE8-43C1-90DD-27E21D4D9A37}"/>
+                <a16:creationId xmlns:a16="http://schemas.microsoft.com/office/drawing/2014/main" id="{2ED020C7-76FF-45E7-9E60-01F60FD37E3D}"/>
               </a:ext>
             </a:extLst>
           </p:cNvPr>
@@ -1985,7 +1985,7 @@
           <p:cNvPr id="2" name="Left column">
             <a:extLst xmlns:a="http://schemas.openxmlformats.org/drawingml/2006/main">
               <a:ext uri="{FF2B5EF4-FFF2-40B4-BE49-F238E27FC236}">
-                <a16:creationId xmlns:a16="http://schemas.microsoft.com/office/drawing/2014/main" id="{B9C29385-FC80-4EDF-83F3-C56487BF8C00}"/>
+                <a16:creationId xmlns:a16="http://schemas.microsoft.com/office/drawing/2014/main" id="{91C3E6BA-33F4-40F1-A42F-FD79EE1576A9}"/>
               </a:ext>
             </a:extLst>
           </p:cNvPr>
@@ -2214,7 +2214,7 @@
           <p:cNvPr id="3" name="Right column">
             <a:extLst xmlns:a="http://schemas.openxmlformats.org/drawingml/2006/main">
               <a:ext uri="{FF2B5EF4-FFF2-40B4-BE49-F238E27FC236}">
-                <a16:creationId xmlns:a16="http://schemas.microsoft.com/office/drawing/2014/main" id="{4F4C5AF1-9FF1-431B-A9E7-C78837D91F7B}"/>
+                <a16:creationId xmlns:a16="http://schemas.microsoft.com/office/drawing/2014/main" id="{F6789520-178E-4E82-A766-47BAFADA6A23}"/>
               </a:ext>
             </a:extLst>
           </p:cNvPr>
@@ -2460,7 +2460,7 @@
           <p:cNvPr id="3" name="Title">
             <a:extLst xmlns:a="http://schemas.openxmlformats.org/drawingml/2006/main">
               <a:ext uri="{FF2B5EF4-FFF2-40B4-BE49-F238E27FC236}">
-                <a16:creationId xmlns:a16="http://schemas.microsoft.com/office/drawing/2014/main" id="{CB66E449-1D8D-4E23-A85E-3C423C6C56AC}"/>
+                <a16:creationId xmlns:a16="http://schemas.microsoft.com/office/drawing/2014/main" id="{5D7CEAC8-8A03-415E-96BC-6945E3B437C2}"/>
               </a:ext>
             </a:extLst>
           </p:cNvPr>
@@ -2689,7 +2689,7 @@
           <p:cNvPr id="2" name="Left column">
             <a:extLst xmlns:a="http://schemas.openxmlformats.org/drawingml/2006/main">
               <a:ext uri="{FF2B5EF4-FFF2-40B4-BE49-F238E27FC236}">
-                <a16:creationId xmlns:a16="http://schemas.microsoft.com/office/drawing/2014/main" id="{1BB170E9-00E7-4A5B-8BCE-E1D8826581BC}"/>
+                <a16:creationId xmlns:a16="http://schemas.microsoft.com/office/drawing/2014/main" id="{E8BC5131-C639-44DF-86B9-4CF7B7B04AE9}"/>
               </a:ext>
             </a:extLst>
           </p:cNvPr>
@@ -2956,12 +2956,12 @@
   </p:cSld>
   <p:clrMap bg1="lt1" tx1="dk1" bg2="lt2" tx2="dk2" accent1="accent1" accent2="accent2" accent3="accent3" accent4="accent4" accent5="accent5" accent6="accent6" hlink="hlink" folHlink="folHlink"/>
   <p:sldLayoutIdLst>
-    <p:sldLayoutId xmlns:r="http://schemas.openxmlformats.org/officeDocument/2006/relationships" id="2147483649" r:id="Raed5051db20e4685"/>
-    <p:sldLayoutId xmlns:r="http://schemas.openxmlformats.org/officeDocument/2006/relationships" id="2147483650" r:id="R86f762c83bc34743"/>
-    <p:sldLayoutId xmlns:r="http://schemas.openxmlformats.org/officeDocument/2006/relationships" id="2147483651" r:id="R0d657a5e0f0245df"/>
-    <p:sldLayoutId xmlns:r="http://schemas.openxmlformats.org/officeDocument/2006/relationships" id="2147483652" r:id="Rc5d694adbe054fe6"/>
-    <p:sldLayoutId xmlns:r="http://schemas.openxmlformats.org/officeDocument/2006/relationships" id="2147483653" r:id="Rcf13293f117249ed"/>
-    <p:sldLayoutId xmlns:r="http://schemas.openxmlformats.org/officeDocument/2006/relationships" id="2147483654" r:id="R3db9ed17d2664c2e"/>
+    <p:sldLayoutId xmlns:r="http://schemas.openxmlformats.org/officeDocument/2006/relationships" id="2147483649" r:id="R6f4276fc3d104add"/>
+    <p:sldLayoutId xmlns:r="http://schemas.openxmlformats.org/officeDocument/2006/relationships" id="2147483650" r:id="R599d0649e168418c"/>
+    <p:sldLayoutId xmlns:r="http://schemas.openxmlformats.org/officeDocument/2006/relationships" id="2147483651" r:id="R280096c884d8401f"/>
+    <p:sldLayoutId xmlns:r="http://schemas.openxmlformats.org/officeDocument/2006/relationships" id="2147483652" r:id="Raf72f6ce43994de9"/>
+    <p:sldLayoutId xmlns:r="http://schemas.openxmlformats.org/officeDocument/2006/relationships" id="2147483653" r:id="Rac6d231e78a74503"/>
+    <p:sldLayoutId xmlns:r="http://schemas.openxmlformats.org/officeDocument/2006/relationships" id="2147483654" r:id="Rac36eda6438544bc"/>
   </p:sldLayoutIdLst>
   <p:txStyles>
     <p:titleStyle>
@@ -3512,7 +3512,7 @@
           <p:cNvPr id="55" name="">
             <a:extLst xmlns:a="http://schemas.openxmlformats.org/drawingml/2006/main">
               <a:ext uri="{FF2B5EF4-FFF2-40B4-BE49-F238E27FC236}">
-                <a16:creationId xmlns:a16="http://schemas.microsoft.com/office/drawing/2014/main" id="{69BE826A-6672-4281-A2C4-ECF6DFFF5FF6}"/>
+                <a16:creationId xmlns:a16="http://schemas.microsoft.com/office/drawing/2014/main" id="{BE80771F-9AE6-4A76-99B4-16B19630BE47}"/>
               </a:ext>
             </a:extLst>
           </p:cNvPr>
@@ -3668,7 +3668,7 @@
           <p:cNvPr id="2" name="">
             <a:extLst xmlns:a="http://schemas.openxmlformats.org/drawingml/2006/main">
               <a:ext uri="{FF2B5EF4-FFF2-40B4-BE49-F238E27FC236}">
-                <a16:creationId xmlns:a16="http://schemas.microsoft.com/office/drawing/2014/main" id="{EE414D8F-78B6-4D89-9A1B-4F428BAB37A0}"/>
+                <a16:creationId xmlns:a16="http://schemas.microsoft.com/office/drawing/2014/main" id="{2FA33B7C-D848-4757-8ED7-6F57C184F08E}"/>
               </a:ext>
             </a:extLst>
           </p:cNvPr>
@@ -3824,7 +3824,7 @@
           <p:cNvPr id="3" name="">
             <a:extLst xmlns:a="http://schemas.openxmlformats.org/drawingml/2006/main">
               <a:ext uri="{FF2B5EF4-FFF2-40B4-BE49-F238E27FC236}">
-                <a16:creationId xmlns:a16="http://schemas.microsoft.com/office/drawing/2014/main" id="{57DADE91-0B14-4E8E-A95F-4FD86E7F6AE8}"/>
+                <a16:creationId xmlns:a16="http://schemas.microsoft.com/office/drawing/2014/main" id="{588B3552-FC38-4BC9-8B3E-FCEEF2BB6922}"/>
               </a:ext>
             </a:extLst>
           </p:cNvPr>
@@ -3834,7 +3834,7 @@
           <p:nvPr/>
         </p:nvPicPr>
         <p:blipFill>
-          <a:blip xmlns:r="http://schemas.openxmlformats.org/officeDocument/2006/relationships" xmlns:a="http://schemas.openxmlformats.org/drawingml/2006/main" r:embed="R44fadb3aa80146ee"/>
+          <a:blip xmlns:r="http://schemas.openxmlformats.org/officeDocument/2006/relationships" xmlns:a="http://schemas.openxmlformats.org/drawingml/2006/main" r:embed="R1ad730f7c9714397"/>
           <a:stretch xmlns:a="http://schemas.openxmlformats.org/drawingml/2006/main"/>
         </p:blipFill>
         <p:spPr>
@@ -3852,7 +3852,7 @@
           <p:cNvPr id="4" name="">
             <a:extLst xmlns:a="http://schemas.openxmlformats.org/drawingml/2006/main">
               <a:ext uri="{FF2B5EF4-FFF2-40B4-BE49-F238E27FC236}">
-                <a16:creationId xmlns:a16="http://schemas.microsoft.com/office/drawing/2014/main" id="{694AA0D1-3322-4FC2-8C79-6E027A9356C3}"/>
+                <a16:creationId xmlns:a16="http://schemas.microsoft.com/office/drawing/2014/main" id="{C3DC9353-64EB-48A9-84F6-EC546EF5154E}"/>
               </a:ext>
             </a:extLst>
           </p:cNvPr>
@@ -3882,7 +3882,7 @@
           <p:cNvPr id="5" name="">
             <a:extLst xmlns:a="http://schemas.openxmlformats.org/drawingml/2006/main">
               <a:ext uri="{FF2B5EF4-FFF2-40B4-BE49-F238E27FC236}">
-                <a16:creationId xmlns:a16="http://schemas.microsoft.com/office/drawing/2014/main" id="{C216A8D2-2A30-458D-89D8-033BA0F82B4D}"/>
+                <a16:creationId xmlns:a16="http://schemas.microsoft.com/office/drawing/2014/main" id="{7B9F60B7-9976-43AC-B46D-FC466BC0242A}"/>
               </a:ext>
             </a:extLst>
           </p:cNvPr>
@@ -3912,7 +3912,7 @@
           <p:cNvPr id="6" name="">
             <a:extLst xmlns:a="http://schemas.openxmlformats.org/drawingml/2006/main">
               <a:ext uri="{FF2B5EF4-FFF2-40B4-BE49-F238E27FC236}">
-                <a16:creationId xmlns:a16="http://schemas.microsoft.com/office/drawing/2014/main" id="{5EE5645A-F4E5-4B95-9D14-6922BD2C3717}"/>
+                <a16:creationId xmlns:a16="http://schemas.microsoft.com/office/drawing/2014/main" id="{47F07341-0B88-48BD-9400-AC5F84AD3C90}"/>
               </a:ext>
             </a:extLst>
           </p:cNvPr>
@@ -3942,7 +3942,7 @@
           <p:cNvPr id="7" name="">
             <a:extLst xmlns:a="http://schemas.openxmlformats.org/drawingml/2006/main">
               <a:ext uri="{FF2B5EF4-FFF2-40B4-BE49-F238E27FC236}">
-                <a16:creationId xmlns:a16="http://schemas.microsoft.com/office/drawing/2014/main" id="{F939C4AC-BA02-4F22-B010-E3DC1A7F72CF}"/>
+                <a16:creationId xmlns:a16="http://schemas.microsoft.com/office/drawing/2014/main" id="{03959B81-174B-4953-9A69-768763D7B93C}"/>
               </a:ext>
             </a:extLst>
           </p:cNvPr>
@@ -3972,7 +3972,7 @@
           <p:cNvPr id="8" name="">
             <a:extLst xmlns:a="http://schemas.openxmlformats.org/drawingml/2006/main">
               <a:ext uri="{FF2B5EF4-FFF2-40B4-BE49-F238E27FC236}">
-                <a16:creationId xmlns:a16="http://schemas.microsoft.com/office/drawing/2014/main" id="{937DB98A-72BC-42BF-AD0F-E75C744ECA12}"/>
+                <a16:creationId xmlns:a16="http://schemas.microsoft.com/office/drawing/2014/main" id="{4A9582F9-2A51-4DEB-832C-4F718B2FABCF}"/>
               </a:ext>
             </a:extLst>
           </p:cNvPr>
@@ -4002,7 +4002,7 @@
           <p:cNvPr id="9" name="">
             <a:extLst xmlns:a="http://schemas.openxmlformats.org/drawingml/2006/main">
               <a:ext uri="{FF2B5EF4-FFF2-40B4-BE49-F238E27FC236}">
-                <a16:creationId xmlns:a16="http://schemas.microsoft.com/office/drawing/2014/main" id="{C3817AE9-AA59-48D5-BA79-A935CEFF09E8}"/>
+                <a16:creationId xmlns:a16="http://schemas.microsoft.com/office/drawing/2014/main" id="{FB93BE6B-30B4-49FE-B1B1-56C7284C0219}"/>
               </a:ext>
             </a:extLst>
           </p:cNvPr>
@@ -4029,7 +4029,7 @@
           <p:cNvPr id="10" name="">
             <a:extLst xmlns:a="http://schemas.openxmlformats.org/drawingml/2006/main">
               <a:ext uri="{FF2B5EF4-FFF2-40B4-BE49-F238E27FC236}">
-                <a16:creationId xmlns:a16="http://schemas.microsoft.com/office/drawing/2014/main" id="{97262337-407F-4B1F-A77C-8809D2B01808}"/>
+                <a16:creationId xmlns:a16="http://schemas.microsoft.com/office/drawing/2014/main" id="{F2D45478-496B-4D70-B04F-A026E8DCA70B}"/>
               </a:ext>
             </a:extLst>
           </p:cNvPr>
@@ -4056,7 +4056,7 @@
           <p:cNvPr id="11" name="">
             <a:extLst xmlns:a="http://schemas.openxmlformats.org/drawingml/2006/main">
               <a:ext uri="{FF2B5EF4-FFF2-40B4-BE49-F238E27FC236}">
-                <a16:creationId xmlns:a16="http://schemas.microsoft.com/office/drawing/2014/main" id="{81A131FA-B0AB-445F-9C65-4557158D5885}"/>
+                <a16:creationId xmlns:a16="http://schemas.microsoft.com/office/drawing/2014/main" id="{4B1FC15D-C833-4B9C-9A47-9F482E99E449}"/>
               </a:ext>
             </a:extLst>
           </p:cNvPr>
@@ -4084,7 +4084,7 @@
           <p:cNvPr id="12" name="">
             <a:extLst xmlns:a="http://schemas.openxmlformats.org/drawingml/2006/main">
               <a:ext uri="{FF2B5EF4-FFF2-40B4-BE49-F238E27FC236}">
-                <a16:creationId xmlns:a16="http://schemas.microsoft.com/office/drawing/2014/main" id="{37B2D7B9-5346-4D01-9CB1-F4ECBE1DFB2E}"/>
+                <a16:creationId xmlns:a16="http://schemas.microsoft.com/office/drawing/2014/main" id="{0421979D-3982-4346-A5A1-8A3161191504}"/>
               </a:ext>
             </a:extLst>
           </p:cNvPr>
@@ -4112,7 +4112,7 @@
           <p:cNvPr id="13" name="">
             <a:extLst xmlns:a="http://schemas.openxmlformats.org/drawingml/2006/main">
               <a:ext uri="{FF2B5EF4-FFF2-40B4-BE49-F238E27FC236}">
-                <a16:creationId xmlns:a16="http://schemas.microsoft.com/office/drawing/2014/main" id="{CECCF846-B051-4EFE-B002-0EADFBA64E63}"/>
+                <a16:creationId xmlns:a16="http://schemas.microsoft.com/office/drawing/2014/main" id="{4737591D-CB23-41B1-80F8-461789392D91}"/>
               </a:ext>
             </a:extLst>
           </p:cNvPr>
@@ -4140,7 +4140,7 @@
           <p:cNvPr id="14" name="">
             <a:extLst xmlns:a="http://schemas.openxmlformats.org/drawingml/2006/main">
               <a:ext uri="{FF2B5EF4-FFF2-40B4-BE49-F238E27FC236}">
-                <a16:creationId xmlns:a16="http://schemas.microsoft.com/office/drawing/2014/main" id="{B0443FC9-81B2-44F1-8992-9377C980A599}"/>
+                <a16:creationId xmlns:a16="http://schemas.microsoft.com/office/drawing/2014/main" id="{1DCD5AAD-5AD8-4A62-AD41-0CFB553937A8}"/>
               </a:ext>
             </a:extLst>
           </p:cNvPr>
@@ -4168,7 +4168,7 @@
           <p:cNvPr id="15" name="">
             <a:extLst xmlns:a="http://schemas.openxmlformats.org/drawingml/2006/main">
               <a:ext uri="{FF2B5EF4-FFF2-40B4-BE49-F238E27FC236}">
-                <a16:creationId xmlns:a16="http://schemas.microsoft.com/office/drawing/2014/main" id="{EAEA9992-1137-4CE3-AE15-236766D13445}"/>
+                <a16:creationId xmlns:a16="http://schemas.microsoft.com/office/drawing/2014/main" id="{67189779-6B9E-4765-BD6C-ACCE81A1A8D6}"/>
               </a:ext>
             </a:extLst>
           </p:cNvPr>
@@ -4196,7 +4196,7 @@
           <p:cNvPr id="16" name="">
             <a:extLst xmlns:a="http://schemas.openxmlformats.org/drawingml/2006/main">
               <a:ext uri="{FF2B5EF4-FFF2-40B4-BE49-F238E27FC236}">
-                <a16:creationId xmlns:a16="http://schemas.microsoft.com/office/drawing/2014/main" id="{E6E8D004-B0C5-4FD4-B986-0146E7AF29D3}"/>
+                <a16:creationId xmlns:a16="http://schemas.microsoft.com/office/drawing/2014/main" id="{4BF901C5-7E6F-4380-8588-B074497E6C11}"/>
               </a:ext>
             </a:extLst>
           </p:cNvPr>
@@ -4224,7 +4224,7 @@
           <p:cNvPr id="17" name="">
             <a:extLst xmlns:a="http://schemas.openxmlformats.org/drawingml/2006/main">
               <a:ext uri="{FF2B5EF4-FFF2-40B4-BE49-F238E27FC236}">
-                <a16:creationId xmlns:a16="http://schemas.microsoft.com/office/drawing/2014/main" id="{1A94F37C-14D4-459B-94CF-533B88F3F600}"/>
+                <a16:creationId xmlns:a16="http://schemas.microsoft.com/office/drawing/2014/main" id="{742D08B2-9436-4BBB-AA04-94CDC20054DD}"/>
               </a:ext>
             </a:extLst>
           </p:cNvPr>
@@ -4382,7 +4382,7 @@
           <p:cNvPr id="18" name="">
             <a:extLst xmlns:a="http://schemas.openxmlformats.org/drawingml/2006/main">
               <a:ext uri="{FF2B5EF4-FFF2-40B4-BE49-F238E27FC236}">
-                <a16:creationId xmlns:a16="http://schemas.microsoft.com/office/drawing/2014/main" id="{CD252028-0EE8-4481-8D41-D7B7A03006CD}"/>
+                <a16:creationId xmlns:a16="http://schemas.microsoft.com/office/drawing/2014/main" id="{47ABA691-6FAC-4949-9248-BCD8F006EA67}"/>
               </a:ext>
             </a:extLst>
           </p:cNvPr>
@@ -4409,7 +4409,7 @@
           <p:cNvPr id="19" name="">
             <a:extLst xmlns:a="http://schemas.openxmlformats.org/drawingml/2006/main">
               <a:ext uri="{FF2B5EF4-FFF2-40B4-BE49-F238E27FC236}">
-                <a16:creationId xmlns:a16="http://schemas.microsoft.com/office/drawing/2014/main" id="{89EB42BC-BE84-4231-B8D2-2B462D30AEC0}"/>
+                <a16:creationId xmlns:a16="http://schemas.microsoft.com/office/drawing/2014/main" id="{72E28ECF-C394-45A5-9E00-50615969E6D9}"/>
               </a:ext>
             </a:extLst>
           </p:cNvPr>
@@ -4436,7 +4436,7 @@
           <p:cNvPr id="20" name="">
             <a:extLst xmlns:a="http://schemas.openxmlformats.org/drawingml/2006/main">
               <a:ext uri="{FF2B5EF4-FFF2-40B4-BE49-F238E27FC236}">
-                <a16:creationId xmlns:a16="http://schemas.microsoft.com/office/drawing/2014/main" id="{221C3319-7CC6-472D-8903-524CC7A738D8}"/>
+                <a16:creationId xmlns:a16="http://schemas.microsoft.com/office/drawing/2014/main" id="{7C2D0D50-9A6C-4A13-8995-E0B9732E6A73}"/>
               </a:ext>
             </a:extLst>
           </p:cNvPr>
@@ -4464,7 +4464,7 @@
           <p:cNvPr id="21" name="">
             <a:extLst xmlns:a="http://schemas.openxmlformats.org/drawingml/2006/main">
               <a:ext uri="{FF2B5EF4-FFF2-40B4-BE49-F238E27FC236}">
-                <a16:creationId xmlns:a16="http://schemas.microsoft.com/office/drawing/2014/main" id="{2B10845E-F462-4F34-ABCE-D5F53B9B558B}"/>
+                <a16:creationId xmlns:a16="http://schemas.microsoft.com/office/drawing/2014/main" id="{5893A1AD-CF9C-4959-B474-7D418AFB2B0C}"/>
               </a:ext>
             </a:extLst>
           </p:cNvPr>
@@ -4622,7 +4622,7 @@
           <p:cNvPr id="22" name="">
             <a:extLst xmlns:a="http://schemas.openxmlformats.org/drawingml/2006/main">
               <a:ext uri="{FF2B5EF4-FFF2-40B4-BE49-F238E27FC236}">
-                <a16:creationId xmlns:a16="http://schemas.microsoft.com/office/drawing/2014/main" id="{C1C3A176-692F-4406-B0CE-E53FEB9E7771}"/>
+                <a16:creationId xmlns:a16="http://schemas.microsoft.com/office/drawing/2014/main" id="{7A4A7C3D-3F76-4A66-9FC3-BDBCBEE7B8D0}"/>
               </a:ext>
             </a:extLst>
           </p:cNvPr>
@@ -4650,7 +4650,7 @@
           <p:cNvPr id="23" name="">
             <a:extLst xmlns:a="http://schemas.openxmlformats.org/drawingml/2006/main">
               <a:ext uri="{FF2B5EF4-FFF2-40B4-BE49-F238E27FC236}">
-                <a16:creationId xmlns:a16="http://schemas.microsoft.com/office/drawing/2014/main" id="{0D0BAE4B-96BB-47F3-9022-62B5C309F584}"/>
+                <a16:creationId xmlns:a16="http://schemas.microsoft.com/office/drawing/2014/main" id="{2EB1A1B0-6E1F-4375-B100-466178A8B28C}"/>
               </a:ext>
             </a:extLst>
           </p:cNvPr>
@@ -4808,7 +4808,7 @@
           <p:cNvPr id="24" name="">
             <a:extLst xmlns:a="http://schemas.openxmlformats.org/drawingml/2006/main">
               <a:ext uri="{FF2B5EF4-FFF2-40B4-BE49-F238E27FC236}">
-                <a16:creationId xmlns:a16="http://schemas.microsoft.com/office/drawing/2014/main" id="{1CB98656-AFF1-449D-AD46-53CC3020149F}"/>
+                <a16:creationId xmlns:a16="http://schemas.microsoft.com/office/drawing/2014/main" id="{C80BC69F-E596-4640-ADD9-2140ABB1308C}"/>
               </a:ext>
             </a:extLst>
           </p:cNvPr>
@@ -4836,7 +4836,7 @@
           <p:cNvPr id="25" name="">
             <a:extLst xmlns:a="http://schemas.openxmlformats.org/drawingml/2006/main">
               <a:ext uri="{FF2B5EF4-FFF2-40B4-BE49-F238E27FC236}">
-                <a16:creationId xmlns:a16="http://schemas.microsoft.com/office/drawing/2014/main" id="{BCB58FC5-7B6A-4FEE-AE08-FEB113CB8C86}"/>
+                <a16:creationId xmlns:a16="http://schemas.microsoft.com/office/drawing/2014/main" id="{FEF45708-43A7-4FF1-B8DE-6CD8F70EA270}"/>
               </a:ext>
             </a:extLst>
           </p:cNvPr>
@@ -4994,7 +4994,7 @@
           <p:cNvPr id="26" name="">
             <a:extLst xmlns:a="http://schemas.openxmlformats.org/drawingml/2006/main">
               <a:ext uri="{FF2B5EF4-FFF2-40B4-BE49-F238E27FC236}">
-                <a16:creationId xmlns:a16="http://schemas.microsoft.com/office/drawing/2014/main" id="{1C3BEFDB-77EF-43FA-BCFA-22D7F2CB90BE}"/>
+                <a16:creationId xmlns:a16="http://schemas.microsoft.com/office/drawing/2014/main" id="{955D8109-7B12-4AED-AEFA-BFF1AF4D9E9B}"/>
               </a:ext>
             </a:extLst>
           </p:cNvPr>
@@ -5022,7 +5022,7 @@
           <p:cNvPr id="27" name="">
             <a:extLst xmlns:a="http://schemas.openxmlformats.org/drawingml/2006/main">
               <a:ext uri="{FF2B5EF4-FFF2-40B4-BE49-F238E27FC236}">
-                <a16:creationId xmlns:a16="http://schemas.microsoft.com/office/drawing/2014/main" id="{09D66806-8BE3-435E-A887-5D8E3B5D0F42}"/>
+                <a16:creationId xmlns:a16="http://schemas.microsoft.com/office/drawing/2014/main" id="{07C61D37-BDC8-4BAF-A849-129E3A3AFCE1}"/>
               </a:ext>
             </a:extLst>
           </p:cNvPr>
@@ -5180,7 +5180,7 @@
           <p:cNvPr id="28" name="">
             <a:extLst xmlns:a="http://schemas.openxmlformats.org/drawingml/2006/main">
               <a:ext uri="{FF2B5EF4-FFF2-40B4-BE49-F238E27FC236}">
-                <a16:creationId xmlns:a16="http://schemas.microsoft.com/office/drawing/2014/main" id="{ADCF6D40-A122-4FEA-9843-48FFF857C923}"/>
+                <a16:creationId xmlns:a16="http://schemas.microsoft.com/office/drawing/2014/main" id="{2A0A4697-55AA-4EBD-B503-6E41223B548C}"/>
               </a:ext>
             </a:extLst>
           </p:cNvPr>
@@ -5208,7 +5208,7 @@
           <p:cNvPr id="29" name="">
             <a:extLst xmlns:a="http://schemas.openxmlformats.org/drawingml/2006/main">
               <a:ext uri="{FF2B5EF4-FFF2-40B4-BE49-F238E27FC236}">
-                <a16:creationId xmlns:a16="http://schemas.microsoft.com/office/drawing/2014/main" id="{BF8577E3-73B0-4CB2-97FD-BD2F2CD7A6E4}"/>
+                <a16:creationId xmlns:a16="http://schemas.microsoft.com/office/drawing/2014/main" id="{D3E0C333-C286-4068-9358-FE267B69F0D2}"/>
               </a:ext>
             </a:extLst>
           </p:cNvPr>
@@ -5366,7 +5366,7 @@
           <p:cNvPr id="30" name="">
             <a:extLst xmlns:a="http://schemas.openxmlformats.org/drawingml/2006/main">
               <a:ext uri="{FF2B5EF4-FFF2-40B4-BE49-F238E27FC236}">
-                <a16:creationId xmlns:a16="http://schemas.microsoft.com/office/drawing/2014/main" id="{2FC69BF5-A5C9-4A5B-AE24-A317A6B01B7C}"/>
+                <a16:creationId xmlns:a16="http://schemas.microsoft.com/office/drawing/2014/main" id="{C0E20E40-FE6A-4714-9869-9705780D333F}"/>
               </a:ext>
             </a:extLst>
           </p:cNvPr>
@@ -5393,7 +5393,7 @@
           <p:cNvPr id="31" name="">
             <a:extLst xmlns:a="http://schemas.openxmlformats.org/drawingml/2006/main">
               <a:ext uri="{FF2B5EF4-FFF2-40B4-BE49-F238E27FC236}">
-                <a16:creationId xmlns:a16="http://schemas.microsoft.com/office/drawing/2014/main" id="{63E1822E-E4DB-4E44-A3AF-525A60CC255F}"/>
+                <a16:creationId xmlns:a16="http://schemas.microsoft.com/office/drawing/2014/main" id="{0928F67D-D94B-4B9C-8E82-4F8629031603}"/>
               </a:ext>
             </a:extLst>
           </p:cNvPr>
@@ -5420,7 +5420,7 @@
           <p:cNvPr id="32" name="">
             <a:extLst xmlns:a="http://schemas.openxmlformats.org/drawingml/2006/main">
               <a:ext uri="{FF2B5EF4-FFF2-40B4-BE49-F238E27FC236}">
-                <a16:creationId xmlns:a16="http://schemas.microsoft.com/office/drawing/2014/main" id="{BA9D80C3-FC57-4A11-AA75-6FB731FB44D1}"/>
+                <a16:creationId xmlns:a16="http://schemas.microsoft.com/office/drawing/2014/main" id="{1441207A-15FA-4B9B-932C-22F93911DD72}"/>
               </a:ext>
             </a:extLst>
           </p:cNvPr>
@@ -5448,7 +5448,7 @@
           <p:cNvPr id="33" name="">
             <a:extLst xmlns:a="http://schemas.openxmlformats.org/drawingml/2006/main">
               <a:ext uri="{FF2B5EF4-FFF2-40B4-BE49-F238E27FC236}">
-                <a16:creationId xmlns:a16="http://schemas.microsoft.com/office/drawing/2014/main" id="{EEFE7783-4787-4D30-BAAA-91215402E6C4}"/>
+                <a16:creationId xmlns:a16="http://schemas.microsoft.com/office/drawing/2014/main" id="{DAD04CD0-A08D-4DAD-ADC0-1F91032C1D29}"/>
               </a:ext>
             </a:extLst>
           </p:cNvPr>
@@ -5606,7 +5606,7 @@
           <p:cNvPr id="34" name="">
             <a:extLst xmlns:a="http://schemas.openxmlformats.org/drawingml/2006/main">
               <a:ext uri="{FF2B5EF4-FFF2-40B4-BE49-F238E27FC236}">
-                <a16:creationId xmlns:a16="http://schemas.microsoft.com/office/drawing/2014/main" id="{A7F9519F-F732-4420-ABFE-6C9B26AF6273}"/>
+                <a16:creationId xmlns:a16="http://schemas.microsoft.com/office/drawing/2014/main" id="{3F749E62-E62A-4D67-9ECE-488AED5A2196}"/>
               </a:ext>
             </a:extLst>
           </p:cNvPr>
@@ -5633,7 +5633,7 @@
           <p:cNvPr id="35" name="">
             <a:extLst xmlns:a="http://schemas.openxmlformats.org/drawingml/2006/main">
               <a:ext uri="{FF2B5EF4-FFF2-40B4-BE49-F238E27FC236}">
-                <a16:creationId xmlns:a16="http://schemas.microsoft.com/office/drawing/2014/main" id="{4C6044FB-46A4-40DD-BE65-E8FD65B58289}"/>
+                <a16:creationId xmlns:a16="http://schemas.microsoft.com/office/drawing/2014/main" id="{8E0C68BD-5FB8-4112-9344-306FF0A62895}"/>
               </a:ext>
             </a:extLst>
           </p:cNvPr>
@@ -5660,7 +5660,7 @@
           <p:cNvPr id="36" name="">
             <a:extLst xmlns:a="http://schemas.openxmlformats.org/drawingml/2006/main">
               <a:ext uri="{FF2B5EF4-FFF2-40B4-BE49-F238E27FC236}">
-                <a16:creationId xmlns:a16="http://schemas.microsoft.com/office/drawing/2014/main" id="{FE6C927D-4216-4D58-92DB-B2BC8F2054CE}"/>
+                <a16:creationId xmlns:a16="http://schemas.microsoft.com/office/drawing/2014/main" id="{067604BA-83A4-4F7D-A4B7-AB522E2A1B0A}"/>
               </a:ext>
             </a:extLst>
           </p:cNvPr>
@@ -5688,7 +5688,7 @@
           <p:cNvPr id="37" name="">
             <a:extLst xmlns:a="http://schemas.openxmlformats.org/drawingml/2006/main">
               <a:ext uri="{FF2B5EF4-FFF2-40B4-BE49-F238E27FC236}">
-                <a16:creationId xmlns:a16="http://schemas.microsoft.com/office/drawing/2014/main" id="{BCC4A76A-49B2-495D-AC8E-8E3BB49897ED}"/>
+                <a16:creationId xmlns:a16="http://schemas.microsoft.com/office/drawing/2014/main" id="{D7F27E8E-B4F8-48D8-B974-5B02D756C05E}"/>
               </a:ext>
             </a:extLst>
           </p:cNvPr>
@@ -5846,7 +5846,7 @@
           <p:cNvPr id="38" name="">
             <a:extLst xmlns:a="http://schemas.openxmlformats.org/drawingml/2006/main">
               <a:ext uri="{FF2B5EF4-FFF2-40B4-BE49-F238E27FC236}">
-                <a16:creationId xmlns:a16="http://schemas.microsoft.com/office/drawing/2014/main" id="{6152132D-0CD5-4525-B284-1BF4CABD7D71}"/>
+                <a16:creationId xmlns:a16="http://schemas.microsoft.com/office/drawing/2014/main" id="{6117F9F0-B948-40DC-8D24-E9A8538DEF90}"/>
               </a:ext>
             </a:extLst>
           </p:cNvPr>
@@ -5873,7 +5873,7 @@
           <p:cNvPr id="39" name="">
             <a:extLst xmlns:a="http://schemas.openxmlformats.org/drawingml/2006/main">
               <a:ext uri="{FF2B5EF4-FFF2-40B4-BE49-F238E27FC236}">
-                <a16:creationId xmlns:a16="http://schemas.microsoft.com/office/drawing/2014/main" id="{DA4E980F-E693-429B-8C21-2C07E3CF2783}"/>
+                <a16:creationId xmlns:a16="http://schemas.microsoft.com/office/drawing/2014/main" id="{6161B512-5DA3-4CE1-9D17-65F1CDC1F7D1}"/>
               </a:ext>
             </a:extLst>
           </p:cNvPr>
@@ -5901,7 +5901,7 @@
           <p:cNvPr id="40" name="">
             <a:extLst xmlns:a="http://schemas.openxmlformats.org/drawingml/2006/main">
               <a:ext uri="{FF2B5EF4-FFF2-40B4-BE49-F238E27FC236}">
-                <a16:creationId xmlns:a16="http://schemas.microsoft.com/office/drawing/2014/main" id="{1D40ECF9-1D22-490E-97CD-048386D7DFC2}"/>
+                <a16:creationId xmlns:a16="http://schemas.microsoft.com/office/drawing/2014/main" id="{22649E88-03C3-4A1C-A51A-AD09745C332C}"/>
               </a:ext>
             </a:extLst>
           </p:cNvPr>
@@ -6059,7 +6059,7 @@
           <p:cNvPr id="41" name="">
             <a:extLst xmlns:a="http://schemas.openxmlformats.org/drawingml/2006/main">
               <a:ext uri="{FF2B5EF4-FFF2-40B4-BE49-F238E27FC236}">
-                <a16:creationId xmlns:a16="http://schemas.microsoft.com/office/drawing/2014/main" id="{25DB98BB-F89D-42A4-B53D-328019C0BB71}"/>
+                <a16:creationId xmlns:a16="http://schemas.microsoft.com/office/drawing/2014/main" id="{27013356-5D5F-4692-A505-E5FE4B3841BE}"/>
               </a:ext>
             </a:extLst>
           </p:cNvPr>
@@ -6087,7 +6087,7 @@
           <p:cNvPr id="42" name="">
             <a:extLst xmlns:a="http://schemas.openxmlformats.org/drawingml/2006/main">
               <a:ext uri="{FF2B5EF4-FFF2-40B4-BE49-F238E27FC236}">
-                <a16:creationId xmlns:a16="http://schemas.microsoft.com/office/drawing/2014/main" id="{D26F230A-7BFA-4FDD-9171-ADB0A01933D0}"/>
+                <a16:creationId xmlns:a16="http://schemas.microsoft.com/office/drawing/2014/main" id="{3155EC29-27CB-4AB5-9D63-BE97D21BE605}"/>
               </a:ext>
             </a:extLst>
           </p:cNvPr>
@@ -6245,7 +6245,7 @@
           <p:cNvPr id="43" name="">
             <a:extLst xmlns:a="http://schemas.openxmlformats.org/drawingml/2006/main">
               <a:ext uri="{FF2B5EF4-FFF2-40B4-BE49-F238E27FC236}">
-                <a16:creationId xmlns:a16="http://schemas.microsoft.com/office/drawing/2014/main" id="{B8449016-F5E7-4545-939E-6B4E064B3A62}"/>
+                <a16:creationId xmlns:a16="http://schemas.microsoft.com/office/drawing/2014/main" id="{D3DDEE89-F4A4-4E03-B03A-4EBF81BC1419}"/>
               </a:ext>
             </a:extLst>
           </p:cNvPr>
@@ -6273,7 +6273,7 @@
           <p:cNvPr id="44" name="">
             <a:extLst xmlns:a="http://schemas.openxmlformats.org/drawingml/2006/main">
               <a:ext uri="{FF2B5EF4-FFF2-40B4-BE49-F238E27FC236}">
-                <a16:creationId xmlns:a16="http://schemas.microsoft.com/office/drawing/2014/main" id="{42F8463D-7A0B-4CE7-91B9-89155321E8E4}"/>
+                <a16:creationId xmlns:a16="http://schemas.microsoft.com/office/drawing/2014/main" id="{9EA3DA9F-5675-4865-91DF-09E7F862DEDB}"/>
               </a:ext>
             </a:extLst>
           </p:cNvPr>
@@ -6431,7 +6431,7 @@
           <p:cNvPr id="45" name="">
             <a:extLst xmlns:a="http://schemas.openxmlformats.org/drawingml/2006/main">
               <a:ext uri="{FF2B5EF4-FFF2-40B4-BE49-F238E27FC236}">
-                <a16:creationId xmlns:a16="http://schemas.microsoft.com/office/drawing/2014/main" id="{6E2593B0-BBC6-4809-8A9E-AD6492C6CF19}"/>
+                <a16:creationId xmlns:a16="http://schemas.microsoft.com/office/drawing/2014/main" id="{9EAEEAA1-3DC6-485A-BBA5-34674045BA9F}"/>
               </a:ext>
             </a:extLst>
           </p:cNvPr>
@@ -6458,7 +6458,7 @@
           <p:cNvPr id="46" name="">
             <a:extLst xmlns:a="http://schemas.openxmlformats.org/drawingml/2006/main">
               <a:ext uri="{FF2B5EF4-FFF2-40B4-BE49-F238E27FC236}">
-                <a16:creationId xmlns:a16="http://schemas.microsoft.com/office/drawing/2014/main" id="{20CB3FDB-E7B5-455D-A44B-E151E159ED06}"/>
+                <a16:creationId xmlns:a16="http://schemas.microsoft.com/office/drawing/2014/main" id="{98611155-4D59-42EE-81A8-DE7F9D06584C}"/>
               </a:ext>
             </a:extLst>
           </p:cNvPr>
@@ -6485,7 +6485,7 @@
           <p:cNvPr id="47" name="">
             <a:extLst xmlns:a="http://schemas.openxmlformats.org/drawingml/2006/main">
               <a:ext uri="{FF2B5EF4-FFF2-40B4-BE49-F238E27FC236}">
-                <a16:creationId xmlns:a16="http://schemas.microsoft.com/office/drawing/2014/main" id="{515499BA-0D3B-48BA-AD7C-94E98E18C325}"/>
+                <a16:creationId xmlns:a16="http://schemas.microsoft.com/office/drawing/2014/main" id="{EC111004-958A-40FF-8279-995880548635}"/>
               </a:ext>
             </a:extLst>
           </p:cNvPr>
@@ -6513,7 +6513,7 @@
           <p:cNvPr id="48" name="">
             <a:extLst xmlns:a="http://schemas.openxmlformats.org/drawingml/2006/main">
               <a:ext uri="{FF2B5EF4-FFF2-40B4-BE49-F238E27FC236}">
-                <a16:creationId xmlns:a16="http://schemas.microsoft.com/office/drawing/2014/main" id="{2BCAC1AC-F3A3-4C56-85A5-6B68D3CC7180}"/>
+                <a16:creationId xmlns:a16="http://schemas.microsoft.com/office/drawing/2014/main" id="{775DAB60-3EC7-4736-8EEB-3CB0E598148C}"/>
               </a:ext>
             </a:extLst>
           </p:cNvPr>
@@ -6671,7 +6671,7 @@
           <p:cNvPr id="49" name="">
             <a:extLst xmlns:a="http://schemas.openxmlformats.org/drawingml/2006/main">
               <a:ext uri="{FF2B5EF4-FFF2-40B4-BE49-F238E27FC236}">
-                <a16:creationId xmlns:a16="http://schemas.microsoft.com/office/drawing/2014/main" id="{D711CF66-584F-496D-A01D-90212797452D}"/>
+                <a16:creationId xmlns:a16="http://schemas.microsoft.com/office/drawing/2014/main" id="{CB2A6E97-7F79-45EE-AE9B-0EEB7281CDE1}"/>
               </a:ext>
             </a:extLst>
           </p:cNvPr>
@@ -6699,7 +6699,7 @@
           <p:cNvPr id="50" name="">
             <a:extLst xmlns:a="http://schemas.openxmlformats.org/drawingml/2006/main">
               <a:ext uri="{FF2B5EF4-FFF2-40B4-BE49-F238E27FC236}">
-                <a16:creationId xmlns:a16="http://schemas.microsoft.com/office/drawing/2014/main" id="{749AFDCB-410D-4014-91EF-5006F9DCFE2C}"/>
+                <a16:creationId xmlns:a16="http://schemas.microsoft.com/office/drawing/2014/main" id="{64ECD0C5-888A-4A91-AEDB-A070E240BEA8}"/>
               </a:ext>
             </a:extLst>
           </p:cNvPr>
@@ -6857,7 +6857,7 @@
           <p:cNvPr id="51" name="">
             <a:extLst xmlns:a="http://schemas.openxmlformats.org/drawingml/2006/main">
               <a:ext uri="{FF2B5EF4-FFF2-40B4-BE49-F238E27FC236}">
-                <a16:creationId xmlns:a16="http://schemas.microsoft.com/office/drawing/2014/main" id="{BF76CA10-EE86-4589-A9DA-75261B716225}"/>
+                <a16:creationId xmlns:a16="http://schemas.microsoft.com/office/drawing/2014/main" id="{F0625FC6-D34B-43AF-8C7B-DF610E4D674C}"/>
               </a:ext>
             </a:extLst>
           </p:cNvPr>
@@ -6885,7 +6885,7 @@
           <p:cNvPr id="52" name="">
             <a:extLst xmlns:a="http://schemas.openxmlformats.org/drawingml/2006/main">
               <a:ext uri="{FF2B5EF4-FFF2-40B4-BE49-F238E27FC236}">
-                <a16:creationId xmlns:a16="http://schemas.microsoft.com/office/drawing/2014/main" id="{ADE07DD9-E7FA-45A1-8EAD-8A7F52D90849}"/>
+                <a16:creationId xmlns:a16="http://schemas.microsoft.com/office/drawing/2014/main" id="{E7166B5D-DA31-412F-85CA-72B8392C26B8}"/>
               </a:ext>
             </a:extLst>
           </p:cNvPr>
@@ -7043,7 +7043,7 @@
           <p:cNvPr id="53" name="">
             <a:extLst xmlns:a="http://schemas.openxmlformats.org/drawingml/2006/main">
               <a:ext uri="{FF2B5EF4-FFF2-40B4-BE49-F238E27FC236}">
-                <a16:creationId xmlns:a16="http://schemas.microsoft.com/office/drawing/2014/main" id="{AE9514AC-752E-4DA2-B2D0-095064CCF434}"/>
+                <a16:creationId xmlns:a16="http://schemas.microsoft.com/office/drawing/2014/main" id="{8C70AECB-AF6A-4CA0-9980-9300EDFEF9F0}"/>
               </a:ext>
             </a:extLst>
           </p:cNvPr>
@@ -7201,7 +7201,7 @@
           <p:cNvPr id="54" name="">
             <a:extLst xmlns:a="http://schemas.openxmlformats.org/drawingml/2006/main">
               <a:ext uri="{FF2B5EF4-FFF2-40B4-BE49-F238E27FC236}">
-                <a16:creationId xmlns:a16="http://schemas.microsoft.com/office/drawing/2014/main" id="{FA5480DC-5C8E-45B9-87B6-426462AB8F65}"/>
+                <a16:creationId xmlns:a16="http://schemas.microsoft.com/office/drawing/2014/main" id="{529BADB8-91DB-4671-90F0-EC4BF68CF330}"/>
               </a:ext>
             </a:extLst>
           </p:cNvPr>
@@ -7355,7 +7355,7 @@
     </p:spTree>
     <p:extLst>
       <p:ext uri="{BB962C8B-B14F-4D97-AF65-F5344CB8AC3E}">
-        <p14:creationId xmlns:p14="http://schemas.microsoft.com/office/powerpoint/2010/main" val="1985055564"/>
+        <p14:creationId xmlns:p14="http://schemas.microsoft.com/office/powerpoint/2010/main" val="782078795"/>
       </p:ext>
     </p:extLst>
   </p:cSld>
@@ -7383,10 +7383,10 @@
       </p:grpSpPr>
       <p:sp>
         <p:nvSpPr>
-          <p:cNvPr id="58" name="">
+          <p:cNvPr id="70" name="">
             <a:extLst xmlns:a="http://schemas.openxmlformats.org/drawingml/2006/main">
               <a:ext uri="{FF2B5EF4-FFF2-40B4-BE49-F238E27FC236}">
-                <a16:creationId xmlns:a16="http://schemas.microsoft.com/office/drawing/2014/main" id="{45606BC4-81DD-4FC3-877C-271D51DC7415}"/>
+                <a16:creationId xmlns:a16="http://schemas.microsoft.com/office/drawing/2014/main" id="{C0D0498D-0C8C-4F60-8F62-EE3B25DFE9C5}"/>
               </a:ext>
             </a:extLst>
           </p:cNvPr>
@@ -7542,7 +7542,7 @@
           <p:cNvPr id="2" name="">
             <a:extLst xmlns:a="http://schemas.openxmlformats.org/drawingml/2006/main">
               <a:ext uri="{FF2B5EF4-FFF2-40B4-BE49-F238E27FC236}">
-                <a16:creationId xmlns:a16="http://schemas.microsoft.com/office/drawing/2014/main" id="{6CAEDE0C-59EC-4AD9-A229-AEFE425C39BE}"/>
+                <a16:creationId xmlns:a16="http://schemas.microsoft.com/office/drawing/2014/main" id="{EE84E3C5-4D1E-40A4-901B-F2030C3F01CC}"/>
               </a:ext>
             </a:extLst>
           </p:cNvPr>
@@ -7698,7 +7698,7 @@
           <p:cNvPr id="3" name="">
             <a:extLst xmlns:a="http://schemas.openxmlformats.org/drawingml/2006/main">
               <a:ext uri="{FF2B5EF4-FFF2-40B4-BE49-F238E27FC236}">
-                <a16:creationId xmlns:a16="http://schemas.microsoft.com/office/drawing/2014/main" id="{3475F697-D935-49A4-8282-4A4FEFF02CD6}"/>
+                <a16:creationId xmlns:a16="http://schemas.microsoft.com/office/drawing/2014/main" id="{06F4F8B3-8B6F-4649-897B-C55784B3E934}"/>
               </a:ext>
             </a:extLst>
           </p:cNvPr>
@@ -7730,7 +7730,7 @@
           <p:cNvPr id="4" name="">
             <a:extLst xmlns:a="http://schemas.openxmlformats.org/drawingml/2006/main">
               <a:ext uri="{FF2B5EF4-FFF2-40B4-BE49-F238E27FC236}">
-                <a16:creationId xmlns:a16="http://schemas.microsoft.com/office/drawing/2014/main" id="{BCCBADF4-8D61-4FA5-92C2-77B4CB2D2537}"/>
+                <a16:creationId xmlns:a16="http://schemas.microsoft.com/office/drawing/2014/main" id="{6978BD71-A39F-420E-85D2-E76C87539A54}"/>
               </a:ext>
             </a:extLst>
           </p:cNvPr>
@@ -7886,7 +7886,7 @@
           <p:cNvPr id="5" name="">
             <a:extLst xmlns:a="http://schemas.openxmlformats.org/drawingml/2006/main">
               <a:ext uri="{FF2B5EF4-FFF2-40B4-BE49-F238E27FC236}">
-                <a16:creationId xmlns:a16="http://schemas.microsoft.com/office/drawing/2014/main" id="{C0DDA939-F26E-4539-A4D0-7D210C8D59CE}"/>
+                <a16:creationId xmlns:a16="http://schemas.microsoft.com/office/drawing/2014/main" id="{A528E47F-6154-4522-88CD-607C55CC3222}"/>
               </a:ext>
             </a:extLst>
           </p:cNvPr>
@@ -7896,7 +7896,7 @@
         <p:spPr>
           <a:xfrm xmlns:a="http://schemas.openxmlformats.org/drawingml/2006/main">
             <a:off x="762000" y="1666875"/>
-            <a:ext cx="0" cy="7572375"/>
+            <a:ext cx="0" cy="7953375"/>
           </a:xfrm>
           <a:prstGeom xmlns:a="http://schemas.openxmlformats.org/drawingml/2006/main" prst="straightConnector1">
             <a:avLst/>
@@ -7913,7 +7913,7 @@
           <p:cNvPr id="6" name="">
             <a:extLst xmlns:a="http://schemas.openxmlformats.org/drawingml/2006/main">
               <a:ext uri="{FF2B5EF4-FFF2-40B4-BE49-F238E27FC236}">
-                <a16:creationId xmlns:a16="http://schemas.microsoft.com/office/drawing/2014/main" id="{A15082B3-EBEA-4121-90E7-B13DF7443A3E}"/>
+                <a16:creationId xmlns:a16="http://schemas.microsoft.com/office/drawing/2014/main" id="{FDED6139-7374-444A-A70E-0C12AF6FD25B}"/>
               </a:ext>
             </a:extLst>
           </p:cNvPr>
@@ -7945,7 +7945,7 @@
           <p:cNvPr id="7" name="">
             <a:extLst xmlns:a="http://schemas.openxmlformats.org/drawingml/2006/main">
               <a:ext uri="{FF2B5EF4-FFF2-40B4-BE49-F238E27FC236}">
-                <a16:creationId xmlns:a16="http://schemas.microsoft.com/office/drawing/2014/main" id="{B4E63BE2-B3CA-476D-91AF-61EF2B8B2087}"/>
+                <a16:creationId xmlns:a16="http://schemas.microsoft.com/office/drawing/2014/main" id="{48F6F997-D83B-4BD0-AE92-7F9FAA268399}"/>
               </a:ext>
             </a:extLst>
           </p:cNvPr>
@@ -8124,7 +8124,7 @@
           <p:cNvPr id="8" name="">
             <a:extLst xmlns:a="http://schemas.openxmlformats.org/drawingml/2006/main">
               <a:ext uri="{FF2B5EF4-FFF2-40B4-BE49-F238E27FC236}">
-                <a16:creationId xmlns:a16="http://schemas.microsoft.com/office/drawing/2014/main" id="{EA89FEC3-8B9A-442F-9AC1-18DB13334108}"/>
+                <a16:creationId xmlns:a16="http://schemas.microsoft.com/office/drawing/2014/main" id="{9D6F04FB-5313-431E-85B9-C114CB0FE99D}"/>
               </a:ext>
             </a:extLst>
           </p:cNvPr>
@@ -8134,7 +8134,7 @@
         <p:spPr>
           <a:xfrm xmlns:a="http://schemas.openxmlformats.org/drawingml/2006/main">
             <a:off x="2190750" y="1666875"/>
-            <a:ext cx="0" cy="7572375"/>
+            <a:ext cx="0" cy="7953375"/>
           </a:xfrm>
           <a:prstGeom xmlns:a="http://schemas.openxmlformats.org/drawingml/2006/main" prst="straightConnector1">
             <a:avLst/>
@@ -8151,7 +8151,7 @@
           <p:cNvPr id="9" name="">
             <a:extLst xmlns:a="http://schemas.openxmlformats.org/drawingml/2006/main">
               <a:ext uri="{FF2B5EF4-FFF2-40B4-BE49-F238E27FC236}">
-                <a16:creationId xmlns:a16="http://schemas.microsoft.com/office/drawing/2014/main" id="{09811A8E-7750-4FDE-B9F1-85614E3E1452}"/>
+                <a16:creationId xmlns:a16="http://schemas.microsoft.com/office/drawing/2014/main" id="{DEB13F08-35B2-49B4-81C2-E135D3BF5932}"/>
               </a:ext>
             </a:extLst>
           </p:cNvPr>
@@ -8183,7 +8183,7 @@
           <p:cNvPr id="10" name="">
             <a:extLst xmlns:a="http://schemas.openxmlformats.org/drawingml/2006/main">
               <a:ext uri="{FF2B5EF4-FFF2-40B4-BE49-F238E27FC236}">
-                <a16:creationId xmlns:a16="http://schemas.microsoft.com/office/drawing/2014/main" id="{2367CDF4-C153-44AF-A12A-21712F64B457}"/>
+                <a16:creationId xmlns:a16="http://schemas.microsoft.com/office/drawing/2014/main" id="{309A4F8B-A155-40C0-BF01-4489FB1F294E}"/>
               </a:ext>
             </a:extLst>
           </p:cNvPr>
@@ -8362,7 +8362,7 @@
           <p:cNvPr id="11" name="">
             <a:extLst xmlns:a="http://schemas.openxmlformats.org/drawingml/2006/main">
               <a:ext uri="{FF2B5EF4-FFF2-40B4-BE49-F238E27FC236}">
-                <a16:creationId xmlns:a16="http://schemas.microsoft.com/office/drawing/2014/main" id="{8539D849-BE4E-4662-813D-2B8AE296C58C}"/>
+                <a16:creationId xmlns:a16="http://schemas.microsoft.com/office/drawing/2014/main" id="{B97E25F6-4DE0-4A3B-85F0-023943D68D87}"/>
               </a:ext>
             </a:extLst>
           </p:cNvPr>
@@ -8372,7 +8372,7 @@
         <p:spPr>
           <a:xfrm xmlns:a="http://schemas.openxmlformats.org/drawingml/2006/main">
             <a:off x="3619500" y="1666875"/>
-            <a:ext cx="0" cy="7572375"/>
+            <a:ext cx="0" cy="7953375"/>
           </a:xfrm>
           <a:prstGeom xmlns:a="http://schemas.openxmlformats.org/drawingml/2006/main" prst="straightConnector1">
             <a:avLst/>
@@ -8389,7 +8389,7 @@
           <p:cNvPr id="12" name="">
             <a:extLst xmlns:a="http://schemas.openxmlformats.org/drawingml/2006/main">
               <a:ext uri="{FF2B5EF4-FFF2-40B4-BE49-F238E27FC236}">
-                <a16:creationId xmlns:a16="http://schemas.microsoft.com/office/drawing/2014/main" id="{9065982A-F1DE-4EA6-8A12-4BCF68975A45}"/>
+                <a16:creationId xmlns:a16="http://schemas.microsoft.com/office/drawing/2014/main" id="{17B5A76B-50C2-471D-A325-116B7626A5D2}"/>
               </a:ext>
             </a:extLst>
           </p:cNvPr>
@@ -8421,7 +8421,7 @@
           <p:cNvPr id="13" name="">
             <a:extLst xmlns:a="http://schemas.openxmlformats.org/drawingml/2006/main">
               <a:ext uri="{FF2B5EF4-FFF2-40B4-BE49-F238E27FC236}">
-                <a16:creationId xmlns:a16="http://schemas.microsoft.com/office/drawing/2014/main" id="{41E683FA-12FA-4310-BEB3-7AD2B749D45F}"/>
+                <a16:creationId xmlns:a16="http://schemas.microsoft.com/office/drawing/2014/main" id="{BECCD085-ADD0-4863-AC58-33836BCB94B4}"/>
               </a:ext>
             </a:extLst>
           </p:cNvPr>
@@ -8600,7 +8600,7 @@
           <p:cNvPr id="14" name="">
             <a:extLst xmlns:a="http://schemas.openxmlformats.org/drawingml/2006/main">
               <a:ext uri="{FF2B5EF4-FFF2-40B4-BE49-F238E27FC236}">
-                <a16:creationId xmlns:a16="http://schemas.microsoft.com/office/drawing/2014/main" id="{4A5D60B2-C4A3-4F29-929A-A0673F0960A6}"/>
+                <a16:creationId xmlns:a16="http://schemas.microsoft.com/office/drawing/2014/main" id="{E8A4ACD1-8CFE-4F70-BA88-BDDE6D34E511}"/>
               </a:ext>
             </a:extLst>
           </p:cNvPr>
@@ -8610,7 +8610,7 @@
         <p:spPr>
           <a:xfrm xmlns:a="http://schemas.openxmlformats.org/drawingml/2006/main">
             <a:off x="5048250" y="1666875"/>
-            <a:ext cx="0" cy="7572375"/>
+            <a:ext cx="0" cy="7953375"/>
           </a:xfrm>
           <a:prstGeom xmlns:a="http://schemas.openxmlformats.org/drawingml/2006/main" prst="straightConnector1">
             <a:avLst/>
@@ -8627,7 +8627,7 @@
           <p:cNvPr id="15" name="">
             <a:extLst xmlns:a="http://schemas.openxmlformats.org/drawingml/2006/main">
               <a:ext uri="{FF2B5EF4-FFF2-40B4-BE49-F238E27FC236}">
-                <a16:creationId xmlns:a16="http://schemas.microsoft.com/office/drawing/2014/main" id="{321E9634-68B1-4076-A385-08DD585DC630}"/>
+                <a16:creationId xmlns:a16="http://schemas.microsoft.com/office/drawing/2014/main" id="{BE7C58FB-284B-4F8B-A253-7E2891DCCB78}"/>
               </a:ext>
             </a:extLst>
           </p:cNvPr>
@@ -8659,7 +8659,7 @@
           <p:cNvPr id="16" name="">
             <a:extLst xmlns:a="http://schemas.openxmlformats.org/drawingml/2006/main">
               <a:ext uri="{FF2B5EF4-FFF2-40B4-BE49-F238E27FC236}">
-                <a16:creationId xmlns:a16="http://schemas.microsoft.com/office/drawing/2014/main" id="{BC3D30BB-061A-449F-99B8-F3C13BB7F40A}"/>
+                <a16:creationId xmlns:a16="http://schemas.microsoft.com/office/drawing/2014/main" id="{9CDD5BB6-D2BE-4FEB-AB60-771F1B663393}"/>
               </a:ext>
             </a:extLst>
           </p:cNvPr>
@@ -8838,7 +8838,7 @@
           <p:cNvPr id="17" name="">
             <a:extLst xmlns:a="http://schemas.openxmlformats.org/drawingml/2006/main">
               <a:ext uri="{FF2B5EF4-FFF2-40B4-BE49-F238E27FC236}">
-                <a16:creationId xmlns:a16="http://schemas.microsoft.com/office/drawing/2014/main" id="{0A4FB5CC-A153-4EAA-AF0D-956AB171E5D2}"/>
+                <a16:creationId xmlns:a16="http://schemas.microsoft.com/office/drawing/2014/main" id="{D8BAA8BB-0908-4EBB-A560-57954BCD2DF8}"/>
               </a:ext>
             </a:extLst>
           </p:cNvPr>
@@ -8848,7 +8848,7 @@
         <p:spPr>
           <a:xfrm xmlns:a="http://schemas.openxmlformats.org/drawingml/2006/main">
             <a:off x="6477000" y="1666875"/>
-            <a:ext cx="0" cy="7572375"/>
+            <a:ext cx="0" cy="7953375"/>
           </a:xfrm>
           <a:prstGeom xmlns:a="http://schemas.openxmlformats.org/drawingml/2006/main" prst="straightConnector1">
             <a:avLst/>
@@ -8865,7 +8865,7 @@
           <p:cNvPr id="18" name="">
             <a:extLst xmlns:a="http://schemas.openxmlformats.org/drawingml/2006/main">
               <a:ext uri="{FF2B5EF4-FFF2-40B4-BE49-F238E27FC236}">
-                <a16:creationId xmlns:a16="http://schemas.microsoft.com/office/drawing/2014/main" id="{737BE792-1B43-445C-A757-21218CA74AEC}"/>
+                <a16:creationId xmlns:a16="http://schemas.microsoft.com/office/drawing/2014/main" id="{89B11922-5D80-4AA8-933C-D1B86456A435}"/>
               </a:ext>
             </a:extLst>
           </p:cNvPr>
@@ -8897,7 +8897,7 @@
           <p:cNvPr id="19" name="">
             <a:extLst xmlns:a="http://schemas.openxmlformats.org/drawingml/2006/main">
               <a:ext uri="{FF2B5EF4-FFF2-40B4-BE49-F238E27FC236}">
-                <a16:creationId xmlns:a16="http://schemas.microsoft.com/office/drawing/2014/main" id="{99DA01BA-49BF-46D3-85C5-5F6600393D3C}"/>
+                <a16:creationId xmlns:a16="http://schemas.microsoft.com/office/drawing/2014/main" id="{62225C9E-7B71-4567-8B7B-3DC3EB98FBDC}"/>
               </a:ext>
             </a:extLst>
           </p:cNvPr>
@@ -9076,7 +9076,7 @@
           <p:cNvPr id="20" name="">
             <a:extLst xmlns:a="http://schemas.openxmlformats.org/drawingml/2006/main">
               <a:ext uri="{FF2B5EF4-FFF2-40B4-BE49-F238E27FC236}">
-                <a16:creationId xmlns:a16="http://schemas.microsoft.com/office/drawing/2014/main" id="{00495F92-F355-4D87-804E-A16C59194B95}"/>
+                <a16:creationId xmlns:a16="http://schemas.microsoft.com/office/drawing/2014/main" id="{BC900794-296E-49AE-AC34-51383EE0257D}"/>
               </a:ext>
             </a:extLst>
           </p:cNvPr>
@@ -9086,7 +9086,7 @@
         <p:spPr>
           <a:xfrm xmlns:a="http://schemas.openxmlformats.org/drawingml/2006/main">
             <a:off x="7905750" y="1666875"/>
-            <a:ext cx="0" cy="7572375"/>
+            <a:ext cx="0" cy="7953375"/>
           </a:xfrm>
           <a:prstGeom xmlns:a="http://schemas.openxmlformats.org/drawingml/2006/main" prst="straightConnector1">
             <a:avLst/>
@@ -9103,7 +9103,7 @@
           <p:cNvPr id="21" name="">
             <a:extLst xmlns:a="http://schemas.openxmlformats.org/drawingml/2006/main">
               <a:ext uri="{FF2B5EF4-FFF2-40B4-BE49-F238E27FC236}">
-                <a16:creationId xmlns:a16="http://schemas.microsoft.com/office/drawing/2014/main" id="{7EDEE3A2-CD99-4427-A51A-DB488EBD92D6}"/>
+                <a16:creationId xmlns:a16="http://schemas.microsoft.com/office/drawing/2014/main" id="{F8B2FF68-7CDA-40CF-8649-DD73122CD8DD}"/>
               </a:ext>
             </a:extLst>
           </p:cNvPr>
@@ -9135,7 +9135,7 @@
           <p:cNvPr id="22" name="">
             <a:extLst xmlns:a="http://schemas.openxmlformats.org/drawingml/2006/main">
               <a:ext uri="{FF2B5EF4-FFF2-40B4-BE49-F238E27FC236}">
-                <a16:creationId xmlns:a16="http://schemas.microsoft.com/office/drawing/2014/main" id="{DB7A644F-195E-4180-8C24-D02092CBE1F5}"/>
+                <a16:creationId xmlns:a16="http://schemas.microsoft.com/office/drawing/2014/main" id="{77BA7EBA-28C7-4E9D-9130-57993A6DE881}"/>
               </a:ext>
             </a:extLst>
           </p:cNvPr>
@@ -9314,7 +9314,7 @@
           <p:cNvPr id="23" name="">
             <a:extLst xmlns:a="http://schemas.openxmlformats.org/drawingml/2006/main">
               <a:ext uri="{FF2B5EF4-FFF2-40B4-BE49-F238E27FC236}">
-                <a16:creationId xmlns:a16="http://schemas.microsoft.com/office/drawing/2014/main" id="{CC2E7814-0637-4FC1-A2AF-9D7BF46BFC68}"/>
+                <a16:creationId xmlns:a16="http://schemas.microsoft.com/office/drawing/2014/main" id="{FD6FD442-0AE0-46F7-8EDC-F4E0299F5269}"/>
               </a:ext>
             </a:extLst>
           </p:cNvPr>
@@ -9324,7 +9324,7 @@
         <p:spPr>
           <a:xfrm xmlns:a="http://schemas.openxmlformats.org/drawingml/2006/main">
             <a:off x="9334500" y="1666875"/>
-            <a:ext cx="0" cy="7572375"/>
+            <a:ext cx="0" cy="7953375"/>
           </a:xfrm>
           <a:prstGeom xmlns:a="http://schemas.openxmlformats.org/drawingml/2006/main" prst="straightConnector1">
             <a:avLst/>
@@ -9341,7 +9341,7 @@
           <p:cNvPr id="24" name="">
             <a:extLst xmlns:a="http://schemas.openxmlformats.org/drawingml/2006/main">
               <a:ext uri="{FF2B5EF4-FFF2-40B4-BE49-F238E27FC236}">
-                <a16:creationId xmlns:a16="http://schemas.microsoft.com/office/drawing/2014/main" id="{0F91C187-2654-4C78-9564-A0EF383BE5B0}"/>
+                <a16:creationId xmlns:a16="http://schemas.microsoft.com/office/drawing/2014/main" id="{024B6908-4D09-46C2-98E8-0F488DF6DA6A}"/>
               </a:ext>
             </a:extLst>
           </p:cNvPr>
@@ -9373,7 +9373,7 @@
           <p:cNvPr id="25" name="">
             <a:extLst xmlns:a="http://schemas.openxmlformats.org/drawingml/2006/main">
               <a:ext uri="{FF2B5EF4-FFF2-40B4-BE49-F238E27FC236}">
-                <a16:creationId xmlns:a16="http://schemas.microsoft.com/office/drawing/2014/main" id="{F105CD49-7753-4FA9-9629-732CA0007513}"/>
+                <a16:creationId xmlns:a16="http://schemas.microsoft.com/office/drawing/2014/main" id="{ABA2EF0F-93FF-4547-898F-3B49637F9E3C}"/>
               </a:ext>
             </a:extLst>
           </p:cNvPr>
@@ -9552,7 +9552,7 @@
           <p:cNvPr id="26" name="">
             <a:extLst xmlns:a="http://schemas.openxmlformats.org/drawingml/2006/main">
               <a:ext uri="{FF2B5EF4-FFF2-40B4-BE49-F238E27FC236}">
-                <a16:creationId xmlns:a16="http://schemas.microsoft.com/office/drawing/2014/main" id="{B9196B31-53A1-4701-9086-886F7D4263B4}"/>
+                <a16:creationId xmlns:a16="http://schemas.microsoft.com/office/drawing/2014/main" id="{566DC912-38F4-49BF-B1AD-88A6F0F0DC19}"/>
               </a:ext>
             </a:extLst>
           </p:cNvPr>
@@ -9562,7 +9562,7 @@
         <p:spPr>
           <a:xfrm xmlns:a="http://schemas.openxmlformats.org/drawingml/2006/main">
             <a:off x="10763250" y="1666875"/>
-            <a:ext cx="0" cy="7572375"/>
+            <a:ext cx="0" cy="7953375"/>
           </a:xfrm>
           <a:prstGeom xmlns:a="http://schemas.openxmlformats.org/drawingml/2006/main" prst="straightConnector1">
             <a:avLst/>
@@ -9579,7 +9579,7 @@
           <p:cNvPr id="27" name="">
             <a:extLst xmlns:a="http://schemas.openxmlformats.org/drawingml/2006/main">
               <a:ext uri="{FF2B5EF4-FFF2-40B4-BE49-F238E27FC236}">
-                <a16:creationId xmlns:a16="http://schemas.microsoft.com/office/drawing/2014/main" id="{EBB9F06A-8609-4F96-8A3C-1C4558E8F9CF}"/>
+                <a16:creationId xmlns:a16="http://schemas.microsoft.com/office/drawing/2014/main" id="{15C8CFC0-D2B9-470E-A3DA-1E271A22308F}"/>
               </a:ext>
             </a:extLst>
           </p:cNvPr>
@@ -9611,7 +9611,7 @@
           <p:cNvPr id="28" name="">
             <a:extLst xmlns:a="http://schemas.openxmlformats.org/drawingml/2006/main">
               <a:ext uri="{FF2B5EF4-FFF2-40B4-BE49-F238E27FC236}">
-                <a16:creationId xmlns:a16="http://schemas.microsoft.com/office/drawing/2014/main" id="{854FBBF4-CF80-47B1-869E-614A937ED2FF}"/>
+                <a16:creationId xmlns:a16="http://schemas.microsoft.com/office/drawing/2014/main" id="{728242CC-CE8D-45F2-AAA7-C25743BA5F03}"/>
               </a:ext>
             </a:extLst>
           </p:cNvPr>
@@ -9790,7 +9790,7 @@
           <p:cNvPr id="29" name="">
             <a:extLst xmlns:a="http://schemas.openxmlformats.org/drawingml/2006/main">
               <a:ext uri="{FF2B5EF4-FFF2-40B4-BE49-F238E27FC236}">
-                <a16:creationId xmlns:a16="http://schemas.microsoft.com/office/drawing/2014/main" id="{DA2D8E14-0532-4E11-88E2-EED11689E12E}"/>
+                <a16:creationId xmlns:a16="http://schemas.microsoft.com/office/drawing/2014/main" id="{F4AF79BD-65B0-4989-BD67-C6BF6875E983}"/>
               </a:ext>
             </a:extLst>
           </p:cNvPr>
@@ -9800,7 +9800,7 @@
         <p:spPr>
           <a:xfrm xmlns:a="http://schemas.openxmlformats.org/drawingml/2006/main">
             <a:off x="12382500" y="1666875"/>
-            <a:ext cx="0" cy="7572375"/>
+            <a:ext cx="0" cy="7953375"/>
           </a:xfrm>
           <a:prstGeom xmlns:a="http://schemas.openxmlformats.org/drawingml/2006/main" prst="straightConnector1">
             <a:avLst/>
@@ -9812,40 +9812,12 @@
           </a:ln>
         </p:spPr>
       </p:cxnSp>
-      <p:cxnSp>
-        <p:nvCxnSpPr>
+      <p:sp>
+        <p:nvSpPr>
           <p:cNvPr id="30" name="">
             <a:extLst xmlns:a="http://schemas.openxmlformats.org/drawingml/2006/main">
               <a:ext uri="{FF2B5EF4-FFF2-40B4-BE49-F238E27FC236}">
-                <a16:creationId xmlns:a16="http://schemas.microsoft.com/office/drawing/2014/main" id="{1676BC98-6490-4DC6-80C6-7F6C081A07AF}"/>
-              </a:ext>
-            </a:extLst>
-          </p:cNvPr>
-          <p:cNvCxnSpPr/>
-          <p:nvPr/>
-        </p:nvCxnSpPr>
-        <p:spPr>
-          <a:xfrm xmlns:a="http://schemas.openxmlformats.org/drawingml/2006/main">
-            <a:off x="762000" y="2047875"/>
-            <a:ext cx="1428750" cy="0"/>
-          </a:xfrm>
-          <a:prstGeom xmlns:a="http://schemas.openxmlformats.org/drawingml/2006/main" prst="straightConnector1">
-            <a:avLst/>
-          </a:prstGeom>
-          <a:ln xmlns:a="http://schemas.openxmlformats.org/drawingml/2006/main" w="23813">
-            <a:solidFill>
-              <a:srgbClr val="1259A7"/>
-            </a:solidFill>
-            <a:tailEnd type="triangle" w="sm" len="sm"/>
-          </a:ln>
-        </p:spPr>
-      </p:cxnSp>
-      <p:sp>
-        <p:nvSpPr>
-          <p:cNvPr id="31" name="">
-            <a:extLst xmlns:a="http://schemas.openxmlformats.org/drawingml/2006/main">
-              <a:ext uri="{FF2B5EF4-FFF2-40B4-BE49-F238E27FC236}">
-                <a16:creationId xmlns:a16="http://schemas.microsoft.com/office/drawing/2014/main" id="{46D87081-FE92-4133-9FC8-A39AF4FD5F1C}"/>
+                <a16:creationId xmlns:a16="http://schemas.microsoft.com/office/drawing/2014/main" id="{5EF4535A-A439-4DD7-8C78-0B14B147823B}"/>
               </a:ext>
             </a:extLst>
           </p:cNvPr>
@@ -9856,15 +9828,45 @@
         </p:nvSpPr>
         <p:spPr>
           <a:xfrm xmlns:a="http://schemas.openxmlformats.org/drawingml/2006/main">
-            <a:off x="838200" y="1790700"/>
-            <a:ext cx="4000500" cy="247650"/>
+            <a:off x="13096875" y="1047750"/>
+            <a:ext cx="1047750" cy="619125"/>
           </a:xfrm>
           <a:prstGeom xmlns:a="http://schemas.openxmlformats.org/drawingml/2006/main" prst="rect">
             <a:avLst/>
           </a:prstGeom>
           <a:solidFill xmlns:a="http://schemas.openxmlformats.org/drawingml/2006/main">
-            <a:srgbClr val="FFFFFF"/>
+            <a:srgbClr val="EDF3F8"/>
           </a:solidFill>
+          <a:ln xmlns:a="http://schemas.openxmlformats.org/drawingml/2006/main" w="9525">
+            <a:solidFill>
+              <a:srgbClr val="8394A4"/>
+            </a:solidFill>
+          </a:ln>
+        </p:spPr>
+      </p:sp>
+      <p:sp>
+        <p:nvSpPr>
+          <p:cNvPr id="31" name="">
+            <a:extLst xmlns:a="http://schemas.openxmlformats.org/drawingml/2006/main">
+              <a:ext uri="{FF2B5EF4-FFF2-40B4-BE49-F238E27FC236}">
+                <a16:creationId xmlns:a16="http://schemas.microsoft.com/office/drawing/2014/main" id="{356D4DFC-72A2-4D39-8697-1117EBC0C40C}"/>
+              </a:ext>
+            </a:extLst>
+          </p:cNvPr>
+          <p:cNvSpPr>
+            <a:spLocks xmlns:a="http://schemas.openxmlformats.org/drawingml/2006/main" noGrp="1"/>
+          </p:cNvSpPr>
+          <p:nvPr/>
+        </p:nvSpPr>
+        <p:spPr>
+          <a:xfrm xmlns:a="http://schemas.openxmlformats.org/drawingml/2006/main">
+            <a:off x="13134975" y="1114425"/>
+            <a:ext cx="971550" cy="495300"/>
+          </a:xfrm>
+          <a:prstGeom xmlns:a="http://schemas.openxmlformats.org/drawingml/2006/main" prst="rect">
+            <a:avLst/>
+          </a:prstGeom>
+          <a:noFill xmlns:a="http://schemas.openxmlformats.org/drawingml/2006/main"/>
           <a:ln xmlns:a="http://schemas.openxmlformats.org/drawingml/2006/main" w="0">
             <a:noFill/>
           </a:ln>
@@ -9873,9 +9875,9 @@
           <a:bodyPr xmlns:a="http://schemas.openxmlformats.org/drawingml/2006/main" lIns="0" tIns="0" rIns="0" bIns="0"/>
           <a:lstStyle xmlns:a="http://schemas.openxmlformats.org/drawingml/2006/main">
             <a:defPPr>
-              <a:defRPr sz="1200" b="1">
-                <a:solidFill>
-                  <a:srgbClr val="1259A7"/>
+              <a:defRPr sz="1125" b="1">
+                <a:solidFill>
+                  <a:srgbClr val="16212C"/>
                 </a:solidFill>
                 <a:latin typeface="Arial"/>
                 <a:ea typeface="Arial"/>
@@ -9883,9 +9885,9 @@
               </a:defRPr>
             </a:defPPr>
             <a:lvl1pPr>
-              <a:defRPr sz="1200" b="1">
-                <a:solidFill>
-                  <a:srgbClr val="1259A7"/>
+              <a:defRPr sz="1125" b="1">
+                <a:solidFill>
+                  <a:srgbClr val="16212C"/>
                 </a:solidFill>
                 <a:latin typeface="Arial"/>
                 <a:ea typeface="Arial"/>
@@ -9893,9 +9895,9 @@
               </a:defRPr>
             </a:lvl1pPr>
             <a:lvl2pPr>
-              <a:defRPr sz="1200" b="1">
-                <a:solidFill>
-                  <a:srgbClr val="1259A7"/>
+              <a:defRPr sz="1125" b="1">
+                <a:solidFill>
+                  <a:srgbClr val="16212C"/>
                 </a:solidFill>
                 <a:latin typeface="Arial"/>
                 <a:ea typeface="Arial"/>
@@ -9903,9 +9905,9 @@
               </a:defRPr>
             </a:lvl2pPr>
             <a:lvl3pPr>
-              <a:defRPr sz="1200" b="1">
-                <a:solidFill>
-                  <a:srgbClr val="1259A7"/>
+              <a:defRPr sz="1125" b="1">
+                <a:solidFill>
+                  <a:srgbClr val="16212C"/>
                 </a:solidFill>
                 <a:latin typeface="Arial"/>
                 <a:ea typeface="Arial"/>
@@ -9913,9 +9915,9 @@
               </a:defRPr>
             </a:lvl3pPr>
             <a:lvl4pPr>
-              <a:defRPr sz="1200" b="1">
-                <a:solidFill>
-                  <a:srgbClr val="1259A7"/>
+              <a:defRPr sz="1125" b="1">
+                <a:solidFill>
+                  <a:srgbClr val="16212C"/>
                 </a:solidFill>
                 <a:latin typeface="Arial"/>
                 <a:ea typeface="Arial"/>
@@ -9923,9 +9925,9 @@
               </a:defRPr>
             </a:lvl4pPr>
             <a:lvl5pPr>
-              <a:defRPr sz="1200" b="1">
-                <a:solidFill>
-                  <a:srgbClr val="1259A7"/>
+              <a:defRPr sz="1125" b="1">
+                <a:solidFill>
+                  <a:srgbClr val="16212C"/>
                 </a:solidFill>
                 <a:latin typeface="Arial"/>
                 <a:ea typeface="Arial"/>
@@ -9933,9 +9935,9 @@
               </a:defRPr>
             </a:lvl5pPr>
             <a:lvl6pPr>
-              <a:defRPr sz="1200" b="1">
-                <a:solidFill>
-                  <a:srgbClr val="1259A7"/>
+              <a:defRPr sz="1125" b="1">
+                <a:solidFill>
+                  <a:srgbClr val="16212C"/>
                 </a:solidFill>
                 <a:latin typeface="Arial"/>
                 <a:ea typeface="Arial"/>
@@ -9943,9 +9945,9 @@
               </a:defRPr>
             </a:lvl6pPr>
             <a:lvl7pPr>
-              <a:defRPr sz="1200" b="1">
-                <a:solidFill>
-                  <a:srgbClr val="1259A7"/>
+              <a:defRPr sz="1125" b="1">
+                <a:solidFill>
+                  <a:srgbClr val="16212C"/>
                 </a:solidFill>
                 <a:latin typeface="Arial"/>
                 <a:ea typeface="Arial"/>
@@ -9953,9 +9955,9 @@
               </a:defRPr>
             </a:lvl7pPr>
             <a:lvl8pPr>
-              <a:defRPr sz="1200" b="1">
-                <a:solidFill>
-                  <a:srgbClr val="1259A7"/>
+              <a:defRPr sz="1125" b="1">
+                <a:solidFill>
+                  <a:srgbClr val="16212C"/>
                 </a:solidFill>
                 <a:latin typeface="Arial"/>
                 <a:ea typeface="Arial"/>
@@ -9963,9 +9965,9 @@
               </a:defRPr>
             </a:lvl8pPr>
             <a:lvl9pPr>
-              <a:defRPr sz="1200" b="1">
-                <a:solidFill>
-                  <a:srgbClr val="1259A7"/>
+              <a:defRPr sz="1125" b="1">
+                <a:solidFill>
+                  <a:srgbClr val="16212C"/>
                 </a:solidFill>
                 <a:latin typeface="Arial"/>
                 <a:ea typeface="Arial"/>
@@ -9975,9 +9977,9 @@
           </a:lstStyle>
           <a:p xmlns:a="http://schemas.openxmlformats.org/drawingml/2006/main">
             <a:pPr>
-              <a:defRPr sz="1200" b="1">
-                <a:solidFill>
-                  <a:srgbClr val="1259A7"/>
+              <a:defRPr sz="1125" b="1">
+                <a:solidFill>
+                  <a:srgbClr val="16212C"/>
                 </a:solidFill>
                 <a:latin typeface="Arial"/>
                 <a:ea typeface="Arial"/>
@@ -9985,15 +9987,38 @@
               </a:defRPr>
             </a:pPr>
             <a:r>
-              <a:rPr sz="1200" b="1">
-                <a:solidFill>
-                  <a:srgbClr val="1259A7"/>
+              <a:rPr sz="1125" b="1">
+                <a:solidFill>
+                  <a:srgbClr val="16212C"/>
                 </a:solidFill>
                 <a:latin typeface="Arial"/>
                 <a:ea typeface="Arial"/>
                 <a:cs typeface="Arial"/>
               </a:rPr>
-              <a:t>1  Stock pair and date</a:t>
+              <a:t>System</a:t>
+            </a:r>
+          </a:p>
+          <a:p xmlns:a="http://schemas.openxmlformats.org/drawingml/2006/main">
+            <a:pPr>
+              <a:defRPr sz="1125" b="1">
+                <a:solidFill>
+                  <a:srgbClr val="16212C"/>
+                </a:solidFill>
+                <a:latin typeface="Arial"/>
+                <a:ea typeface="Arial"/>
+                <a:cs typeface="Arial"/>
+              </a:defRPr>
+            </a:pPr>
+            <a:r>
+              <a:rPr sz="1125" b="1">
+                <a:solidFill>
+                  <a:srgbClr val="16212C"/>
+                </a:solidFill>
+                <a:latin typeface="Arial"/>
+                <a:ea typeface="Arial"/>
+                <a:cs typeface="Arial"/>
+              </a:rPr>
+              <a:t>Maintainer</a:t>
             </a:r>
           </a:p>
         </p:txBody>
@@ -10003,7 +10028,7 @@
           <p:cNvPr id="32" name="">
             <a:extLst xmlns:a="http://schemas.openxmlformats.org/drawingml/2006/main">
               <a:ext uri="{FF2B5EF4-FFF2-40B4-BE49-F238E27FC236}">
-                <a16:creationId xmlns:a16="http://schemas.microsoft.com/office/drawing/2014/main" id="{AC9305BD-9100-4CDE-A4D9-B6C0DC2C40A3}"/>
+                <a16:creationId xmlns:a16="http://schemas.microsoft.com/office/drawing/2014/main" id="{CD8AF54C-F7DF-490F-9F73-F637FC478B07}"/>
               </a:ext>
             </a:extLst>
           </p:cNvPr>
@@ -10012,26 +10037,192 @@
         </p:nvCxnSpPr>
         <p:spPr>
           <a:xfrm xmlns:a="http://schemas.openxmlformats.org/drawingml/2006/main">
-            <a:off x="2190750" y="2571750"/>
-            <a:ext cx="1428750" cy="0"/>
+            <a:off x="13620750" y="1666875"/>
+            <a:ext cx="0" cy="7953375"/>
           </a:xfrm>
           <a:prstGeom xmlns:a="http://schemas.openxmlformats.org/drawingml/2006/main" prst="straightConnector1">
             <a:avLst/>
           </a:prstGeom>
+          <a:ln xmlns:a="http://schemas.openxmlformats.org/drawingml/2006/main" w="9525">
+            <a:solidFill>
+              <a:srgbClr val="CDD4DC"/>
+            </a:solidFill>
+          </a:ln>
+        </p:spPr>
+      </p:cxnSp>
+      <p:cxnSp>
+        <p:nvCxnSpPr>
+          <p:cNvPr id="33" name="">
+            <a:extLst xmlns:a="http://schemas.openxmlformats.org/drawingml/2006/main">
+              <a:ext uri="{FF2B5EF4-FFF2-40B4-BE49-F238E27FC236}">
+                <a16:creationId xmlns:a16="http://schemas.microsoft.com/office/drawing/2014/main" id="{778F42F7-4E0F-4146-853B-F7CCBC11E467}"/>
+              </a:ext>
+            </a:extLst>
+          </p:cNvPr>
+          <p:cNvCxnSpPr/>
+          <p:nvPr/>
+        </p:nvCxnSpPr>
+        <p:spPr>
+          <a:xfrm xmlns:a="http://schemas.openxmlformats.org/drawingml/2006/main">
+            <a:off x="2190750" y="2095500"/>
+            <a:ext cx="11430000" cy="0"/>
+          </a:xfrm>
+          <a:prstGeom xmlns:a="http://schemas.openxmlformats.org/drawingml/2006/main" prst="straightConnector1">
+            <a:avLst/>
+          </a:prstGeom>
           <a:ln xmlns:a="http://schemas.openxmlformats.org/drawingml/2006/main" w="23813">
             <a:solidFill>
-              <a:srgbClr val="087A63"/>
+              <a:srgbClr val="586471"/>
+            </a:solidFill>
+          </a:ln>
+        </p:spPr>
+      </p:cxnSp>
+      <p:cxnSp>
+        <p:nvCxnSpPr>
+          <p:cNvPr id="34" name="">
+            <a:extLst xmlns:a="http://schemas.openxmlformats.org/drawingml/2006/main">
+              <a:ext uri="{FF2B5EF4-FFF2-40B4-BE49-F238E27FC236}">
+                <a16:creationId xmlns:a16="http://schemas.microsoft.com/office/drawing/2014/main" id="{9BACD7AA-41AD-45A1-9424-084AEA05B1A9}"/>
+              </a:ext>
+            </a:extLst>
+          </p:cNvPr>
+          <p:cNvCxnSpPr/>
+          <p:nvPr/>
+        </p:nvCxnSpPr>
+        <p:spPr>
+          <a:xfrm xmlns:a="http://schemas.openxmlformats.org/drawingml/2006/main">
+            <a:off x="2190750" y="2095500"/>
+            <a:ext cx="0" cy="190500"/>
+          </a:xfrm>
+          <a:prstGeom xmlns:a="http://schemas.openxmlformats.org/drawingml/2006/main" prst="straightConnector1">
+            <a:avLst/>
+          </a:prstGeom>
+          <a:ln xmlns:a="http://schemas.openxmlformats.org/drawingml/2006/main" w="23813">
+            <a:solidFill>
+              <a:srgbClr val="586471"/>
             </a:solidFill>
             <a:tailEnd type="triangle" w="sm" len="sm"/>
           </a:ln>
         </p:spPr>
       </p:cxnSp>
+      <p:cxnSp>
+        <p:nvCxnSpPr>
+          <p:cNvPr id="35" name="">
+            <a:extLst xmlns:a="http://schemas.openxmlformats.org/drawingml/2006/main">
+              <a:ext uri="{FF2B5EF4-FFF2-40B4-BE49-F238E27FC236}">
+                <a16:creationId xmlns:a16="http://schemas.microsoft.com/office/drawing/2014/main" id="{6CBE6EDB-99A2-4CB9-A7A6-46851B44BC9C}"/>
+              </a:ext>
+            </a:extLst>
+          </p:cNvPr>
+          <p:cNvCxnSpPr/>
+          <p:nvPr/>
+        </p:nvCxnSpPr>
+        <p:spPr>
+          <a:xfrm xmlns:a="http://schemas.openxmlformats.org/drawingml/2006/main">
+            <a:off x="3619500" y="2095500"/>
+            <a:ext cx="0" cy="190500"/>
+          </a:xfrm>
+          <a:prstGeom xmlns:a="http://schemas.openxmlformats.org/drawingml/2006/main" prst="straightConnector1">
+            <a:avLst/>
+          </a:prstGeom>
+          <a:ln xmlns:a="http://schemas.openxmlformats.org/drawingml/2006/main" w="23813">
+            <a:solidFill>
+              <a:srgbClr val="586471"/>
+            </a:solidFill>
+            <a:tailEnd type="triangle" w="sm" len="sm"/>
+          </a:ln>
+        </p:spPr>
+      </p:cxnSp>
+      <p:cxnSp>
+        <p:nvCxnSpPr>
+          <p:cNvPr id="36" name="">
+            <a:extLst xmlns:a="http://schemas.openxmlformats.org/drawingml/2006/main">
+              <a:ext uri="{FF2B5EF4-FFF2-40B4-BE49-F238E27FC236}">
+                <a16:creationId xmlns:a16="http://schemas.microsoft.com/office/drawing/2014/main" id="{44140E41-94D2-4089-8787-EA2EDCC9D5F8}"/>
+              </a:ext>
+            </a:extLst>
+          </p:cNvPr>
+          <p:cNvCxnSpPr/>
+          <p:nvPr/>
+        </p:nvCxnSpPr>
+        <p:spPr>
+          <a:xfrm xmlns:a="http://schemas.openxmlformats.org/drawingml/2006/main">
+            <a:off x="7905750" y="2095500"/>
+            <a:ext cx="0" cy="190500"/>
+          </a:xfrm>
+          <a:prstGeom xmlns:a="http://schemas.openxmlformats.org/drawingml/2006/main" prst="straightConnector1">
+            <a:avLst/>
+          </a:prstGeom>
+          <a:ln xmlns:a="http://schemas.openxmlformats.org/drawingml/2006/main" w="23813">
+            <a:solidFill>
+              <a:srgbClr val="586471"/>
+            </a:solidFill>
+            <a:tailEnd type="triangle" w="sm" len="sm"/>
+          </a:ln>
+        </p:spPr>
+      </p:cxnSp>
+      <p:cxnSp>
+        <p:nvCxnSpPr>
+          <p:cNvPr id="37" name="">
+            <a:extLst xmlns:a="http://schemas.openxmlformats.org/drawingml/2006/main">
+              <a:ext uri="{FF2B5EF4-FFF2-40B4-BE49-F238E27FC236}">
+                <a16:creationId xmlns:a16="http://schemas.microsoft.com/office/drawing/2014/main" id="{FA44FD88-EEC9-45B3-BDD3-90866302BFD9}"/>
+              </a:ext>
+            </a:extLst>
+          </p:cNvPr>
+          <p:cNvCxnSpPr/>
+          <p:nvPr/>
+        </p:nvCxnSpPr>
+        <p:spPr>
+          <a:xfrm xmlns:a="http://schemas.openxmlformats.org/drawingml/2006/main">
+            <a:off x="9334500" y="2095500"/>
+            <a:ext cx="0" cy="190500"/>
+          </a:xfrm>
+          <a:prstGeom xmlns:a="http://schemas.openxmlformats.org/drawingml/2006/main" prst="straightConnector1">
+            <a:avLst/>
+          </a:prstGeom>
+          <a:ln xmlns:a="http://schemas.openxmlformats.org/drawingml/2006/main" w="23813">
+            <a:solidFill>
+              <a:srgbClr val="586471"/>
+            </a:solidFill>
+            <a:tailEnd type="triangle" w="sm" len="sm"/>
+          </a:ln>
+        </p:spPr>
+      </p:cxnSp>
+      <p:cxnSp>
+        <p:nvCxnSpPr>
+          <p:cNvPr id="38" name="">
+            <a:extLst xmlns:a="http://schemas.openxmlformats.org/drawingml/2006/main">
+              <a:ext uri="{FF2B5EF4-FFF2-40B4-BE49-F238E27FC236}">
+                <a16:creationId xmlns:a16="http://schemas.microsoft.com/office/drawing/2014/main" id="{E7AEDCD7-23EF-4503-9D0A-4142B9E4DB2C}"/>
+              </a:ext>
+            </a:extLst>
+          </p:cNvPr>
+          <p:cNvCxnSpPr/>
+          <p:nvPr/>
+        </p:nvCxnSpPr>
+        <p:spPr>
+          <a:xfrm xmlns:a="http://schemas.openxmlformats.org/drawingml/2006/main">
+            <a:off x="12382500" y="2095500"/>
+            <a:ext cx="0" cy="190500"/>
+          </a:xfrm>
+          <a:prstGeom xmlns:a="http://schemas.openxmlformats.org/drawingml/2006/main" prst="straightConnector1">
+            <a:avLst/>
+          </a:prstGeom>
+          <a:ln xmlns:a="http://schemas.openxmlformats.org/drawingml/2006/main" w="23813">
+            <a:solidFill>
+              <a:srgbClr val="586471"/>
+            </a:solidFill>
+            <a:tailEnd type="triangle" w="sm" len="sm"/>
+          </a:ln>
+        </p:spPr>
+      </p:cxnSp>
       <p:sp>
         <p:nvSpPr>
-          <p:cNvPr id="33" name="">
+          <p:cNvPr id="39" name="">
             <a:extLst xmlns:a="http://schemas.openxmlformats.org/drawingml/2006/main">
               <a:ext uri="{FF2B5EF4-FFF2-40B4-BE49-F238E27FC236}">
-                <a16:creationId xmlns:a16="http://schemas.microsoft.com/office/drawing/2014/main" id="{150AA53A-A743-406A-BCAA-4F0BC9271795}"/>
+                <a16:creationId xmlns:a16="http://schemas.microsoft.com/office/drawing/2014/main" id="{2729E207-EEA8-451E-96CD-850836C8D8BA}"/>
               </a:ext>
             </a:extLst>
           </p:cNvPr>
@@ -10042,8 +10233,8 @@
         </p:nvSpPr>
         <p:spPr>
           <a:xfrm xmlns:a="http://schemas.openxmlformats.org/drawingml/2006/main">
-            <a:off x="2266950" y="2314575"/>
-            <a:ext cx="4000500" cy="247650"/>
+            <a:off x="2286000" y="1781175"/>
+            <a:ext cx="10668000" cy="266700"/>
           </a:xfrm>
           <a:prstGeom xmlns:a="http://schemas.openxmlformats.org/drawingml/2006/main" prst="rect">
             <a:avLst/>
@@ -10059,9 +10250,9 @@
           <a:bodyPr xmlns:a="http://schemas.openxmlformats.org/drawingml/2006/main" lIns="0" tIns="0" rIns="0" bIns="0"/>
           <a:lstStyle xmlns:a="http://schemas.openxmlformats.org/drawingml/2006/main">
             <a:defPPr>
-              <a:defRPr sz="1200" b="1">
-                <a:solidFill>
-                  <a:srgbClr val="087A63"/>
+              <a:defRPr sz="1275" b="1">
+                <a:solidFill>
+                  <a:srgbClr val="586471"/>
                 </a:solidFill>
                 <a:latin typeface="Arial"/>
                 <a:ea typeface="Arial"/>
@@ -10069,9 +10260,9 @@
               </a:defRPr>
             </a:defPPr>
             <a:lvl1pPr>
-              <a:defRPr sz="1200" b="1">
-                <a:solidFill>
-                  <a:srgbClr val="087A63"/>
+              <a:defRPr sz="1275" b="1">
+                <a:solidFill>
+                  <a:srgbClr val="586471"/>
                 </a:solidFill>
                 <a:latin typeface="Arial"/>
                 <a:ea typeface="Arial"/>
@@ -10079,9 +10270,9 @@
               </a:defRPr>
             </a:lvl1pPr>
             <a:lvl2pPr>
-              <a:defRPr sz="1200" b="1">
-                <a:solidFill>
-                  <a:srgbClr val="087A63"/>
+              <a:defRPr sz="1275" b="1">
+                <a:solidFill>
+                  <a:srgbClr val="586471"/>
                 </a:solidFill>
                 <a:latin typeface="Arial"/>
                 <a:ea typeface="Arial"/>
@@ -10089,9 +10280,9 @@
               </a:defRPr>
             </a:lvl2pPr>
             <a:lvl3pPr>
-              <a:defRPr sz="1200" b="1">
-                <a:solidFill>
-                  <a:srgbClr val="087A63"/>
+              <a:defRPr sz="1275" b="1">
+                <a:solidFill>
+                  <a:srgbClr val="586471"/>
                 </a:solidFill>
                 <a:latin typeface="Arial"/>
                 <a:ea typeface="Arial"/>
@@ -10099,9 +10290,9 @@
               </a:defRPr>
             </a:lvl3pPr>
             <a:lvl4pPr>
-              <a:defRPr sz="1200" b="1">
-                <a:solidFill>
-                  <a:srgbClr val="087A63"/>
+              <a:defRPr sz="1275" b="1">
+                <a:solidFill>
+                  <a:srgbClr val="586471"/>
                 </a:solidFill>
                 <a:latin typeface="Arial"/>
                 <a:ea typeface="Arial"/>
@@ -10109,9 +10300,9 @@
               </a:defRPr>
             </a:lvl4pPr>
             <a:lvl5pPr>
-              <a:defRPr sz="1200" b="1">
-                <a:solidFill>
-                  <a:srgbClr val="087A63"/>
+              <a:defRPr sz="1275" b="1">
+                <a:solidFill>
+                  <a:srgbClr val="586471"/>
                 </a:solidFill>
                 <a:latin typeface="Arial"/>
                 <a:ea typeface="Arial"/>
@@ -10119,9 +10310,9 @@
               </a:defRPr>
             </a:lvl5pPr>
             <a:lvl6pPr>
-              <a:defRPr sz="1200" b="1">
-                <a:solidFill>
-                  <a:srgbClr val="087A63"/>
+              <a:defRPr sz="1275" b="1">
+                <a:solidFill>
+                  <a:srgbClr val="586471"/>
                 </a:solidFill>
                 <a:latin typeface="Arial"/>
                 <a:ea typeface="Arial"/>
@@ -10129,9 +10320,9 @@
               </a:defRPr>
             </a:lvl6pPr>
             <a:lvl7pPr>
-              <a:defRPr sz="1200" b="1">
-                <a:solidFill>
-                  <a:srgbClr val="087A63"/>
+              <a:defRPr sz="1275" b="1">
+                <a:solidFill>
+                  <a:srgbClr val="586471"/>
                 </a:solidFill>
                 <a:latin typeface="Arial"/>
                 <a:ea typeface="Arial"/>
@@ -10139,9 +10330,9 @@
               </a:defRPr>
             </a:lvl7pPr>
             <a:lvl8pPr>
-              <a:defRPr sz="1200" b="1">
-                <a:solidFill>
-                  <a:srgbClr val="087A63"/>
+              <a:defRPr sz="1275" b="1">
+                <a:solidFill>
+                  <a:srgbClr val="586471"/>
                 </a:solidFill>
                 <a:latin typeface="Arial"/>
                 <a:ea typeface="Arial"/>
@@ -10149,9 +10340,9 @@
               </a:defRPr>
             </a:lvl8pPr>
             <a:lvl9pPr>
-              <a:defRPr sz="1200" b="1">
-                <a:solidFill>
-                  <a:srgbClr val="087A63"/>
+              <a:defRPr sz="1275" b="1">
+                <a:solidFill>
+                  <a:srgbClr val="586471"/>
                 </a:solidFill>
                 <a:latin typeface="Arial"/>
                 <a:ea typeface="Arial"/>
@@ -10161,9 +10352,9 @@
           </a:lstStyle>
           <a:p xmlns:a="http://schemas.openxmlformats.org/drawingml/2006/main">
             <a:pPr>
-              <a:defRPr sz="1200" b="1">
-                <a:solidFill>
-                  <a:srgbClr val="087A63"/>
+              <a:defRPr sz="1275" b="1">
+                <a:solidFill>
+                  <a:srgbClr val="586471"/>
                 </a:solidFill>
                 <a:latin typeface="Arial"/>
                 <a:ea typeface="Arial"/>
@@ -10171,573 +10362,15 @@
               </a:defRPr>
             </a:pPr>
             <a:r>
-              <a:rPr sz="1200" b="1">
-                <a:solidFill>
-                  <a:srgbClr val="087A63"/>
+              <a:rPr sz="1275" b="1">
+                <a:solidFill>
+                  <a:srgbClr val="586471"/>
                 </a:solidFill>
                 <a:latin typeface="Arial"/>
                 <a:ea typeface="Arial"/>
                 <a:cs typeface="Arial"/>
               </a:rPr>
-              <a:t>1.1  IF.01 validated request</a:t>
-            </a:r>
-          </a:p>
-        </p:txBody>
-      </p:sp>
-      <p:cxnSp>
-        <p:nvCxnSpPr>
-          <p:cNvPr id="34" name="">
-            <a:extLst xmlns:a="http://schemas.openxmlformats.org/drawingml/2006/main">
-              <a:ext uri="{FF2B5EF4-FFF2-40B4-BE49-F238E27FC236}">
-                <a16:creationId xmlns:a16="http://schemas.microsoft.com/office/drawing/2014/main" id="{B5CF05AC-2B94-4725-B530-45B760BF36C4}"/>
-              </a:ext>
-            </a:extLst>
-          </p:cNvPr>
-          <p:cNvCxnSpPr/>
-          <p:nvPr/>
-        </p:nvCxnSpPr>
-        <p:spPr>
-          <a:xfrm xmlns:a="http://schemas.openxmlformats.org/drawingml/2006/main">
-            <a:off x="3619500" y="3095625"/>
-            <a:ext cx="1428750" cy="0"/>
-          </a:xfrm>
-          <a:prstGeom xmlns:a="http://schemas.openxmlformats.org/drawingml/2006/main" prst="straightConnector1">
-            <a:avLst/>
-          </a:prstGeom>
-          <a:ln xmlns:a="http://schemas.openxmlformats.org/drawingml/2006/main" w="23813">
-            <a:solidFill>
-              <a:srgbClr val="1259A7"/>
-            </a:solidFill>
-            <a:tailEnd type="triangle" w="sm" len="sm"/>
-          </a:ln>
-        </p:spPr>
-      </p:cxnSp>
-      <p:sp>
-        <p:nvSpPr>
-          <p:cNvPr id="35" name="">
-            <a:extLst xmlns:a="http://schemas.openxmlformats.org/drawingml/2006/main">
-              <a:ext uri="{FF2B5EF4-FFF2-40B4-BE49-F238E27FC236}">
-                <a16:creationId xmlns:a16="http://schemas.microsoft.com/office/drawing/2014/main" id="{85412BD6-AABE-4396-A7C9-9DF715EF7583}"/>
-              </a:ext>
-            </a:extLst>
-          </p:cNvPr>
-          <p:cNvSpPr>
-            <a:spLocks xmlns:a="http://schemas.openxmlformats.org/drawingml/2006/main" noGrp="1"/>
-          </p:cNvSpPr>
-          <p:nvPr/>
-        </p:nvSpPr>
-        <p:spPr>
-          <a:xfrm xmlns:a="http://schemas.openxmlformats.org/drawingml/2006/main">
-            <a:off x="3695700" y="2838450"/>
-            <a:ext cx="4000500" cy="247650"/>
-          </a:xfrm>
-          <a:prstGeom xmlns:a="http://schemas.openxmlformats.org/drawingml/2006/main" prst="rect">
-            <a:avLst/>
-          </a:prstGeom>
-          <a:solidFill xmlns:a="http://schemas.openxmlformats.org/drawingml/2006/main">
-            <a:srgbClr val="FFFFFF"/>
-          </a:solidFill>
-          <a:ln xmlns:a="http://schemas.openxmlformats.org/drawingml/2006/main" w="0">
-            <a:noFill/>
-          </a:ln>
-        </p:spPr>
-        <p:txBody>
-          <a:bodyPr xmlns:a="http://schemas.openxmlformats.org/drawingml/2006/main" lIns="0" tIns="0" rIns="0" bIns="0"/>
-          <a:lstStyle xmlns:a="http://schemas.openxmlformats.org/drawingml/2006/main">
-            <a:defPPr>
-              <a:defRPr sz="1200" b="1">
-                <a:solidFill>
-                  <a:srgbClr val="1259A7"/>
-                </a:solidFill>
-                <a:latin typeface="Arial"/>
-                <a:ea typeface="Arial"/>
-                <a:cs typeface="Arial"/>
-              </a:defRPr>
-            </a:defPPr>
-            <a:lvl1pPr>
-              <a:defRPr sz="1200" b="1">
-                <a:solidFill>
-                  <a:srgbClr val="1259A7"/>
-                </a:solidFill>
-                <a:latin typeface="Arial"/>
-                <a:ea typeface="Arial"/>
-                <a:cs typeface="Arial"/>
-              </a:defRPr>
-            </a:lvl1pPr>
-            <a:lvl2pPr>
-              <a:defRPr sz="1200" b="1">
-                <a:solidFill>
-                  <a:srgbClr val="1259A7"/>
-                </a:solidFill>
-                <a:latin typeface="Arial"/>
-                <a:ea typeface="Arial"/>
-                <a:cs typeface="Arial"/>
-              </a:defRPr>
-            </a:lvl2pPr>
-            <a:lvl3pPr>
-              <a:defRPr sz="1200" b="1">
-                <a:solidFill>
-                  <a:srgbClr val="1259A7"/>
-                </a:solidFill>
-                <a:latin typeface="Arial"/>
-                <a:ea typeface="Arial"/>
-                <a:cs typeface="Arial"/>
-              </a:defRPr>
-            </a:lvl3pPr>
-            <a:lvl4pPr>
-              <a:defRPr sz="1200" b="1">
-                <a:solidFill>
-                  <a:srgbClr val="1259A7"/>
-                </a:solidFill>
-                <a:latin typeface="Arial"/>
-                <a:ea typeface="Arial"/>
-                <a:cs typeface="Arial"/>
-              </a:defRPr>
-            </a:lvl4pPr>
-            <a:lvl5pPr>
-              <a:defRPr sz="1200" b="1">
-                <a:solidFill>
-                  <a:srgbClr val="1259A7"/>
-                </a:solidFill>
-                <a:latin typeface="Arial"/>
-                <a:ea typeface="Arial"/>
-                <a:cs typeface="Arial"/>
-              </a:defRPr>
-            </a:lvl5pPr>
-            <a:lvl6pPr>
-              <a:defRPr sz="1200" b="1">
-                <a:solidFill>
-                  <a:srgbClr val="1259A7"/>
-                </a:solidFill>
-                <a:latin typeface="Arial"/>
-                <a:ea typeface="Arial"/>
-                <a:cs typeface="Arial"/>
-              </a:defRPr>
-            </a:lvl6pPr>
-            <a:lvl7pPr>
-              <a:defRPr sz="1200" b="1">
-                <a:solidFill>
-                  <a:srgbClr val="1259A7"/>
-                </a:solidFill>
-                <a:latin typeface="Arial"/>
-                <a:ea typeface="Arial"/>
-                <a:cs typeface="Arial"/>
-              </a:defRPr>
-            </a:lvl7pPr>
-            <a:lvl8pPr>
-              <a:defRPr sz="1200" b="1">
-                <a:solidFill>
-                  <a:srgbClr val="1259A7"/>
-                </a:solidFill>
-                <a:latin typeface="Arial"/>
-                <a:ea typeface="Arial"/>
-                <a:cs typeface="Arial"/>
-              </a:defRPr>
-            </a:lvl8pPr>
-            <a:lvl9pPr>
-              <a:defRPr sz="1200" b="1">
-                <a:solidFill>
-                  <a:srgbClr val="1259A7"/>
-                </a:solidFill>
-                <a:latin typeface="Arial"/>
-                <a:ea typeface="Arial"/>
-                <a:cs typeface="Arial"/>
-              </a:defRPr>
-            </a:lvl9pPr>
-          </a:lstStyle>
-          <a:p xmlns:a="http://schemas.openxmlformats.org/drawingml/2006/main">
-            <a:pPr>
-              <a:defRPr sz="1200" b="1">
-                <a:solidFill>
-                  <a:srgbClr val="1259A7"/>
-                </a:solidFill>
-                <a:latin typeface="Arial"/>
-                <a:ea typeface="Arial"/>
-                <a:cs typeface="Arial"/>
-              </a:defRPr>
-            </a:pPr>
-            <a:r>
-              <a:rPr sz="1200" b="1">
-                <a:solidFill>
-                  <a:srgbClr val="1259A7"/>
-                </a:solidFill>
-                <a:latin typeface="Arial"/>
-                <a:ea typeface="Arial"/>
-                <a:cs typeface="Arial"/>
-              </a:rPr>
-              <a:t>2  IO.04 news query</a:t>
-            </a:r>
-          </a:p>
-        </p:txBody>
-      </p:sp>
-      <p:cxnSp>
-        <p:nvCxnSpPr>
-          <p:cNvPr id="36" name="">
-            <a:extLst xmlns:a="http://schemas.openxmlformats.org/drawingml/2006/main">
-              <a:ext uri="{FF2B5EF4-FFF2-40B4-BE49-F238E27FC236}">
-                <a16:creationId xmlns:a16="http://schemas.microsoft.com/office/drawing/2014/main" id="{0F8C380F-D7A7-45AC-8046-1F142D398AED}"/>
-              </a:ext>
-            </a:extLst>
-          </p:cNvPr>
-          <p:cNvCxnSpPr/>
-          <p:nvPr/>
-        </p:nvCxnSpPr>
-        <p:spPr>
-          <a:xfrm xmlns:a="http://schemas.openxmlformats.org/drawingml/2006/main">
-            <a:off x="3619500" y="3619500"/>
-            <a:ext cx="2857500" cy="0"/>
-          </a:xfrm>
-          <a:prstGeom xmlns:a="http://schemas.openxmlformats.org/drawingml/2006/main" prst="straightConnector1">
-            <a:avLst/>
-          </a:prstGeom>
-          <a:ln xmlns:a="http://schemas.openxmlformats.org/drawingml/2006/main" w="23813">
-            <a:solidFill>
-              <a:srgbClr val="1259A7"/>
-            </a:solidFill>
-            <a:tailEnd type="triangle" w="sm" len="sm"/>
-          </a:ln>
-        </p:spPr>
-      </p:cxnSp>
-      <p:sp>
-        <p:nvSpPr>
-          <p:cNvPr id="37" name="">
-            <a:extLst xmlns:a="http://schemas.openxmlformats.org/drawingml/2006/main">
-              <a:ext uri="{FF2B5EF4-FFF2-40B4-BE49-F238E27FC236}">
-                <a16:creationId xmlns:a16="http://schemas.microsoft.com/office/drawing/2014/main" id="{EB91147A-DEA6-4329-9489-37E304DA984C}"/>
-              </a:ext>
-            </a:extLst>
-          </p:cNvPr>
-          <p:cNvSpPr>
-            <a:spLocks xmlns:a="http://schemas.openxmlformats.org/drawingml/2006/main" noGrp="1"/>
-          </p:cNvSpPr>
-          <p:nvPr/>
-        </p:nvSpPr>
-        <p:spPr>
-          <a:xfrm xmlns:a="http://schemas.openxmlformats.org/drawingml/2006/main">
-            <a:off x="3695700" y="3362325"/>
-            <a:ext cx="4000500" cy="247650"/>
-          </a:xfrm>
-          <a:prstGeom xmlns:a="http://schemas.openxmlformats.org/drawingml/2006/main" prst="rect">
-            <a:avLst/>
-          </a:prstGeom>
-          <a:solidFill xmlns:a="http://schemas.openxmlformats.org/drawingml/2006/main">
-            <a:srgbClr val="FFFFFF"/>
-          </a:solidFill>
-          <a:ln xmlns:a="http://schemas.openxmlformats.org/drawingml/2006/main" w="0">
-            <a:noFill/>
-          </a:ln>
-        </p:spPr>
-        <p:txBody>
-          <a:bodyPr xmlns:a="http://schemas.openxmlformats.org/drawingml/2006/main" lIns="0" tIns="0" rIns="0" bIns="0"/>
-          <a:lstStyle xmlns:a="http://schemas.openxmlformats.org/drawingml/2006/main">
-            <a:defPPr>
-              <a:defRPr sz="1200" b="1">
-                <a:solidFill>
-                  <a:srgbClr val="1259A7"/>
-                </a:solidFill>
-                <a:latin typeface="Arial"/>
-                <a:ea typeface="Arial"/>
-                <a:cs typeface="Arial"/>
-              </a:defRPr>
-            </a:defPPr>
-            <a:lvl1pPr>
-              <a:defRPr sz="1200" b="1">
-                <a:solidFill>
-                  <a:srgbClr val="1259A7"/>
-                </a:solidFill>
-                <a:latin typeface="Arial"/>
-                <a:ea typeface="Arial"/>
-                <a:cs typeface="Arial"/>
-              </a:defRPr>
-            </a:lvl1pPr>
-            <a:lvl2pPr>
-              <a:defRPr sz="1200" b="1">
-                <a:solidFill>
-                  <a:srgbClr val="1259A7"/>
-                </a:solidFill>
-                <a:latin typeface="Arial"/>
-                <a:ea typeface="Arial"/>
-                <a:cs typeface="Arial"/>
-              </a:defRPr>
-            </a:lvl2pPr>
-            <a:lvl3pPr>
-              <a:defRPr sz="1200" b="1">
-                <a:solidFill>
-                  <a:srgbClr val="1259A7"/>
-                </a:solidFill>
-                <a:latin typeface="Arial"/>
-                <a:ea typeface="Arial"/>
-                <a:cs typeface="Arial"/>
-              </a:defRPr>
-            </a:lvl3pPr>
-            <a:lvl4pPr>
-              <a:defRPr sz="1200" b="1">
-                <a:solidFill>
-                  <a:srgbClr val="1259A7"/>
-                </a:solidFill>
-                <a:latin typeface="Arial"/>
-                <a:ea typeface="Arial"/>
-                <a:cs typeface="Arial"/>
-              </a:defRPr>
-            </a:lvl4pPr>
-            <a:lvl5pPr>
-              <a:defRPr sz="1200" b="1">
-                <a:solidFill>
-                  <a:srgbClr val="1259A7"/>
-                </a:solidFill>
-                <a:latin typeface="Arial"/>
-                <a:ea typeface="Arial"/>
-                <a:cs typeface="Arial"/>
-              </a:defRPr>
-            </a:lvl5pPr>
-            <a:lvl6pPr>
-              <a:defRPr sz="1200" b="1">
-                <a:solidFill>
-                  <a:srgbClr val="1259A7"/>
-                </a:solidFill>
-                <a:latin typeface="Arial"/>
-                <a:ea typeface="Arial"/>
-                <a:cs typeface="Arial"/>
-              </a:defRPr>
-            </a:lvl6pPr>
-            <a:lvl7pPr>
-              <a:defRPr sz="1200" b="1">
-                <a:solidFill>
-                  <a:srgbClr val="1259A7"/>
-                </a:solidFill>
-                <a:latin typeface="Arial"/>
-                <a:ea typeface="Arial"/>
-                <a:cs typeface="Arial"/>
-              </a:defRPr>
-            </a:lvl7pPr>
-            <a:lvl8pPr>
-              <a:defRPr sz="1200" b="1">
-                <a:solidFill>
-                  <a:srgbClr val="1259A7"/>
-                </a:solidFill>
-                <a:latin typeface="Arial"/>
-                <a:ea typeface="Arial"/>
-                <a:cs typeface="Arial"/>
-              </a:defRPr>
-            </a:lvl8pPr>
-            <a:lvl9pPr>
-              <a:defRPr sz="1200" b="1">
-                <a:solidFill>
-                  <a:srgbClr val="1259A7"/>
-                </a:solidFill>
-                <a:latin typeface="Arial"/>
-                <a:ea typeface="Arial"/>
-                <a:cs typeface="Arial"/>
-              </a:defRPr>
-            </a:lvl9pPr>
-          </a:lstStyle>
-          <a:p xmlns:a="http://schemas.openxmlformats.org/drawingml/2006/main">
-            <a:pPr>
-              <a:defRPr sz="1200" b="1">
-                <a:solidFill>
-                  <a:srgbClr val="1259A7"/>
-                </a:solidFill>
-                <a:latin typeface="Arial"/>
-                <a:ea typeface="Arial"/>
-                <a:cs typeface="Arial"/>
-              </a:defRPr>
-            </a:pPr>
-            <a:r>
-              <a:rPr sz="1200" b="1">
-                <a:solidFill>
-                  <a:srgbClr val="1259A7"/>
-                </a:solidFill>
-                <a:latin typeface="Arial"/>
-                <a:ea typeface="Arial"/>
-                <a:cs typeface="Arial"/>
-              </a:rPr>
-              <a:t>3  IO.03 market query</a:t>
-            </a:r>
-          </a:p>
-        </p:txBody>
-      </p:sp>
-      <p:cxnSp>
-        <p:nvCxnSpPr>
-          <p:cNvPr id="38" name="">
-            <a:extLst xmlns:a="http://schemas.openxmlformats.org/drawingml/2006/main">
-              <a:ext uri="{FF2B5EF4-FFF2-40B4-BE49-F238E27FC236}">
-                <a16:creationId xmlns:a16="http://schemas.microsoft.com/office/drawing/2014/main" id="{35284B64-7D48-465B-A4A4-A86FAED5C3EC}"/>
-              </a:ext>
-            </a:extLst>
-          </p:cNvPr>
-          <p:cNvCxnSpPr/>
-          <p:nvPr/>
-        </p:nvCxnSpPr>
-        <p:spPr>
-          <a:xfrm xmlns:a="http://schemas.openxmlformats.org/drawingml/2006/main">
-            <a:off x="3619500" y="4143375"/>
-            <a:ext cx="2857500" cy="0"/>
-          </a:xfrm>
-          <a:prstGeom xmlns:a="http://schemas.openxmlformats.org/drawingml/2006/main" prst="straightConnector1">
-            <a:avLst/>
-          </a:prstGeom>
-          <a:ln xmlns:a="http://schemas.openxmlformats.org/drawingml/2006/main" w="23813">
-            <a:solidFill>
-              <a:srgbClr val="1259A7"/>
-            </a:solidFill>
-            <a:headEnd type="triangle" w="sm" len="sm"/>
-          </a:ln>
-        </p:spPr>
-      </p:cxnSp>
-      <p:sp>
-        <p:nvSpPr>
-          <p:cNvPr id="39" name="">
-            <a:extLst xmlns:a="http://schemas.openxmlformats.org/drawingml/2006/main">
-              <a:ext uri="{FF2B5EF4-FFF2-40B4-BE49-F238E27FC236}">
-                <a16:creationId xmlns:a16="http://schemas.microsoft.com/office/drawing/2014/main" id="{E52C4B2E-59D1-48E7-AD1A-7F00D175DFF3}"/>
-              </a:ext>
-            </a:extLst>
-          </p:cNvPr>
-          <p:cNvSpPr>
-            <a:spLocks xmlns:a="http://schemas.openxmlformats.org/drawingml/2006/main" noGrp="1"/>
-          </p:cNvSpPr>
-          <p:nvPr/>
-        </p:nvSpPr>
-        <p:spPr>
-          <a:xfrm xmlns:a="http://schemas.openxmlformats.org/drawingml/2006/main">
-            <a:off x="3695700" y="3886200"/>
-            <a:ext cx="4000500" cy="247650"/>
-          </a:xfrm>
-          <a:prstGeom xmlns:a="http://schemas.openxmlformats.org/drawingml/2006/main" prst="rect">
-            <a:avLst/>
-          </a:prstGeom>
-          <a:solidFill xmlns:a="http://schemas.openxmlformats.org/drawingml/2006/main">
-            <a:srgbClr val="FFFFFF"/>
-          </a:solidFill>
-          <a:ln xmlns:a="http://schemas.openxmlformats.org/drawingml/2006/main" w="0">
-            <a:noFill/>
-          </a:ln>
-        </p:spPr>
-        <p:txBody>
-          <a:bodyPr xmlns:a="http://schemas.openxmlformats.org/drawingml/2006/main" lIns="0" tIns="0" rIns="0" bIns="0"/>
-          <a:lstStyle xmlns:a="http://schemas.openxmlformats.org/drawingml/2006/main">
-            <a:defPPr>
-              <a:defRPr sz="1200" b="1">
-                <a:solidFill>
-                  <a:srgbClr val="1259A7"/>
-                </a:solidFill>
-                <a:latin typeface="Arial"/>
-                <a:ea typeface="Arial"/>
-                <a:cs typeface="Arial"/>
-              </a:defRPr>
-            </a:defPPr>
-            <a:lvl1pPr>
-              <a:defRPr sz="1200" b="1">
-                <a:solidFill>
-                  <a:srgbClr val="1259A7"/>
-                </a:solidFill>
-                <a:latin typeface="Arial"/>
-                <a:ea typeface="Arial"/>
-                <a:cs typeface="Arial"/>
-              </a:defRPr>
-            </a:lvl1pPr>
-            <a:lvl2pPr>
-              <a:defRPr sz="1200" b="1">
-                <a:solidFill>
-                  <a:srgbClr val="1259A7"/>
-                </a:solidFill>
-                <a:latin typeface="Arial"/>
-                <a:ea typeface="Arial"/>
-                <a:cs typeface="Arial"/>
-              </a:defRPr>
-            </a:lvl2pPr>
-            <a:lvl3pPr>
-              <a:defRPr sz="1200" b="1">
-                <a:solidFill>
-                  <a:srgbClr val="1259A7"/>
-                </a:solidFill>
-                <a:latin typeface="Arial"/>
-                <a:ea typeface="Arial"/>
-                <a:cs typeface="Arial"/>
-              </a:defRPr>
-            </a:lvl3pPr>
-            <a:lvl4pPr>
-              <a:defRPr sz="1200" b="1">
-                <a:solidFill>
-                  <a:srgbClr val="1259A7"/>
-                </a:solidFill>
-                <a:latin typeface="Arial"/>
-                <a:ea typeface="Arial"/>
-                <a:cs typeface="Arial"/>
-              </a:defRPr>
-            </a:lvl4pPr>
-            <a:lvl5pPr>
-              <a:defRPr sz="1200" b="1">
-                <a:solidFill>
-                  <a:srgbClr val="1259A7"/>
-                </a:solidFill>
-                <a:latin typeface="Arial"/>
-                <a:ea typeface="Arial"/>
-                <a:cs typeface="Arial"/>
-              </a:defRPr>
-            </a:lvl5pPr>
-            <a:lvl6pPr>
-              <a:defRPr sz="1200" b="1">
-                <a:solidFill>
-                  <a:srgbClr val="1259A7"/>
-                </a:solidFill>
-                <a:latin typeface="Arial"/>
-                <a:ea typeface="Arial"/>
-                <a:cs typeface="Arial"/>
-              </a:defRPr>
-            </a:lvl6pPr>
-            <a:lvl7pPr>
-              <a:defRPr sz="1200" b="1">
-                <a:solidFill>
-                  <a:srgbClr val="1259A7"/>
-                </a:solidFill>
-                <a:latin typeface="Arial"/>
-                <a:ea typeface="Arial"/>
-                <a:cs typeface="Arial"/>
-              </a:defRPr>
-            </a:lvl7pPr>
-            <a:lvl8pPr>
-              <a:defRPr sz="1200" b="1">
-                <a:solidFill>
-                  <a:srgbClr val="1259A7"/>
-                </a:solidFill>
-                <a:latin typeface="Arial"/>
-                <a:ea typeface="Arial"/>
-                <a:cs typeface="Arial"/>
-              </a:defRPr>
-            </a:lvl8pPr>
-            <a:lvl9pPr>
-              <a:defRPr sz="1200" b="1">
-                <a:solidFill>
-                  <a:srgbClr val="1259A7"/>
-                </a:solidFill>
-                <a:latin typeface="Arial"/>
-                <a:ea typeface="Arial"/>
-                <a:cs typeface="Arial"/>
-              </a:defRPr>
-            </a:lvl9pPr>
-          </a:lstStyle>
-          <a:p xmlns:a="http://schemas.openxmlformats.org/drawingml/2006/main">
-            <a:pPr>
-              <a:defRPr sz="1200" b="1">
-                <a:solidFill>
-                  <a:srgbClr val="1259A7"/>
-                </a:solidFill>
-                <a:latin typeface="Arial"/>
-                <a:ea typeface="Arial"/>
-                <a:cs typeface="Arial"/>
-              </a:defRPr>
-            </a:pPr>
-            <a:r>
-              <a:rPr sz="1200" b="1">
-                <a:solidFill>
-                  <a:srgbClr val="1259A7"/>
-                </a:solidFill>
-                <a:latin typeface="Arial"/>
-                <a:ea typeface="Arial"/>
-                <a:cs typeface="Arial"/>
-              </a:rPr>
-              <a:t>4  IO.07 dated market records</a:t>
+              <a:t>0  IO.10 Research Configuration — control on F.1–F.5</a:t>
             </a:r>
           </a:p>
         </p:txBody>
@@ -10747,7 +10380,7 @@
           <p:cNvPr id="40" name="">
             <a:extLst xmlns:a="http://schemas.openxmlformats.org/drawingml/2006/main">
               <a:ext uri="{FF2B5EF4-FFF2-40B4-BE49-F238E27FC236}">
-                <a16:creationId xmlns:a16="http://schemas.microsoft.com/office/drawing/2014/main" id="{68E51B37-AA6C-45FD-91B8-30DA99A646EB}"/>
+                <a16:creationId xmlns:a16="http://schemas.microsoft.com/office/drawing/2014/main" id="{2C8E17CE-3BE4-4C99-AEBD-78AC542CFC63}"/>
               </a:ext>
             </a:extLst>
           </p:cNvPr>
@@ -10756,7 +10389,7 @@
         </p:nvCxnSpPr>
         <p:spPr>
           <a:xfrm xmlns:a="http://schemas.openxmlformats.org/drawingml/2006/main">
-            <a:off x="3619500" y="4667250"/>
+            <a:off x="762000" y="2667000"/>
             <a:ext cx="1428750" cy="0"/>
           </a:xfrm>
           <a:prstGeom xmlns:a="http://schemas.openxmlformats.org/drawingml/2006/main" prst="straightConnector1">
@@ -10766,7 +10399,7 @@
             <a:solidFill>
               <a:srgbClr val="1259A7"/>
             </a:solidFill>
-            <a:headEnd type="triangle" w="sm" len="sm"/>
+            <a:tailEnd type="triangle" w="sm" len="sm"/>
           </a:ln>
         </p:spPr>
       </p:cxnSp>
@@ -10775,7 +10408,7 @@
           <p:cNvPr id="41" name="">
             <a:extLst xmlns:a="http://schemas.openxmlformats.org/drawingml/2006/main">
               <a:ext uri="{FF2B5EF4-FFF2-40B4-BE49-F238E27FC236}">
-                <a16:creationId xmlns:a16="http://schemas.microsoft.com/office/drawing/2014/main" id="{DFA73BEB-9AB3-4BD9-AF4E-5C011B970DAD}"/>
+                <a16:creationId xmlns:a16="http://schemas.microsoft.com/office/drawing/2014/main" id="{08701841-DCCA-4268-A935-A4472D2B7BB8}"/>
               </a:ext>
             </a:extLst>
           </p:cNvPr>
@@ -10786,7 +10419,7 @@
         </p:nvSpPr>
         <p:spPr>
           <a:xfrm xmlns:a="http://schemas.openxmlformats.org/drawingml/2006/main">
-            <a:off x="3695700" y="4410075"/>
+            <a:off x="838200" y="2409825"/>
             <a:ext cx="4000500" cy="247650"/>
           </a:xfrm>
           <a:prstGeom xmlns:a="http://schemas.openxmlformats.org/drawingml/2006/main" prst="rect">
@@ -10923,7 +10556,7 @@
                 <a:ea typeface="Arial"/>
                 <a:cs typeface="Arial"/>
               </a:rPr>
-              <a:t>5  IO.08 dated news evidence</a:t>
+              <a:t>1  Stock pair and date</a:t>
             </a:r>
           </a:p>
         </p:txBody>
@@ -10933,7 +10566,7 @@
           <p:cNvPr id="42" name="">
             <a:extLst xmlns:a="http://schemas.openxmlformats.org/drawingml/2006/main">
               <a:ext uri="{FF2B5EF4-FFF2-40B4-BE49-F238E27FC236}">
-                <a16:creationId xmlns:a16="http://schemas.microsoft.com/office/drawing/2014/main" id="{B3CEA30B-072D-4302-9287-692C1576C3A8}"/>
+                <a16:creationId xmlns:a16="http://schemas.microsoft.com/office/drawing/2014/main" id="{D557FEDB-8B7C-405E-AA2A-F7517C2ABF43}"/>
               </a:ext>
             </a:extLst>
           </p:cNvPr>
@@ -10942,8 +10575,8 @@
         </p:nvCxnSpPr>
         <p:spPr>
           <a:xfrm xmlns:a="http://schemas.openxmlformats.org/drawingml/2006/main">
-            <a:off x="3619500" y="5191125"/>
-            <a:ext cx="4286250" cy="0"/>
+            <a:off x="2190750" y="3190875"/>
+            <a:ext cx="1428750" cy="0"/>
           </a:xfrm>
           <a:prstGeom xmlns:a="http://schemas.openxmlformats.org/drawingml/2006/main" prst="straightConnector1">
             <a:avLst/>
@@ -10961,7 +10594,7 @@
           <p:cNvPr id="43" name="">
             <a:extLst xmlns:a="http://schemas.openxmlformats.org/drawingml/2006/main">
               <a:ext uri="{FF2B5EF4-FFF2-40B4-BE49-F238E27FC236}">
-                <a16:creationId xmlns:a16="http://schemas.microsoft.com/office/drawing/2014/main" id="{E6506292-D58D-4C3C-90F8-87FAD2508AFF}"/>
+                <a16:creationId xmlns:a16="http://schemas.microsoft.com/office/drawing/2014/main" id="{BE97ECB0-49DA-4461-AA80-FCA0D28DF43A}"/>
               </a:ext>
             </a:extLst>
           </p:cNvPr>
@@ -10972,8 +10605,8 @@
         </p:nvSpPr>
         <p:spPr>
           <a:xfrm xmlns:a="http://schemas.openxmlformats.org/drawingml/2006/main">
-            <a:off x="3695700" y="4933950"/>
-            <a:ext cx="4191000" cy="247650"/>
+            <a:off x="2266950" y="2933700"/>
+            <a:ext cx="4000500" cy="247650"/>
           </a:xfrm>
           <a:prstGeom xmlns:a="http://schemas.openxmlformats.org/drawingml/2006/main" prst="rect">
             <a:avLst/>
@@ -11109,7 +10742,7 @@
                 <a:ea typeface="Arial"/>
                 <a:cs typeface="Arial"/>
               </a:rPr>
-              <a:t>5.1  IF.02 validated evidence</a:t>
+              <a:t>1.1  IF.01 validated request</a:t>
             </a:r>
           </a:p>
         </p:txBody>
@@ -11119,7 +10752,7 @@
           <p:cNvPr id="44" name="">
             <a:extLst xmlns:a="http://schemas.openxmlformats.org/drawingml/2006/main">
               <a:ext uri="{FF2B5EF4-FFF2-40B4-BE49-F238E27FC236}">
-                <a16:creationId xmlns:a16="http://schemas.microsoft.com/office/drawing/2014/main" id="{FB718287-627A-44A4-AAC6-6F6A5021044F}"/>
+                <a16:creationId xmlns:a16="http://schemas.microsoft.com/office/drawing/2014/main" id="{9154B0AA-28FE-4755-BD2D-532CB3046676}"/>
               </a:ext>
             </a:extLst>
           </p:cNvPr>
@@ -11128,7 +10761,7 @@
         </p:nvCxnSpPr>
         <p:spPr>
           <a:xfrm xmlns:a="http://schemas.openxmlformats.org/drawingml/2006/main">
-            <a:off x="7905750" y="5715000"/>
+            <a:off x="3619500" y="3714750"/>
             <a:ext cx="1428750" cy="0"/>
           </a:xfrm>
           <a:prstGeom xmlns:a="http://schemas.openxmlformats.org/drawingml/2006/main" prst="straightConnector1">
@@ -11136,7 +10769,7 @@
           </a:prstGeom>
           <a:ln xmlns:a="http://schemas.openxmlformats.org/drawingml/2006/main" w="23813">
             <a:solidFill>
-              <a:srgbClr val="087A63"/>
+              <a:srgbClr val="1259A7"/>
             </a:solidFill>
             <a:tailEnd type="triangle" w="sm" len="sm"/>
           </a:ln>
@@ -11147,7 +10780,7 @@
           <p:cNvPr id="45" name="">
             <a:extLst xmlns:a="http://schemas.openxmlformats.org/drawingml/2006/main">
               <a:ext uri="{FF2B5EF4-FFF2-40B4-BE49-F238E27FC236}">
-                <a16:creationId xmlns:a16="http://schemas.microsoft.com/office/drawing/2014/main" id="{3FFC56EC-680E-44E0-AE36-1658235B7CC6}"/>
+                <a16:creationId xmlns:a16="http://schemas.microsoft.com/office/drawing/2014/main" id="{226F2C28-189D-467F-BE52-4BF6E087711E}"/>
               </a:ext>
             </a:extLst>
           </p:cNvPr>
@@ -11158,7 +10791,7 @@
         </p:nvSpPr>
         <p:spPr>
           <a:xfrm xmlns:a="http://schemas.openxmlformats.org/drawingml/2006/main">
-            <a:off x="7981950" y="5457825"/>
+            <a:off x="3695700" y="3457575"/>
             <a:ext cx="4000500" cy="247650"/>
           </a:xfrm>
           <a:prstGeom xmlns:a="http://schemas.openxmlformats.org/drawingml/2006/main" prst="rect">
@@ -11177,7 +10810,7 @@
             <a:defPPr>
               <a:defRPr sz="1200" b="1">
                 <a:solidFill>
-                  <a:srgbClr val="087A63"/>
+                  <a:srgbClr val="1259A7"/>
                 </a:solidFill>
                 <a:latin typeface="Arial"/>
                 <a:ea typeface="Arial"/>
@@ -11187,7 +10820,7 @@
             <a:lvl1pPr>
               <a:defRPr sz="1200" b="1">
                 <a:solidFill>
-                  <a:srgbClr val="087A63"/>
+                  <a:srgbClr val="1259A7"/>
                 </a:solidFill>
                 <a:latin typeface="Arial"/>
                 <a:ea typeface="Arial"/>
@@ -11197,7 +10830,7 @@
             <a:lvl2pPr>
               <a:defRPr sz="1200" b="1">
                 <a:solidFill>
-                  <a:srgbClr val="087A63"/>
+                  <a:srgbClr val="1259A7"/>
                 </a:solidFill>
                 <a:latin typeface="Arial"/>
                 <a:ea typeface="Arial"/>
@@ -11207,7 +10840,7 @@
             <a:lvl3pPr>
               <a:defRPr sz="1200" b="1">
                 <a:solidFill>
-                  <a:srgbClr val="087A63"/>
+                  <a:srgbClr val="1259A7"/>
                 </a:solidFill>
                 <a:latin typeface="Arial"/>
                 <a:ea typeface="Arial"/>
@@ -11217,7 +10850,7 @@
             <a:lvl4pPr>
               <a:defRPr sz="1200" b="1">
                 <a:solidFill>
-                  <a:srgbClr val="087A63"/>
+                  <a:srgbClr val="1259A7"/>
                 </a:solidFill>
                 <a:latin typeface="Arial"/>
                 <a:ea typeface="Arial"/>
@@ -11227,7 +10860,7 @@
             <a:lvl5pPr>
               <a:defRPr sz="1200" b="1">
                 <a:solidFill>
-                  <a:srgbClr val="087A63"/>
+                  <a:srgbClr val="1259A7"/>
                 </a:solidFill>
                 <a:latin typeface="Arial"/>
                 <a:ea typeface="Arial"/>
@@ -11237,7 +10870,7 @@
             <a:lvl6pPr>
               <a:defRPr sz="1200" b="1">
                 <a:solidFill>
-                  <a:srgbClr val="087A63"/>
+                  <a:srgbClr val="1259A7"/>
                 </a:solidFill>
                 <a:latin typeface="Arial"/>
                 <a:ea typeface="Arial"/>
@@ -11247,7 +10880,7 @@
             <a:lvl7pPr>
               <a:defRPr sz="1200" b="1">
                 <a:solidFill>
-                  <a:srgbClr val="087A63"/>
+                  <a:srgbClr val="1259A7"/>
                 </a:solidFill>
                 <a:latin typeface="Arial"/>
                 <a:ea typeface="Arial"/>
@@ -11257,7 +10890,7 @@
             <a:lvl8pPr>
               <a:defRPr sz="1200" b="1">
                 <a:solidFill>
-                  <a:srgbClr val="087A63"/>
+                  <a:srgbClr val="1259A7"/>
                 </a:solidFill>
                 <a:latin typeface="Arial"/>
                 <a:ea typeface="Arial"/>
@@ -11267,7 +10900,7 @@
             <a:lvl9pPr>
               <a:defRPr sz="1200" b="1">
                 <a:solidFill>
-                  <a:srgbClr val="087A63"/>
+                  <a:srgbClr val="1259A7"/>
                 </a:solidFill>
                 <a:latin typeface="Arial"/>
                 <a:ea typeface="Arial"/>
@@ -11279,7 +10912,7 @@
             <a:pPr>
               <a:defRPr sz="1200" b="1">
                 <a:solidFill>
-                  <a:srgbClr val="087A63"/>
+                  <a:srgbClr val="1259A7"/>
                 </a:solidFill>
                 <a:latin typeface="Arial"/>
                 <a:ea typeface="Arial"/>
@@ -11289,13 +10922,13 @@
             <a:r>
               <a:rPr sz="1200" b="1">
                 <a:solidFill>
-                  <a:srgbClr val="087A63"/>
+                  <a:srgbClr val="1259A7"/>
                 </a:solidFill>
                 <a:latin typeface="Arial"/>
                 <a:ea typeface="Arial"/>
                 <a:cs typeface="Arial"/>
               </a:rPr>
-              <a:t>5.2  IF.03 computed record</a:t>
+              <a:t>2  IO.04 news query</a:t>
             </a:r>
           </a:p>
         </p:txBody>
@@ -11305,7 +10938,7 @@
           <p:cNvPr id="46" name="">
             <a:extLst xmlns:a="http://schemas.openxmlformats.org/drawingml/2006/main">
               <a:ext uri="{FF2B5EF4-FFF2-40B4-BE49-F238E27FC236}">
-                <a16:creationId xmlns:a16="http://schemas.microsoft.com/office/drawing/2014/main" id="{4C3679E2-20D9-47B3-B293-2DA4EBF771CF}"/>
+                <a16:creationId xmlns:a16="http://schemas.microsoft.com/office/drawing/2014/main" id="{F60B9957-4882-4F82-B4EC-2B6E6CE7601E}"/>
               </a:ext>
             </a:extLst>
           </p:cNvPr>
@@ -11314,15 +10947,15 @@
         </p:nvCxnSpPr>
         <p:spPr>
           <a:xfrm xmlns:a="http://schemas.openxmlformats.org/drawingml/2006/main">
-            <a:off x="7905750" y="6238875"/>
-            <a:ext cx="4476750" cy="0"/>
+            <a:off x="3619500" y="4238625"/>
+            <a:ext cx="2857500" cy="0"/>
           </a:xfrm>
           <a:prstGeom xmlns:a="http://schemas.openxmlformats.org/drawingml/2006/main" prst="straightConnector1">
             <a:avLst/>
           </a:prstGeom>
           <a:ln xmlns:a="http://schemas.openxmlformats.org/drawingml/2006/main" w="23813">
             <a:solidFill>
-              <a:srgbClr val="087A63"/>
+              <a:srgbClr val="1259A7"/>
             </a:solidFill>
             <a:tailEnd type="triangle" w="sm" len="sm"/>
           </a:ln>
@@ -11333,7 +10966,7 @@
           <p:cNvPr id="47" name="">
             <a:extLst xmlns:a="http://schemas.openxmlformats.org/drawingml/2006/main">
               <a:ext uri="{FF2B5EF4-FFF2-40B4-BE49-F238E27FC236}">
-                <a16:creationId xmlns:a16="http://schemas.microsoft.com/office/drawing/2014/main" id="{9F3C64F2-1652-488B-AAF2-A9CB5FE51014}"/>
+                <a16:creationId xmlns:a16="http://schemas.microsoft.com/office/drawing/2014/main" id="{624C8C08-A069-4DFB-8C4A-107AE2A643CC}"/>
               </a:ext>
             </a:extLst>
           </p:cNvPr>
@@ -11344,8 +10977,8 @@
         </p:nvSpPr>
         <p:spPr>
           <a:xfrm xmlns:a="http://schemas.openxmlformats.org/drawingml/2006/main">
-            <a:off x="7981950" y="5981700"/>
-            <a:ext cx="4381500" cy="247650"/>
+            <a:off x="3695700" y="3981450"/>
+            <a:ext cx="4000500" cy="247650"/>
           </a:xfrm>
           <a:prstGeom xmlns:a="http://schemas.openxmlformats.org/drawingml/2006/main" prst="rect">
             <a:avLst/>
@@ -11363,7 +10996,7 @@
             <a:defPPr>
               <a:defRPr sz="1200" b="1">
                 <a:solidFill>
-                  <a:srgbClr val="087A63"/>
+                  <a:srgbClr val="1259A7"/>
                 </a:solidFill>
                 <a:latin typeface="Arial"/>
                 <a:ea typeface="Arial"/>
@@ -11373,7 +11006,7 @@
             <a:lvl1pPr>
               <a:defRPr sz="1200" b="1">
                 <a:solidFill>
-                  <a:srgbClr val="087A63"/>
+                  <a:srgbClr val="1259A7"/>
                 </a:solidFill>
                 <a:latin typeface="Arial"/>
                 <a:ea typeface="Arial"/>
@@ -11383,7 +11016,7 @@
             <a:lvl2pPr>
               <a:defRPr sz="1200" b="1">
                 <a:solidFill>
-                  <a:srgbClr val="087A63"/>
+                  <a:srgbClr val="1259A7"/>
                 </a:solidFill>
                 <a:latin typeface="Arial"/>
                 <a:ea typeface="Arial"/>
@@ -11393,7 +11026,7 @@
             <a:lvl3pPr>
               <a:defRPr sz="1200" b="1">
                 <a:solidFill>
-                  <a:srgbClr val="087A63"/>
+                  <a:srgbClr val="1259A7"/>
                 </a:solidFill>
                 <a:latin typeface="Arial"/>
                 <a:ea typeface="Arial"/>
@@ -11403,7 +11036,7 @@
             <a:lvl4pPr>
               <a:defRPr sz="1200" b="1">
                 <a:solidFill>
-                  <a:srgbClr val="087A63"/>
+                  <a:srgbClr val="1259A7"/>
                 </a:solidFill>
                 <a:latin typeface="Arial"/>
                 <a:ea typeface="Arial"/>
@@ -11413,7 +11046,7 @@
             <a:lvl5pPr>
               <a:defRPr sz="1200" b="1">
                 <a:solidFill>
-                  <a:srgbClr val="087A63"/>
+                  <a:srgbClr val="1259A7"/>
                 </a:solidFill>
                 <a:latin typeface="Arial"/>
                 <a:ea typeface="Arial"/>
@@ -11423,7 +11056,7 @@
             <a:lvl6pPr>
               <a:defRPr sz="1200" b="1">
                 <a:solidFill>
-                  <a:srgbClr val="087A63"/>
+                  <a:srgbClr val="1259A7"/>
                 </a:solidFill>
                 <a:latin typeface="Arial"/>
                 <a:ea typeface="Arial"/>
@@ -11433,7 +11066,7 @@
             <a:lvl7pPr>
               <a:defRPr sz="1200" b="1">
                 <a:solidFill>
-                  <a:srgbClr val="087A63"/>
+                  <a:srgbClr val="1259A7"/>
                 </a:solidFill>
                 <a:latin typeface="Arial"/>
                 <a:ea typeface="Arial"/>
@@ -11443,7 +11076,7 @@
             <a:lvl8pPr>
               <a:defRPr sz="1200" b="1">
                 <a:solidFill>
-                  <a:srgbClr val="087A63"/>
+                  <a:srgbClr val="1259A7"/>
                 </a:solidFill>
                 <a:latin typeface="Arial"/>
                 <a:ea typeface="Arial"/>
@@ -11453,7 +11086,7 @@
             <a:lvl9pPr>
               <a:defRPr sz="1200" b="1">
                 <a:solidFill>
-                  <a:srgbClr val="087A63"/>
+                  <a:srgbClr val="1259A7"/>
                 </a:solidFill>
                 <a:latin typeface="Arial"/>
                 <a:ea typeface="Arial"/>
@@ -11465,7 +11098,7 @@
             <a:pPr>
               <a:defRPr sz="1200" b="1">
                 <a:solidFill>
-                  <a:srgbClr val="087A63"/>
+                  <a:srgbClr val="1259A7"/>
                 </a:solidFill>
                 <a:latin typeface="Arial"/>
                 <a:ea typeface="Arial"/>
@@ -11475,13 +11108,13 @@
             <a:r>
               <a:rPr sz="1200" b="1">
                 <a:solidFill>
-                  <a:srgbClr val="087A63"/>
+                  <a:srgbClr val="1259A7"/>
                 </a:solidFill>
                 <a:latin typeface="Arial"/>
                 <a:ea typeface="Arial"/>
                 <a:cs typeface="Arial"/>
               </a:rPr>
-              <a:t>5.3  IF.03 same record to display</a:t>
+              <a:t>3  IO.03 market query</a:t>
             </a:r>
           </a:p>
         </p:txBody>
@@ -11491,7 +11124,7 @@
           <p:cNvPr id="48" name="">
             <a:extLst xmlns:a="http://schemas.openxmlformats.org/drawingml/2006/main">
               <a:ext uri="{FF2B5EF4-FFF2-40B4-BE49-F238E27FC236}">
-                <a16:creationId xmlns:a16="http://schemas.microsoft.com/office/drawing/2014/main" id="{1A6AAB26-7405-4007-AA84-3C8A57DFEF1A}"/>
+                <a16:creationId xmlns:a16="http://schemas.microsoft.com/office/drawing/2014/main" id="{1DE2C580-A99F-46F9-9C35-21BB6A2A4F67}"/>
               </a:ext>
             </a:extLst>
           </p:cNvPr>
@@ -11500,8 +11133,8 @@
         </p:nvCxnSpPr>
         <p:spPr>
           <a:xfrm xmlns:a="http://schemas.openxmlformats.org/drawingml/2006/main">
-            <a:off x="9334500" y="6762750"/>
-            <a:ext cx="1428750" cy="0"/>
+            <a:off x="3619500" y="4762500"/>
+            <a:ext cx="2857500" cy="0"/>
           </a:xfrm>
           <a:prstGeom xmlns:a="http://schemas.openxmlformats.org/drawingml/2006/main" prst="straightConnector1">
             <a:avLst/>
@@ -11510,7 +11143,7 @@
             <a:solidFill>
               <a:srgbClr val="1259A7"/>
             </a:solidFill>
-            <a:tailEnd type="triangle" w="sm" len="sm"/>
+            <a:headEnd type="triangle" w="sm" len="sm"/>
           </a:ln>
         </p:spPr>
       </p:cxnSp>
@@ -11519,7 +11152,7 @@
           <p:cNvPr id="49" name="">
             <a:extLst xmlns:a="http://schemas.openxmlformats.org/drawingml/2006/main">
               <a:ext uri="{FF2B5EF4-FFF2-40B4-BE49-F238E27FC236}">
-                <a16:creationId xmlns:a16="http://schemas.microsoft.com/office/drawing/2014/main" id="{C1B3E01F-20DF-4F9C-BC17-6DA2945B1724}"/>
+                <a16:creationId xmlns:a16="http://schemas.microsoft.com/office/drawing/2014/main" id="{A225E9D2-7974-46DE-A281-5C427CE33FE7}"/>
               </a:ext>
             </a:extLst>
           </p:cNvPr>
@@ -11530,7 +11163,7 @@
         </p:nvSpPr>
         <p:spPr>
           <a:xfrm xmlns:a="http://schemas.openxmlformats.org/drawingml/2006/main">
-            <a:off x="9410700" y="6505575"/>
+            <a:off x="3695700" y="4505325"/>
             <a:ext cx="4000500" cy="247650"/>
           </a:xfrm>
           <a:prstGeom xmlns:a="http://schemas.openxmlformats.org/drawingml/2006/main" prst="rect">
@@ -11667,7 +11300,7 @@
                 <a:ea typeface="Arial"/>
                 <a:cs typeface="Arial"/>
               </a:rPr>
-              <a:t>6  IO.05 score-evidence package</a:t>
+              <a:t>4  IO.07 dated market records</a:t>
             </a:r>
           </a:p>
         </p:txBody>
@@ -11677,7 +11310,7 @@
           <p:cNvPr id="50" name="">
             <a:extLst xmlns:a="http://schemas.openxmlformats.org/drawingml/2006/main">
               <a:ext uri="{FF2B5EF4-FFF2-40B4-BE49-F238E27FC236}">
-                <a16:creationId xmlns:a16="http://schemas.microsoft.com/office/drawing/2014/main" id="{C13E7B8F-2356-4744-8CA3-623228DA3036}"/>
+                <a16:creationId xmlns:a16="http://schemas.microsoft.com/office/drawing/2014/main" id="{2969A9DB-3EE9-4D2C-AE28-E6EA9C108261}"/>
               </a:ext>
             </a:extLst>
           </p:cNvPr>
@@ -11686,7 +11319,7 @@
         </p:nvCxnSpPr>
         <p:spPr>
           <a:xfrm xmlns:a="http://schemas.openxmlformats.org/drawingml/2006/main">
-            <a:off x="9334500" y="7286625"/>
+            <a:off x="3619500" y="5286375"/>
             <a:ext cx="1428750" cy="0"/>
           </a:xfrm>
           <a:prstGeom xmlns:a="http://schemas.openxmlformats.org/drawingml/2006/main" prst="straightConnector1">
@@ -11705,7 +11338,7 @@
           <p:cNvPr id="51" name="">
             <a:extLst xmlns:a="http://schemas.openxmlformats.org/drawingml/2006/main">
               <a:ext uri="{FF2B5EF4-FFF2-40B4-BE49-F238E27FC236}">
-                <a16:creationId xmlns:a16="http://schemas.microsoft.com/office/drawing/2014/main" id="{1A45E1AE-D505-4925-B341-A842E998F5E7}"/>
+                <a16:creationId xmlns:a16="http://schemas.microsoft.com/office/drawing/2014/main" id="{D91784D0-8330-484B-99D0-B8BD1EED17C5}"/>
               </a:ext>
             </a:extLst>
           </p:cNvPr>
@@ -11716,7 +11349,7 @@
         </p:nvSpPr>
         <p:spPr>
           <a:xfrm xmlns:a="http://schemas.openxmlformats.org/drawingml/2006/main">
-            <a:off x="9410700" y="7029450"/>
+            <a:off x="3695700" y="5029200"/>
             <a:ext cx="4000500" cy="247650"/>
           </a:xfrm>
           <a:prstGeom xmlns:a="http://schemas.openxmlformats.org/drawingml/2006/main" prst="rect">
@@ -11853,7 +11486,7 @@
                 <a:ea typeface="Arial"/>
                 <a:cs typeface="Arial"/>
               </a:rPr>
-              <a:t>7  IO.09 AI explanation</a:t>
+              <a:t>5  IO.08 dated news evidence</a:t>
             </a:r>
           </a:p>
         </p:txBody>
@@ -11863,7 +11496,7 @@
           <p:cNvPr id="52" name="">
             <a:extLst xmlns:a="http://schemas.openxmlformats.org/drawingml/2006/main">
               <a:ext uri="{FF2B5EF4-FFF2-40B4-BE49-F238E27FC236}">
-                <a16:creationId xmlns:a16="http://schemas.microsoft.com/office/drawing/2014/main" id="{FCEC98DF-D899-4D39-A7D9-1FA8A99219D3}"/>
+                <a16:creationId xmlns:a16="http://schemas.microsoft.com/office/drawing/2014/main" id="{57D6A217-2961-4FB3-B524-83DD9564ED9F}"/>
               </a:ext>
             </a:extLst>
           </p:cNvPr>
@@ -11872,8 +11505,8 @@
         </p:nvCxnSpPr>
         <p:spPr>
           <a:xfrm xmlns:a="http://schemas.openxmlformats.org/drawingml/2006/main">
-            <a:off x="9334500" y="7810500"/>
-            <a:ext cx="3048000" cy="0"/>
+            <a:off x="3619500" y="5810250"/>
+            <a:ext cx="4286250" cy="0"/>
           </a:xfrm>
           <a:prstGeom xmlns:a="http://schemas.openxmlformats.org/drawingml/2006/main" prst="straightConnector1">
             <a:avLst/>
@@ -11891,7 +11524,7 @@
           <p:cNvPr id="53" name="">
             <a:extLst xmlns:a="http://schemas.openxmlformats.org/drawingml/2006/main">
               <a:ext uri="{FF2B5EF4-FFF2-40B4-BE49-F238E27FC236}">
-                <a16:creationId xmlns:a16="http://schemas.microsoft.com/office/drawing/2014/main" id="{89FA74AA-666D-44EF-82E7-6E3FD39C887C}"/>
+                <a16:creationId xmlns:a16="http://schemas.microsoft.com/office/drawing/2014/main" id="{56AE92BC-8EAF-46ED-A06B-64AC5DCC4713}"/>
               </a:ext>
             </a:extLst>
           </p:cNvPr>
@@ -11902,8 +11535,8 @@
         </p:nvSpPr>
         <p:spPr>
           <a:xfrm xmlns:a="http://schemas.openxmlformats.org/drawingml/2006/main">
-            <a:off x="9410700" y="7553325"/>
-            <a:ext cx="4000500" cy="247650"/>
+            <a:off x="3695700" y="5553075"/>
+            <a:ext cx="4191000" cy="247650"/>
           </a:xfrm>
           <a:prstGeom xmlns:a="http://schemas.openxmlformats.org/drawingml/2006/main" prst="rect">
             <a:avLst/>
@@ -12039,7 +11672,7 @@
                 <a:ea typeface="Arial"/>
                 <a:cs typeface="Arial"/>
               </a:rPr>
-              <a:t>7.1  IF.04 checked explanation / availability</a:t>
+              <a:t>5.1  IF.02 validated evidence</a:t>
             </a:r>
           </a:p>
         </p:txBody>
@@ -12049,7 +11682,7 @@
           <p:cNvPr id="54" name="">
             <a:extLst xmlns:a="http://schemas.openxmlformats.org/drawingml/2006/main">
               <a:ext uri="{FF2B5EF4-FFF2-40B4-BE49-F238E27FC236}">
-                <a16:creationId xmlns:a16="http://schemas.microsoft.com/office/drawing/2014/main" id="{FEE85DE5-B8E4-4E12-A094-27FFFAA8E0EB}"/>
+                <a16:creationId xmlns:a16="http://schemas.microsoft.com/office/drawing/2014/main" id="{261DE576-C8B9-4DB7-9A8A-2B633C410BEA}"/>
               </a:ext>
             </a:extLst>
           </p:cNvPr>
@@ -12058,17 +11691,17 @@
         </p:nvCxnSpPr>
         <p:spPr>
           <a:xfrm xmlns:a="http://schemas.openxmlformats.org/drawingml/2006/main">
-            <a:off x="762000" y="8334375"/>
-            <a:ext cx="11620500" cy="0"/>
+            <a:off x="7905750" y="6334125"/>
+            <a:ext cx="1428750" cy="0"/>
           </a:xfrm>
           <a:prstGeom xmlns:a="http://schemas.openxmlformats.org/drawingml/2006/main" prst="straightConnector1">
             <a:avLst/>
           </a:prstGeom>
           <a:ln xmlns:a="http://schemas.openxmlformats.org/drawingml/2006/main" w="23813">
             <a:solidFill>
-              <a:srgbClr val="1259A7"/>
+              <a:srgbClr val="087A63"/>
             </a:solidFill>
-            <a:headEnd type="triangle" w="sm" len="sm"/>
+            <a:tailEnd type="triangle" w="sm" len="sm"/>
           </a:ln>
         </p:spPr>
       </p:cxnSp>
@@ -12077,7 +11710,7 @@
           <p:cNvPr id="55" name="">
             <a:extLst xmlns:a="http://schemas.openxmlformats.org/drawingml/2006/main">
               <a:ext uri="{FF2B5EF4-FFF2-40B4-BE49-F238E27FC236}">
-                <a16:creationId xmlns:a16="http://schemas.microsoft.com/office/drawing/2014/main" id="{D6091633-E3CA-4DD9-B43D-8BBDFD3A4587}"/>
+                <a16:creationId xmlns:a16="http://schemas.microsoft.com/office/drawing/2014/main" id="{B01E45A2-D427-494B-9891-9076A93D5E68}"/>
               </a:ext>
             </a:extLst>
           </p:cNvPr>
@@ -12088,8 +11721,8 @@
         </p:nvSpPr>
         <p:spPr>
           <a:xfrm xmlns:a="http://schemas.openxmlformats.org/drawingml/2006/main">
-            <a:off x="838200" y="8077200"/>
-            <a:ext cx="11525250" cy="247650"/>
+            <a:off x="7981950" y="6076950"/>
+            <a:ext cx="4000500" cy="247650"/>
           </a:xfrm>
           <a:prstGeom xmlns:a="http://schemas.openxmlformats.org/drawingml/2006/main" prst="rect">
             <a:avLst/>
@@ -12107,7 +11740,7 @@
             <a:defPPr>
               <a:defRPr sz="1200" b="1">
                 <a:solidFill>
-                  <a:srgbClr val="1259A7"/>
+                  <a:srgbClr val="087A63"/>
                 </a:solidFill>
                 <a:latin typeface="Arial"/>
                 <a:ea typeface="Arial"/>
@@ -12117,7 +11750,7 @@
             <a:lvl1pPr>
               <a:defRPr sz="1200" b="1">
                 <a:solidFill>
-                  <a:srgbClr val="1259A7"/>
+                  <a:srgbClr val="087A63"/>
                 </a:solidFill>
                 <a:latin typeface="Arial"/>
                 <a:ea typeface="Arial"/>
@@ -12127,7 +11760,7 @@
             <a:lvl2pPr>
               <a:defRPr sz="1200" b="1">
                 <a:solidFill>
-                  <a:srgbClr val="1259A7"/>
+                  <a:srgbClr val="087A63"/>
                 </a:solidFill>
                 <a:latin typeface="Arial"/>
                 <a:ea typeface="Arial"/>
@@ -12137,7 +11770,7 @@
             <a:lvl3pPr>
               <a:defRPr sz="1200" b="1">
                 <a:solidFill>
-                  <a:srgbClr val="1259A7"/>
+                  <a:srgbClr val="087A63"/>
                 </a:solidFill>
                 <a:latin typeface="Arial"/>
                 <a:ea typeface="Arial"/>
@@ -12147,7 +11780,7 @@
             <a:lvl4pPr>
               <a:defRPr sz="1200" b="1">
                 <a:solidFill>
-                  <a:srgbClr val="1259A7"/>
+                  <a:srgbClr val="087A63"/>
                 </a:solidFill>
                 <a:latin typeface="Arial"/>
                 <a:ea typeface="Arial"/>
@@ -12157,7 +11790,7 @@
             <a:lvl5pPr>
               <a:defRPr sz="1200" b="1">
                 <a:solidFill>
-                  <a:srgbClr val="1259A7"/>
+                  <a:srgbClr val="087A63"/>
                 </a:solidFill>
                 <a:latin typeface="Arial"/>
                 <a:ea typeface="Arial"/>
@@ -12167,7 +11800,7 @@
             <a:lvl6pPr>
               <a:defRPr sz="1200" b="1">
                 <a:solidFill>
-                  <a:srgbClr val="1259A7"/>
+                  <a:srgbClr val="087A63"/>
                 </a:solidFill>
                 <a:latin typeface="Arial"/>
                 <a:ea typeface="Arial"/>
@@ -12177,7 +11810,7 @@
             <a:lvl7pPr>
               <a:defRPr sz="1200" b="1">
                 <a:solidFill>
-                  <a:srgbClr val="1259A7"/>
+                  <a:srgbClr val="087A63"/>
                 </a:solidFill>
                 <a:latin typeface="Arial"/>
                 <a:ea typeface="Arial"/>
@@ -12187,7 +11820,7 @@
             <a:lvl8pPr>
               <a:defRPr sz="1200" b="1">
                 <a:solidFill>
-                  <a:srgbClr val="1259A7"/>
+                  <a:srgbClr val="087A63"/>
                 </a:solidFill>
                 <a:latin typeface="Arial"/>
                 <a:ea typeface="Arial"/>
@@ -12197,7 +11830,7 @@
             <a:lvl9pPr>
               <a:defRPr sz="1200" b="1">
                 <a:solidFill>
-                  <a:srgbClr val="1259A7"/>
+                  <a:srgbClr val="087A63"/>
                 </a:solidFill>
                 <a:latin typeface="Arial"/>
                 <a:ea typeface="Arial"/>
@@ -12209,7 +11842,7 @@
             <a:pPr>
               <a:defRPr sz="1200" b="1">
                 <a:solidFill>
-                  <a:srgbClr val="1259A7"/>
+                  <a:srgbClr val="087A63"/>
                 </a:solidFill>
                 <a:latin typeface="Arial"/>
                 <a:ea typeface="Arial"/>
@@ -12219,23 +11852,51 @@
             <a:r>
               <a:rPr sz="1200" b="1">
                 <a:solidFill>
-                  <a:srgbClr val="1259A7"/>
+                  <a:srgbClr val="087A63"/>
                 </a:solidFill>
                 <a:latin typeface="Arial"/>
                 <a:ea typeface="Arial"/>
                 <a:cs typeface="Arial"/>
               </a:rPr>
-              <a:t>8  IO.02 comparison and evidence</a:t>
+              <a:t>5.2  IF.03 computed record</a:t>
             </a:r>
           </a:p>
         </p:txBody>
       </p:sp>
-      <p:sp>
-        <p:nvSpPr>
+      <p:cxnSp>
+        <p:nvCxnSpPr>
           <p:cNvPr id="56" name="">
             <a:extLst xmlns:a="http://schemas.openxmlformats.org/drawingml/2006/main">
               <a:ext uri="{FF2B5EF4-FFF2-40B4-BE49-F238E27FC236}">
-                <a16:creationId xmlns:a16="http://schemas.microsoft.com/office/drawing/2014/main" id="{6AF435B3-E6AF-4CB7-8AA3-5A948FF697D7}"/>
+                <a16:creationId xmlns:a16="http://schemas.microsoft.com/office/drawing/2014/main" id="{BC383779-7133-4731-BD7A-F32EDF9C14C2}"/>
+              </a:ext>
+            </a:extLst>
+          </p:cNvPr>
+          <p:cNvCxnSpPr/>
+          <p:nvPr/>
+        </p:nvCxnSpPr>
+        <p:spPr>
+          <a:xfrm xmlns:a="http://schemas.openxmlformats.org/drawingml/2006/main">
+            <a:off x="7905750" y="6858000"/>
+            <a:ext cx="4476750" cy="0"/>
+          </a:xfrm>
+          <a:prstGeom xmlns:a="http://schemas.openxmlformats.org/drawingml/2006/main" prst="straightConnector1">
+            <a:avLst/>
+          </a:prstGeom>
+          <a:ln xmlns:a="http://schemas.openxmlformats.org/drawingml/2006/main" w="23813">
+            <a:solidFill>
+              <a:srgbClr val="087A63"/>
+            </a:solidFill>
+            <a:tailEnd type="triangle" w="sm" len="sm"/>
+          </a:ln>
+        </p:spPr>
+      </p:cxnSp>
+      <p:sp>
+        <p:nvSpPr>
+          <p:cNvPr id="57" name="">
+            <a:extLst xmlns:a="http://schemas.openxmlformats.org/drawingml/2006/main">
+              <a:ext uri="{FF2B5EF4-FFF2-40B4-BE49-F238E27FC236}">
+                <a16:creationId xmlns:a16="http://schemas.microsoft.com/office/drawing/2014/main" id="{F3B868FD-EF7F-4FF9-A244-BB131C0F9C6B}"/>
               </a:ext>
             </a:extLst>
           </p:cNvPr>
@@ -12246,8 +11907,1096 @@
         </p:nvSpPr>
         <p:spPr>
           <a:xfrm xmlns:a="http://schemas.openxmlformats.org/drawingml/2006/main">
-            <a:off x="285750" y="9239250"/>
-            <a:ext cx="13620750" cy="361950"/>
+            <a:off x="7981950" y="6600825"/>
+            <a:ext cx="4381500" cy="247650"/>
+          </a:xfrm>
+          <a:prstGeom xmlns:a="http://schemas.openxmlformats.org/drawingml/2006/main" prst="rect">
+            <a:avLst/>
+          </a:prstGeom>
+          <a:solidFill xmlns:a="http://schemas.openxmlformats.org/drawingml/2006/main">
+            <a:srgbClr val="FFFFFF"/>
+          </a:solidFill>
+          <a:ln xmlns:a="http://schemas.openxmlformats.org/drawingml/2006/main" w="0">
+            <a:noFill/>
+          </a:ln>
+        </p:spPr>
+        <p:txBody>
+          <a:bodyPr xmlns:a="http://schemas.openxmlformats.org/drawingml/2006/main" lIns="0" tIns="0" rIns="0" bIns="0"/>
+          <a:lstStyle xmlns:a="http://schemas.openxmlformats.org/drawingml/2006/main">
+            <a:defPPr>
+              <a:defRPr sz="1200" b="1">
+                <a:solidFill>
+                  <a:srgbClr val="087A63"/>
+                </a:solidFill>
+                <a:latin typeface="Arial"/>
+                <a:ea typeface="Arial"/>
+                <a:cs typeface="Arial"/>
+              </a:defRPr>
+            </a:defPPr>
+            <a:lvl1pPr>
+              <a:defRPr sz="1200" b="1">
+                <a:solidFill>
+                  <a:srgbClr val="087A63"/>
+                </a:solidFill>
+                <a:latin typeface="Arial"/>
+                <a:ea typeface="Arial"/>
+                <a:cs typeface="Arial"/>
+              </a:defRPr>
+            </a:lvl1pPr>
+            <a:lvl2pPr>
+              <a:defRPr sz="1200" b="1">
+                <a:solidFill>
+                  <a:srgbClr val="087A63"/>
+                </a:solidFill>
+                <a:latin typeface="Arial"/>
+                <a:ea typeface="Arial"/>
+                <a:cs typeface="Arial"/>
+              </a:defRPr>
+            </a:lvl2pPr>
+            <a:lvl3pPr>
+              <a:defRPr sz="1200" b="1">
+                <a:solidFill>
+                  <a:srgbClr val="087A63"/>
+                </a:solidFill>
+                <a:latin typeface="Arial"/>
+                <a:ea typeface="Arial"/>
+                <a:cs typeface="Arial"/>
+              </a:defRPr>
+            </a:lvl3pPr>
+            <a:lvl4pPr>
+              <a:defRPr sz="1200" b="1">
+                <a:solidFill>
+                  <a:srgbClr val="087A63"/>
+                </a:solidFill>
+                <a:latin typeface="Arial"/>
+                <a:ea typeface="Arial"/>
+                <a:cs typeface="Arial"/>
+              </a:defRPr>
+            </a:lvl4pPr>
+            <a:lvl5pPr>
+              <a:defRPr sz="1200" b="1">
+                <a:solidFill>
+                  <a:srgbClr val="087A63"/>
+                </a:solidFill>
+                <a:latin typeface="Arial"/>
+                <a:ea typeface="Arial"/>
+                <a:cs typeface="Arial"/>
+              </a:defRPr>
+            </a:lvl5pPr>
+            <a:lvl6pPr>
+              <a:defRPr sz="1200" b="1">
+                <a:solidFill>
+                  <a:srgbClr val="087A63"/>
+                </a:solidFill>
+                <a:latin typeface="Arial"/>
+                <a:ea typeface="Arial"/>
+                <a:cs typeface="Arial"/>
+              </a:defRPr>
+            </a:lvl6pPr>
+            <a:lvl7pPr>
+              <a:defRPr sz="1200" b="1">
+                <a:solidFill>
+                  <a:srgbClr val="087A63"/>
+                </a:solidFill>
+                <a:latin typeface="Arial"/>
+                <a:ea typeface="Arial"/>
+                <a:cs typeface="Arial"/>
+              </a:defRPr>
+            </a:lvl7pPr>
+            <a:lvl8pPr>
+              <a:defRPr sz="1200" b="1">
+                <a:solidFill>
+                  <a:srgbClr val="087A63"/>
+                </a:solidFill>
+                <a:latin typeface="Arial"/>
+                <a:ea typeface="Arial"/>
+                <a:cs typeface="Arial"/>
+              </a:defRPr>
+            </a:lvl8pPr>
+            <a:lvl9pPr>
+              <a:defRPr sz="1200" b="1">
+                <a:solidFill>
+                  <a:srgbClr val="087A63"/>
+                </a:solidFill>
+                <a:latin typeface="Arial"/>
+                <a:ea typeface="Arial"/>
+                <a:cs typeface="Arial"/>
+              </a:defRPr>
+            </a:lvl9pPr>
+          </a:lstStyle>
+          <a:p xmlns:a="http://schemas.openxmlformats.org/drawingml/2006/main">
+            <a:pPr>
+              <a:defRPr sz="1200" b="1">
+                <a:solidFill>
+                  <a:srgbClr val="087A63"/>
+                </a:solidFill>
+                <a:latin typeface="Arial"/>
+                <a:ea typeface="Arial"/>
+                <a:cs typeface="Arial"/>
+              </a:defRPr>
+            </a:pPr>
+            <a:r>
+              <a:rPr sz="1200" b="1">
+                <a:solidFill>
+                  <a:srgbClr val="087A63"/>
+                </a:solidFill>
+                <a:latin typeface="Arial"/>
+                <a:ea typeface="Arial"/>
+                <a:cs typeface="Arial"/>
+              </a:rPr>
+              <a:t>5.3  IF.03 same record to display</a:t>
+            </a:r>
+          </a:p>
+        </p:txBody>
+      </p:sp>
+      <p:cxnSp>
+        <p:nvCxnSpPr>
+          <p:cNvPr id="58" name="">
+            <a:extLst xmlns:a="http://schemas.openxmlformats.org/drawingml/2006/main">
+              <a:ext uri="{FF2B5EF4-FFF2-40B4-BE49-F238E27FC236}">
+                <a16:creationId xmlns:a16="http://schemas.microsoft.com/office/drawing/2014/main" id="{3998E6C7-3C6B-4D93-9AA6-AB50158D6A2F}"/>
+              </a:ext>
+            </a:extLst>
+          </p:cNvPr>
+          <p:cNvCxnSpPr/>
+          <p:nvPr/>
+        </p:nvCxnSpPr>
+        <p:spPr>
+          <a:xfrm xmlns:a="http://schemas.openxmlformats.org/drawingml/2006/main">
+            <a:off x="9334500" y="7381875"/>
+            <a:ext cx="1428750" cy="0"/>
+          </a:xfrm>
+          <a:prstGeom xmlns:a="http://schemas.openxmlformats.org/drawingml/2006/main" prst="straightConnector1">
+            <a:avLst/>
+          </a:prstGeom>
+          <a:ln xmlns:a="http://schemas.openxmlformats.org/drawingml/2006/main" w="23813">
+            <a:solidFill>
+              <a:srgbClr val="1259A7"/>
+            </a:solidFill>
+            <a:tailEnd type="triangle" w="sm" len="sm"/>
+          </a:ln>
+        </p:spPr>
+      </p:cxnSp>
+      <p:sp>
+        <p:nvSpPr>
+          <p:cNvPr id="59" name="">
+            <a:extLst xmlns:a="http://schemas.openxmlformats.org/drawingml/2006/main">
+              <a:ext uri="{FF2B5EF4-FFF2-40B4-BE49-F238E27FC236}">
+                <a16:creationId xmlns:a16="http://schemas.microsoft.com/office/drawing/2014/main" id="{0A167298-E1F7-41FC-BF73-AD09B7CE4F77}"/>
+              </a:ext>
+            </a:extLst>
+          </p:cNvPr>
+          <p:cNvSpPr>
+            <a:spLocks xmlns:a="http://schemas.openxmlformats.org/drawingml/2006/main" noGrp="1"/>
+          </p:cNvSpPr>
+          <p:nvPr/>
+        </p:nvSpPr>
+        <p:spPr>
+          <a:xfrm xmlns:a="http://schemas.openxmlformats.org/drawingml/2006/main">
+            <a:off x="9410700" y="7124700"/>
+            <a:ext cx="4000500" cy="247650"/>
+          </a:xfrm>
+          <a:prstGeom xmlns:a="http://schemas.openxmlformats.org/drawingml/2006/main" prst="rect">
+            <a:avLst/>
+          </a:prstGeom>
+          <a:solidFill xmlns:a="http://schemas.openxmlformats.org/drawingml/2006/main">
+            <a:srgbClr val="FFFFFF"/>
+          </a:solidFill>
+          <a:ln xmlns:a="http://schemas.openxmlformats.org/drawingml/2006/main" w="0">
+            <a:noFill/>
+          </a:ln>
+        </p:spPr>
+        <p:txBody>
+          <a:bodyPr xmlns:a="http://schemas.openxmlformats.org/drawingml/2006/main" lIns="0" tIns="0" rIns="0" bIns="0"/>
+          <a:lstStyle xmlns:a="http://schemas.openxmlformats.org/drawingml/2006/main">
+            <a:defPPr>
+              <a:defRPr sz="1200" b="1">
+                <a:solidFill>
+                  <a:srgbClr val="1259A7"/>
+                </a:solidFill>
+                <a:latin typeface="Arial"/>
+                <a:ea typeface="Arial"/>
+                <a:cs typeface="Arial"/>
+              </a:defRPr>
+            </a:defPPr>
+            <a:lvl1pPr>
+              <a:defRPr sz="1200" b="1">
+                <a:solidFill>
+                  <a:srgbClr val="1259A7"/>
+                </a:solidFill>
+                <a:latin typeface="Arial"/>
+                <a:ea typeface="Arial"/>
+                <a:cs typeface="Arial"/>
+              </a:defRPr>
+            </a:lvl1pPr>
+            <a:lvl2pPr>
+              <a:defRPr sz="1200" b="1">
+                <a:solidFill>
+                  <a:srgbClr val="1259A7"/>
+                </a:solidFill>
+                <a:latin typeface="Arial"/>
+                <a:ea typeface="Arial"/>
+                <a:cs typeface="Arial"/>
+              </a:defRPr>
+            </a:lvl2pPr>
+            <a:lvl3pPr>
+              <a:defRPr sz="1200" b="1">
+                <a:solidFill>
+                  <a:srgbClr val="1259A7"/>
+                </a:solidFill>
+                <a:latin typeface="Arial"/>
+                <a:ea typeface="Arial"/>
+                <a:cs typeface="Arial"/>
+              </a:defRPr>
+            </a:lvl3pPr>
+            <a:lvl4pPr>
+              <a:defRPr sz="1200" b="1">
+                <a:solidFill>
+                  <a:srgbClr val="1259A7"/>
+                </a:solidFill>
+                <a:latin typeface="Arial"/>
+                <a:ea typeface="Arial"/>
+                <a:cs typeface="Arial"/>
+              </a:defRPr>
+            </a:lvl4pPr>
+            <a:lvl5pPr>
+              <a:defRPr sz="1200" b="1">
+                <a:solidFill>
+                  <a:srgbClr val="1259A7"/>
+                </a:solidFill>
+                <a:latin typeface="Arial"/>
+                <a:ea typeface="Arial"/>
+                <a:cs typeface="Arial"/>
+              </a:defRPr>
+            </a:lvl5pPr>
+            <a:lvl6pPr>
+              <a:defRPr sz="1200" b="1">
+                <a:solidFill>
+                  <a:srgbClr val="1259A7"/>
+                </a:solidFill>
+                <a:latin typeface="Arial"/>
+                <a:ea typeface="Arial"/>
+                <a:cs typeface="Arial"/>
+              </a:defRPr>
+            </a:lvl6pPr>
+            <a:lvl7pPr>
+              <a:defRPr sz="1200" b="1">
+                <a:solidFill>
+                  <a:srgbClr val="1259A7"/>
+                </a:solidFill>
+                <a:latin typeface="Arial"/>
+                <a:ea typeface="Arial"/>
+                <a:cs typeface="Arial"/>
+              </a:defRPr>
+            </a:lvl7pPr>
+            <a:lvl8pPr>
+              <a:defRPr sz="1200" b="1">
+                <a:solidFill>
+                  <a:srgbClr val="1259A7"/>
+                </a:solidFill>
+                <a:latin typeface="Arial"/>
+                <a:ea typeface="Arial"/>
+                <a:cs typeface="Arial"/>
+              </a:defRPr>
+            </a:lvl8pPr>
+            <a:lvl9pPr>
+              <a:defRPr sz="1200" b="1">
+                <a:solidFill>
+                  <a:srgbClr val="1259A7"/>
+                </a:solidFill>
+                <a:latin typeface="Arial"/>
+                <a:ea typeface="Arial"/>
+                <a:cs typeface="Arial"/>
+              </a:defRPr>
+            </a:lvl9pPr>
+          </a:lstStyle>
+          <a:p xmlns:a="http://schemas.openxmlformats.org/drawingml/2006/main">
+            <a:pPr>
+              <a:defRPr sz="1200" b="1">
+                <a:solidFill>
+                  <a:srgbClr val="1259A7"/>
+                </a:solidFill>
+                <a:latin typeface="Arial"/>
+                <a:ea typeface="Arial"/>
+                <a:cs typeface="Arial"/>
+              </a:defRPr>
+            </a:pPr>
+            <a:r>
+              <a:rPr sz="1200" b="1">
+                <a:solidFill>
+                  <a:srgbClr val="1259A7"/>
+                </a:solidFill>
+                <a:latin typeface="Arial"/>
+                <a:ea typeface="Arial"/>
+                <a:cs typeface="Arial"/>
+              </a:rPr>
+              <a:t>6  IO.05 score-evidence package</a:t>
+            </a:r>
+          </a:p>
+        </p:txBody>
+      </p:sp>
+      <p:cxnSp>
+        <p:nvCxnSpPr>
+          <p:cNvPr id="60" name="">
+            <a:extLst xmlns:a="http://schemas.openxmlformats.org/drawingml/2006/main">
+              <a:ext uri="{FF2B5EF4-FFF2-40B4-BE49-F238E27FC236}">
+                <a16:creationId xmlns:a16="http://schemas.microsoft.com/office/drawing/2014/main" id="{44419BEC-9CB1-45DC-BBB1-E4AF82855687}"/>
+              </a:ext>
+            </a:extLst>
+          </p:cNvPr>
+          <p:cNvCxnSpPr/>
+          <p:nvPr/>
+        </p:nvCxnSpPr>
+        <p:spPr>
+          <a:xfrm xmlns:a="http://schemas.openxmlformats.org/drawingml/2006/main">
+            <a:off x="9334500" y="7905750"/>
+            <a:ext cx="1428750" cy="0"/>
+          </a:xfrm>
+          <a:prstGeom xmlns:a="http://schemas.openxmlformats.org/drawingml/2006/main" prst="straightConnector1">
+            <a:avLst/>
+          </a:prstGeom>
+          <a:ln xmlns:a="http://schemas.openxmlformats.org/drawingml/2006/main" w="23813">
+            <a:solidFill>
+              <a:srgbClr val="1259A7"/>
+            </a:solidFill>
+            <a:headEnd type="triangle" w="sm" len="sm"/>
+          </a:ln>
+        </p:spPr>
+      </p:cxnSp>
+      <p:sp>
+        <p:nvSpPr>
+          <p:cNvPr id="61" name="">
+            <a:extLst xmlns:a="http://schemas.openxmlformats.org/drawingml/2006/main">
+              <a:ext uri="{FF2B5EF4-FFF2-40B4-BE49-F238E27FC236}">
+                <a16:creationId xmlns:a16="http://schemas.microsoft.com/office/drawing/2014/main" id="{A353A696-E0D0-4D90-B6BE-A581A8D88027}"/>
+              </a:ext>
+            </a:extLst>
+          </p:cNvPr>
+          <p:cNvSpPr>
+            <a:spLocks xmlns:a="http://schemas.openxmlformats.org/drawingml/2006/main" noGrp="1"/>
+          </p:cNvSpPr>
+          <p:nvPr/>
+        </p:nvSpPr>
+        <p:spPr>
+          <a:xfrm xmlns:a="http://schemas.openxmlformats.org/drawingml/2006/main">
+            <a:off x="9410700" y="7648575"/>
+            <a:ext cx="4000500" cy="247650"/>
+          </a:xfrm>
+          <a:prstGeom xmlns:a="http://schemas.openxmlformats.org/drawingml/2006/main" prst="rect">
+            <a:avLst/>
+          </a:prstGeom>
+          <a:solidFill xmlns:a="http://schemas.openxmlformats.org/drawingml/2006/main">
+            <a:srgbClr val="FFFFFF"/>
+          </a:solidFill>
+          <a:ln xmlns:a="http://schemas.openxmlformats.org/drawingml/2006/main" w="0">
+            <a:noFill/>
+          </a:ln>
+        </p:spPr>
+        <p:txBody>
+          <a:bodyPr xmlns:a="http://schemas.openxmlformats.org/drawingml/2006/main" lIns="0" tIns="0" rIns="0" bIns="0"/>
+          <a:lstStyle xmlns:a="http://schemas.openxmlformats.org/drawingml/2006/main">
+            <a:defPPr>
+              <a:defRPr sz="1200" b="1">
+                <a:solidFill>
+                  <a:srgbClr val="1259A7"/>
+                </a:solidFill>
+                <a:latin typeface="Arial"/>
+                <a:ea typeface="Arial"/>
+                <a:cs typeface="Arial"/>
+              </a:defRPr>
+            </a:defPPr>
+            <a:lvl1pPr>
+              <a:defRPr sz="1200" b="1">
+                <a:solidFill>
+                  <a:srgbClr val="1259A7"/>
+                </a:solidFill>
+                <a:latin typeface="Arial"/>
+                <a:ea typeface="Arial"/>
+                <a:cs typeface="Arial"/>
+              </a:defRPr>
+            </a:lvl1pPr>
+            <a:lvl2pPr>
+              <a:defRPr sz="1200" b="1">
+                <a:solidFill>
+                  <a:srgbClr val="1259A7"/>
+                </a:solidFill>
+                <a:latin typeface="Arial"/>
+                <a:ea typeface="Arial"/>
+                <a:cs typeface="Arial"/>
+              </a:defRPr>
+            </a:lvl2pPr>
+            <a:lvl3pPr>
+              <a:defRPr sz="1200" b="1">
+                <a:solidFill>
+                  <a:srgbClr val="1259A7"/>
+                </a:solidFill>
+                <a:latin typeface="Arial"/>
+                <a:ea typeface="Arial"/>
+                <a:cs typeface="Arial"/>
+              </a:defRPr>
+            </a:lvl3pPr>
+            <a:lvl4pPr>
+              <a:defRPr sz="1200" b="1">
+                <a:solidFill>
+                  <a:srgbClr val="1259A7"/>
+                </a:solidFill>
+                <a:latin typeface="Arial"/>
+                <a:ea typeface="Arial"/>
+                <a:cs typeface="Arial"/>
+              </a:defRPr>
+            </a:lvl4pPr>
+            <a:lvl5pPr>
+              <a:defRPr sz="1200" b="1">
+                <a:solidFill>
+                  <a:srgbClr val="1259A7"/>
+                </a:solidFill>
+                <a:latin typeface="Arial"/>
+                <a:ea typeface="Arial"/>
+                <a:cs typeface="Arial"/>
+              </a:defRPr>
+            </a:lvl5pPr>
+            <a:lvl6pPr>
+              <a:defRPr sz="1200" b="1">
+                <a:solidFill>
+                  <a:srgbClr val="1259A7"/>
+                </a:solidFill>
+                <a:latin typeface="Arial"/>
+                <a:ea typeface="Arial"/>
+                <a:cs typeface="Arial"/>
+              </a:defRPr>
+            </a:lvl6pPr>
+            <a:lvl7pPr>
+              <a:defRPr sz="1200" b="1">
+                <a:solidFill>
+                  <a:srgbClr val="1259A7"/>
+                </a:solidFill>
+                <a:latin typeface="Arial"/>
+                <a:ea typeface="Arial"/>
+                <a:cs typeface="Arial"/>
+              </a:defRPr>
+            </a:lvl7pPr>
+            <a:lvl8pPr>
+              <a:defRPr sz="1200" b="1">
+                <a:solidFill>
+                  <a:srgbClr val="1259A7"/>
+                </a:solidFill>
+                <a:latin typeface="Arial"/>
+                <a:ea typeface="Arial"/>
+                <a:cs typeface="Arial"/>
+              </a:defRPr>
+            </a:lvl8pPr>
+            <a:lvl9pPr>
+              <a:defRPr sz="1200" b="1">
+                <a:solidFill>
+                  <a:srgbClr val="1259A7"/>
+                </a:solidFill>
+                <a:latin typeface="Arial"/>
+                <a:ea typeface="Arial"/>
+                <a:cs typeface="Arial"/>
+              </a:defRPr>
+            </a:lvl9pPr>
+          </a:lstStyle>
+          <a:p xmlns:a="http://schemas.openxmlformats.org/drawingml/2006/main">
+            <a:pPr>
+              <a:defRPr sz="1200" b="1">
+                <a:solidFill>
+                  <a:srgbClr val="1259A7"/>
+                </a:solidFill>
+                <a:latin typeface="Arial"/>
+                <a:ea typeface="Arial"/>
+                <a:cs typeface="Arial"/>
+              </a:defRPr>
+            </a:pPr>
+            <a:r>
+              <a:rPr sz="1200" b="1">
+                <a:solidFill>
+                  <a:srgbClr val="1259A7"/>
+                </a:solidFill>
+                <a:latin typeface="Arial"/>
+                <a:ea typeface="Arial"/>
+                <a:cs typeface="Arial"/>
+              </a:rPr>
+              <a:t>7  IO.09 AI explanation</a:t>
+            </a:r>
+          </a:p>
+        </p:txBody>
+      </p:sp>
+      <p:cxnSp>
+        <p:nvCxnSpPr>
+          <p:cNvPr id="62" name="">
+            <a:extLst xmlns:a="http://schemas.openxmlformats.org/drawingml/2006/main">
+              <a:ext uri="{FF2B5EF4-FFF2-40B4-BE49-F238E27FC236}">
+                <a16:creationId xmlns:a16="http://schemas.microsoft.com/office/drawing/2014/main" id="{F5CAC4DA-384A-4943-B4C7-D44319DD7A16}"/>
+              </a:ext>
+            </a:extLst>
+          </p:cNvPr>
+          <p:cNvCxnSpPr/>
+          <p:nvPr/>
+        </p:nvCxnSpPr>
+        <p:spPr>
+          <a:xfrm xmlns:a="http://schemas.openxmlformats.org/drawingml/2006/main">
+            <a:off x="9334500" y="8429625"/>
+            <a:ext cx="3048000" cy="0"/>
+          </a:xfrm>
+          <a:prstGeom xmlns:a="http://schemas.openxmlformats.org/drawingml/2006/main" prst="straightConnector1">
+            <a:avLst/>
+          </a:prstGeom>
+          <a:ln xmlns:a="http://schemas.openxmlformats.org/drawingml/2006/main" w="23813">
+            <a:solidFill>
+              <a:srgbClr val="087A63"/>
+            </a:solidFill>
+            <a:tailEnd type="triangle" w="sm" len="sm"/>
+          </a:ln>
+        </p:spPr>
+      </p:cxnSp>
+      <p:sp>
+        <p:nvSpPr>
+          <p:cNvPr id="63" name="">
+            <a:extLst xmlns:a="http://schemas.openxmlformats.org/drawingml/2006/main">
+              <a:ext uri="{FF2B5EF4-FFF2-40B4-BE49-F238E27FC236}">
+                <a16:creationId xmlns:a16="http://schemas.microsoft.com/office/drawing/2014/main" id="{40CD56DA-7678-4281-BB6B-CDA418BB0F54}"/>
+              </a:ext>
+            </a:extLst>
+          </p:cNvPr>
+          <p:cNvSpPr>
+            <a:spLocks xmlns:a="http://schemas.openxmlformats.org/drawingml/2006/main" noGrp="1"/>
+          </p:cNvSpPr>
+          <p:nvPr/>
+        </p:nvSpPr>
+        <p:spPr>
+          <a:xfrm xmlns:a="http://schemas.openxmlformats.org/drawingml/2006/main">
+            <a:off x="9410700" y="8172450"/>
+            <a:ext cx="4000500" cy="247650"/>
+          </a:xfrm>
+          <a:prstGeom xmlns:a="http://schemas.openxmlformats.org/drawingml/2006/main" prst="rect">
+            <a:avLst/>
+          </a:prstGeom>
+          <a:solidFill xmlns:a="http://schemas.openxmlformats.org/drawingml/2006/main">
+            <a:srgbClr val="FFFFFF"/>
+          </a:solidFill>
+          <a:ln xmlns:a="http://schemas.openxmlformats.org/drawingml/2006/main" w="0">
+            <a:noFill/>
+          </a:ln>
+        </p:spPr>
+        <p:txBody>
+          <a:bodyPr xmlns:a="http://schemas.openxmlformats.org/drawingml/2006/main" lIns="0" tIns="0" rIns="0" bIns="0"/>
+          <a:lstStyle xmlns:a="http://schemas.openxmlformats.org/drawingml/2006/main">
+            <a:defPPr>
+              <a:defRPr sz="1200" b="1">
+                <a:solidFill>
+                  <a:srgbClr val="087A63"/>
+                </a:solidFill>
+                <a:latin typeface="Arial"/>
+                <a:ea typeface="Arial"/>
+                <a:cs typeface="Arial"/>
+              </a:defRPr>
+            </a:defPPr>
+            <a:lvl1pPr>
+              <a:defRPr sz="1200" b="1">
+                <a:solidFill>
+                  <a:srgbClr val="087A63"/>
+                </a:solidFill>
+                <a:latin typeface="Arial"/>
+                <a:ea typeface="Arial"/>
+                <a:cs typeface="Arial"/>
+              </a:defRPr>
+            </a:lvl1pPr>
+            <a:lvl2pPr>
+              <a:defRPr sz="1200" b="1">
+                <a:solidFill>
+                  <a:srgbClr val="087A63"/>
+                </a:solidFill>
+                <a:latin typeface="Arial"/>
+                <a:ea typeface="Arial"/>
+                <a:cs typeface="Arial"/>
+              </a:defRPr>
+            </a:lvl2pPr>
+            <a:lvl3pPr>
+              <a:defRPr sz="1200" b="1">
+                <a:solidFill>
+                  <a:srgbClr val="087A63"/>
+                </a:solidFill>
+                <a:latin typeface="Arial"/>
+                <a:ea typeface="Arial"/>
+                <a:cs typeface="Arial"/>
+              </a:defRPr>
+            </a:lvl3pPr>
+            <a:lvl4pPr>
+              <a:defRPr sz="1200" b="1">
+                <a:solidFill>
+                  <a:srgbClr val="087A63"/>
+                </a:solidFill>
+                <a:latin typeface="Arial"/>
+                <a:ea typeface="Arial"/>
+                <a:cs typeface="Arial"/>
+              </a:defRPr>
+            </a:lvl4pPr>
+            <a:lvl5pPr>
+              <a:defRPr sz="1200" b="1">
+                <a:solidFill>
+                  <a:srgbClr val="087A63"/>
+                </a:solidFill>
+                <a:latin typeface="Arial"/>
+                <a:ea typeface="Arial"/>
+                <a:cs typeface="Arial"/>
+              </a:defRPr>
+            </a:lvl5pPr>
+            <a:lvl6pPr>
+              <a:defRPr sz="1200" b="1">
+                <a:solidFill>
+                  <a:srgbClr val="087A63"/>
+                </a:solidFill>
+                <a:latin typeface="Arial"/>
+                <a:ea typeface="Arial"/>
+                <a:cs typeface="Arial"/>
+              </a:defRPr>
+            </a:lvl6pPr>
+            <a:lvl7pPr>
+              <a:defRPr sz="1200" b="1">
+                <a:solidFill>
+                  <a:srgbClr val="087A63"/>
+                </a:solidFill>
+                <a:latin typeface="Arial"/>
+                <a:ea typeface="Arial"/>
+                <a:cs typeface="Arial"/>
+              </a:defRPr>
+            </a:lvl7pPr>
+            <a:lvl8pPr>
+              <a:defRPr sz="1200" b="1">
+                <a:solidFill>
+                  <a:srgbClr val="087A63"/>
+                </a:solidFill>
+                <a:latin typeface="Arial"/>
+                <a:ea typeface="Arial"/>
+                <a:cs typeface="Arial"/>
+              </a:defRPr>
+            </a:lvl8pPr>
+            <a:lvl9pPr>
+              <a:defRPr sz="1200" b="1">
+                <a:solidFill>
+                  <a:srgbClr val="087A63"/>
+                </a:solidFill>
+                <a:latin typeface="Arial"/>
+                <a:ea typeface="Arial"/>
+                <a:cs typeface="Arial"/>
+              </a:defRPr>
+            </a:lvl9pPr>
+          </a:lstStyle>
+          <a:p xmlns:a="http://schemas.openxmlformats.org/drawingml/2006/main">
+            <a:pPr>
+              <a:defRPr sz="1200" b="1">
+                <a:solidFill>
+                  <a:srgbClr val="087A63"/>
+                </a:solidFill>
+                <a:latin typeface="Arial"/>
+                <a:ea typeface="Arial"/>
+                <a:cs typeface="Arial"/>
+              </a:defRPr>
+            </a:pPr>
+            <a:r>
+              <a:rPr sz="1200" b="1">
+                <a:solidFill>
+                  <a:srgbClr val="087A63"/>
+                </a:solidFill>
+                <a:latin typeface="Arial"/>
+                <a:ea typeface="Arial"/>
+                <a:cs typeface="Arial"/>
+              </a:rPr>
+              <a:t>7.1  IF.04 checked explanation / availability</a:t>
+            </a:r>
+          </a:p>
+        </p:txBody>
+      </p:sp>
+      <p:cxnSp>
+        <p:nvCxnSpPr>
+          <p:cNvPr id="64" name="">
+            <a:extLst xmlns:a="http://schemas.openxmlformats.org/drawingml/2006/main">
+              <a:ext uri="{FF2B5EF4-FFF2-40B4-BE49-F238E27FC236}">
+                <a16:creationId xmlns:a16="http://schemas.microsoft.com/office/drawing/2014/main" id="{95444881-6067-4CAA-BF1D-D4FA7D903FED}"/>
+              </a:ext>
+            </a:extLst>
+          </p:cNvPr>
+          <p:cNvCxnSpPr/>
+          <p:nvPr/>
+        </p:nvCxnSpPr>
+        <p:spPr>
+          <a:xfrm xmlns:a="http://schemas.openxmlformats.org/drawingml/2006/main">
+            <a:off x="762000" y="8953500"/>
+            <a:ext cx="11620500" cy="0"/>
+          </a:xfrm>
+          <a:prstGeom xmlns:a="http://schemas.openxmlformats.org/drawingml/2006/main" prst="straightConnector1">
+            <a:avLst/>
+          </a:prstGeom>
+          <a:ln xmlns:a="http://schemas.openxmlformats.org/drawingml/2006/main" w="23813">
+            <a:solidFill>
+              <a:srgbClr val="1259A7"/>
+            </a:solidFill>
+            <a:headEnd type="triangle" w="sm" len="sm"/>
+          </a:ln>
+        </p:spPr>
+      </p:cxnSp>
+      <p:sp>
+        <p:nvSpPr>
+          <p:cNvPr id="65" name="">
+            <a:extLst xmlns:a="http://schemas.openxmlformats.org/drawingml/2006/main">
+              <a:ext uri="{FF2B5EF4-FFF2-40B4-BE49-F238E27FC236}">
+                <a16:creationId xmlns:a16="http://schemas.microsoft.com/office/drawing/2014/main" id="{1CD449CC-A286-4B75-9D86-15BFCD42A56E}"/>
+              </a:ext>
+            </a:extLst>
+          </p:cNvPr>
+          <p:cNvSpPr>
+            <a:spLocks xmlns:a="http://schemas.openxmlformats.org/drawingml/2006/main" noGrp="1"/>
+          </p:cNvSpPr>
+          <p:nvPr/>
+        </p:nvSpPr>
+        <p:spPr>
+          <a:xfrm xmlns:a="http://schemas.openxmlformats.org/drawingml/2006/main">
+            <a:off x="838200" y="8696325"/>
+            <a:ext cx="11525250" cy="247650"/>
+          </a:xfrm>
+          <a:prstGeom xmlns:a="http://schemas.openxmlformats.org/drawingml/2006/main" prst="rect">
+            <a:avLst/>
+          </a:prstGeom>
+          <a:solidFill xmlns:a="http://schemas.openxmlformats.org/drawingml/2006/main">
+            <a:srgbClr val="FFFFFF"/>
+          </a:solidFill>
+          <a:ln xmlns:a="http://schemas.openxmlformats.org/drawingml/2006/main" w="0">
+            <a:noFill/>
+          </a:ln>
+        </p:spPr>
+        <p:txBody>
+          <a:bodyPr xmlns:a="http://schemas.openxmlformats.org/drawingml/2006/main" lIns="0" tIns="0" rIns="0" bIns="0"/>
+          <a:lstStyle xmlns:a="http://schemas.openxmlformats.org/drawingml/2006/main">
+            <a:defPPr>
+              <a:defRPr sz="1200" b="1">
+                <a:solidFill>
+                  <a:srgbClr val="1259A7"/>
+                </a:solidFill>
+                <a:latin typeface="Arial"/>
+                <a:ea typeface="Arial"/>
+                <a:cs typeface="Arial"/>
+              </a:defRPr>
+            </a:defPPr>
+            <a:lvl1pPr>
+              <a:defRPr sz="1200" b="1">
+                <a:solidFill>
+                  <a:srgbClr val="1259A7"/>
+                </a:solidFill>
+                <a:latin typeface="Arial"/>
+                <a:ea typeface="Arial"/>
+                <a:cs typeface="Arial"/>
+              </a:defRPr>
+            </a:lvl1pPr>
+            <a:lvl2pPr>
+              <a:defRPr sz="1200" b="1">
+                <a:solidFill>
+                  <a:srgbClr val="1259A7"/>
+                </a:solidFill>
+                <a:latin typeface="Arial"/>
+                <a:ea typeface="Arial"/>
+                <a:cs typeface="Arial"/>
+              </a:defRPr>
+            </a:lvl2pPr>
+            <a:lvl3pPr>
+              <a:defRPr sz="1200" b="1">
+                <a:solidFill>
+                  <a:srgbClr val="1259A7"/>
+                </a:solidFill>
+                <a:latin typeface="Arial"/>
+                <a:ea typeface="Arial"/>
+                <a:cs typeface="Arial"/>
+              </a:defRPr>
+            </a:lvl3pPr>
+            <a:lvl4pPr>
+              <a:defRPr sz="1200" b="1">
+                <a:solidFill>
+                  <a:srgbClr val="1259A7"/>
+                </a:solidFill>
+                <a:latin typeface="Arial"/>
+                <a:ea typeface="Arial"/>
+                <a:cs typeface="Arial"/>
+              </a:defRPr>
+            </a:lvl4pPr>
+            <a:lvl5pPr>
+              <a:defRPr sz="1200" b="1">
+                <a:solidFill>
+                  <a:srgbClr val="1259A7"/>
+                </a:solidFill>
+                <a:latin typeface="Arial"/>
+                <a:ea typeface="Arial"/>
+                <a:cs typeface="Arial"/>
+              </a:defRPr>
+            </a:lvl5pPr>
+            <a:lvl6pPr>
+              <a:defRPr sz="1200" b="1">
+                <a:solidFill>
+                  <a:srgbClr val="1259A7"/>
+                </a:solidFill>
+                <a:latin typeface="Arial"/>
+                <a:ea typeface="Arial"/>
+                <a:cs typeface="Arial"/>
+              </a:defRPr>
+            </a:lvl6pPr>
+            <a:lvl7pPr>
+              <a:defRPr sz="1200" b="1">
+                <a:solidFill>
+                  <a:srgbClr val="1259A7"/>
+                </a:solidFill>
+                <a:latin typeface="Arial"/>
+                <a:ea typeface="Arial"/>
+                <a:cs typeface="Arial"/>
+              </a:defRPr>
+            </a:lvl7pPr>
+            <a:lvl8pPr>
+              <a:defRPr sz="1200" b="1">
+                <a:solidFill>
+                  <a:srgbClr val="1259A7"/>
+                </a:solidFill>
+                <a:latin typeface="Arial"/>
+                <a:ea typeface="Arial"/>
+                <a:cs typeface="Arial"/>
+              </a:defRPr>
+            </a:lvl8pPr>
+            <a:lvl9pPr>
+              <a:defRPr sz="1200" b="1">
+                <a:solidFill>
+                  <a:srgbClr val="1259A7"/>
+                </a:solidFill>
+                <a:latin typeface="Arial"/>
+                <a:ea typeface="Arial"/>
+                <a:cs typeface="Arial"/>
+              </a:defRPr>
+            </a:lvl9pPr>
+          </a:lstStyle>
+          <a:p xmlns:a="http://schemas.openxmlformats.org/drawingml/2006/main">
+            <a:pPr>
+              <a:defRPr sz="1200" b="1">
+                <a:solidFill>
+                  <a:srgbClr val="1259A7"/>
+                </a:solidFill>
+                <a:latin typeface="Arial"/>
+                <a:ea typeface="Arial"/>
+                <a:cs typeface="Arial"/>
+              </a:defRPr>
+            </a:pPr>
+            <a:r>
+              <a:rPr sz="1200" b="1">
+                <a:solidFill>
+                  <a:srgbClr val="1259A7"/>
+                </a:solidFill>
+                <a:latin typeface="Arial"/>
+                <a:ea typeface="Arial"/>
+                <a:cs typeface="Arial"/>
+              </a:rPr>
+              <a:t>8  IO.02 comparison and evidence</a:t>
+            </a:r>
+          </a:p>
+        </p:txBody>
+      </p:sp>
+      <p:cxnSp>
+        <p:nvCxnSpPr>
+          <p:cNvPr id="66" name="">
+            <a:extLst xmlns:a="http://schemas.openxmlformats.org/drawingml/2006/main">
+              <a:ext uri="{FF2B5EF4-FFF2-40B4-BE49-F238E27FC236}">
+                <a16:creationId xmlns:a16="http://schemas.microsoft.com/office/drawing/2014/main" id="{1318355E-C9FA-42D4-B9D9-BE65CD9585C6}"/>
+              </a:ext>
+            </a:extLst>
+          </p:cNvPr>
+          <p:cNvCxnSpPr/>
+          <p:nvPr/>
+        </p:nvCxnSpPr>
+        <p:spPr>
+          <a:xfrm xmlns:a="http://schemas.openxmlformats.org/drawingml/2006/main">
+            <a:off x="12382500" y="9448800"/>
+            <a:ext cx="1238250" cy="0"/>
+          </a:xfrm>
+          <a:prstGeom xmlns:a="http://schemas.openxmlformats.org/drawingml/2006/main" prst="straightConnector1">
+            <a:avLst/>
+          </a:prstGeom>
+          <a:ln xmlns:a="http://schemas.openxmlformats.org/drawingml/2006/main" w="23813">
+            <a:solidFill>
+              <a:srgbClr val="586471"/>
+            </a:solidFill>
+            <a:tailEnd type="triangle" w="sm" len="sm"/>
+          </a:ln>
+        </p:spPr>
+      </p:cxnSp>
+      <p:sp>
+        <p:nvSpPr>
+          <p:cNvPr id="67" name="">
+            <a:extLst xmlns:a="http://schemas.openxmlformats.org/drawingml/2006/main">
+              <a:ext uri="{FF2B5EF4-FFF2-40B4-BE49-F238E27FC236}">
+                <a16:creationId xmlns:a16="http://schemas.microsoft.com/office/drawing/2014/main" id="{7D2CDA9C-8CE5-40FD-9C0C-B68E39EF4584}"/>
+              </a:ext>
+            </a:extLst>
+          </p:cNvPr>
+          <p:cNvSpPr>
+            <a:spLocks xmlns:a="http://schemas.openxmlformats.org/drawingml/2006/main" noGrp="1"/>
+          </p:cNvSpPr>
+          <p:nvPr/>
+        </p:nvSpPr>
+        <p:spPr>
+          <a:xfrm xmlns:a="http://schemas.openxmlformats.org/drawingml/2006/main">
+            <a:off x="10239375" y="9172575"/>
+            <a:ext cx="3762375" cy="257175"/>
+          </a:xfrm>
+          <a:prstGeom xmlns:a="http://schemas.openxmlformats.org/drawingml/2006/main" prst="rect">
+            <a:avLst/>
+          </a:prstGeom>
+          <a:solidFill xmlns:a="http://schemas.openxmlformats.org/drawingml/2006/main">
+            <a:srgbClr val="FFFFFF"/>
+          </a:solidFill>
+          <a:ln xmlns:a="http://schemas.openxmlformats.org/drawingml/2006/main" w="0">
+            <a:noFill/>
+          </a:ln>
+        </p:spPr>
+        <p:txBody>
+          <a:bodyPr xmlns:a="http://schemas.openxmlformats.org/drawingml/2006/main" lIns="0" tIns="0" rIns="0" bIns="0"/>
+          <a:lstStyle xmlns:a="http://schemas.openxmlformats.org/drawingml/2006/main">
+            <a:defPPr>
+              <a:defRPr sz="1200" b="1">
+                <a:solidFill>
+                  <a:srgbClr val="586471"/>
+                </a:solidFill>
+                <a:latin typeface="Arial"/>
+                <a:ea typeface="Arial"/>
+                <a:cs typeface="Arial"/>
+              </a:defRPr>
+            </a:defPPr>
+            <a:lvl1pPr>
+              <a:defRPr sz="1200" b="1">
+                <a:solidFill>
+                  <a:srgbClr val="586471"/>
+                </a:solidFill>
+                <a:latin typeface="Arial"/>
+                <a:ea typeface="Arial"/>
+                <a:cs typeface="Arial"/>
+              </a:defRPr>
+            </a:lvl1pPr>
+            <a:lvl2pPr>
+              <a:defRPr sz="1200" b="1">
+                <a:solidFill>
+                  <a:srgbClr val="586471"/>
+                </a:solidFill>
+                <a:latin typeface="Arial"/>
+                <a:ea typeface="Arial"/>
+                <a:cs typeface="Arial"/>
+              </a:defRPr>
+            </a:lvl2pPr>
+            <a:lvl3pPr>
+              <a:defRPr sz="1200" b="1">
+                <a:solidFill>
+                  <a:srgbClr val="586471"/>
+                </a:solidFill>
+                <a:latin typeface="Arial"/>
+                <a:ea typeface="Arial"/>
+                <a:cs typeface="Arial"/>
+              </a:defRPr>
+            </a:lvl3pPr>
+            <a:lvl4pPr>
+              <a:defRPr sz="1200" b="1">
+                <a:solidFill>
+                  <a:srgbClr val="586471"/>
+                </a:solidFill>
+                <a:latin typeface="Arial"/>
+                <a:ea typeface="Arial"/>
+                <a:cs typeface="Arial"/>
+              </a:defRPr>
+            </a:lvl4pPr>
+            <a:lvl5pPr>
+              <a:defRPr sz="1200" b="1">
+                <a:solidFill>
+                  <a:srgbClr val="586471"/>
+                </a:solidFill>
+                <a:latin typeface="Arial"/>
+                <a:ea typeface="Arial"/>
+                <a:cs typeface="Arial"/>
+              </a:defRPr>
+            </a:lvl5pPr>
+            <a:lvl6pPr>
+              <a:defRPr sz="1200" b="1">
+                <a:solidFill>
+                  <a:srgbClr val="586471"/>
+                </a:solidFill>
+                <a:latin typeface="Arial"/>
+                <a:ea typeface="Arial"/>
+                <a:cs typeface="Arial"/>
+              </a:defRPr>
+            </a:lvl6pPr>
+            <a:lvl7pPr>
+              <a:defRPr sz="1200" b="1">
+                <a:solidFill>
+                  <a:srgbClr val="586471"/>
+                </a:solidFill>
+                <a:latin typeface="Arial"/>
+                <a:ea typeface="Arial"/>
+                <a:cs typeface="Arial"/>
+              </a:defRPr>
+            </a:lvl7pPr>
+            <a:lvl8pPr>
+              <a:defRPr sz="1200" b="1">
+                <a:solidFill>
+                  <a:srgbClr val="586471"/>
+                </a:solidFill>
+                <a:latin typeface="Arial"/>
+                <a:ea typeface="Arial"/>
+                <a:cs typeface="Arial"/>
+              </a:defRPr>
+            </a:lvl8pPr>
+            <a:lvl9pPr>
+              <a:defRPr sz="1200" b="1">
+                <a:solidFill>
+                  <a:srgbClr val="586471"/>
+                </a:solidFill>
+                <a:latin typeface="Arial"/>
+                <a:ea typeface="Arial"/>
+                <a:cs typeface="Arial"/>
+              </a:defRPr>
+            </a:lvl9pPr>
+          </a:lstStyle>
+          <a:p xmlns:a="http://schemas.openxmlformats.org/drawingml/2006/main">
+            <a:pPr>
+              <a:defRPr sz="1200" b="1">
+                <a:solidFill>
+                  <a:srgbClr val="586471"/>
+                </a:solidFill>
+                <a:latin typeface="Arial"/>
+                <a:ea typeface="Arial"/>
+                <a:cs typeface="Arial"/>
+              </a:defRPr>
+            </a:pPr>
+            <a:r>
+              <a:rPr sz="1200" b="1">
+                <a:solidFill>
+                  <a:srgbClr val="586471"/>
+                </a:solidFill>
+                <a:latin typeface="Arial"/>
+                <a:ea typeface="Arial"/>
+                <a:cs typeface="Arial"/>
+              </a:rPr>
+              <a:t>9  IO.06 Service status</a:t>
+            </a:r>
+          </a:p>
+        </p:txBody>
+      </p:sp>
+      <p:sp>
+        <p:nvSpPr>
+          <p:cNvPr id="68" name="">
+            <a:extLst xmlns:a="http://schemas.openxmlformats.org/drawingml/2006/main">
+              <a:ext uri="{FF2B5EF4-FFF2-40B4-BE49-F238E27FC236}">
+                <a16:creationId xmlns:a16="http://schemas.microsoft.com/office/drawing/2014/main" id="{225DC41F-2A09-4892-ABA5-F73FA7580EB6}"/>
+              </a:ext>
+            </a:extLst>
+          </p:cNvPr>
+          <p:cNvSpPr>
+            <a:spLocks xmlns:a="http://schemas.openxmlformats.org/drawingml/2006/main" noGrp="1"/>
+          </p:cNvSpPr>
+          <p:nvPr/>
+        </p:nvSpPr>
+        <p:spPr>
+          <a:xfrm xmlns:a="http://schemas.openxmlformats.org/drawingml/2006/main">
+            <a:off x="285750" y="9810750"/>
+            <a:ext cx="13620750" cy="285750"/>
           </a:xfrm>
           <a:prstGeom xmlns:a="http://schemas.openxmlformats.org/drawingml/2006/main" prst="rect">
             <a:avLst/>
@@ -12388,10 +13137,10 @@
       </p:sp>
       <p:sp>
         <p:nvSpPr>
-          <p:cNvPr id="57" name="">
+          <p:cNvPr id="69" name="">
             <a:extLst xmlns:a="http://schemas.openxmlformats.org/drawingml/2006/main">
               <a:ext uri="{FF2B5EF4-FFF2-40B4-BE49-F238E27FC236}">
-                <a16:creationId xmlns:a16="http://schemas.microsoft.com/office/drawing/2014/main" id="{E21FCFE6-0163-47ED-B597-872019C31B29}"/>
+                <a16:creationId xmlns:a16="http://schemas.microsoft.com/office/drawing/2014/main" id="{B3D3A09B-B91D-4005-9F89-9B7C5696650C}"/>
               </a:ext>
             </a:extLst>
           </p:cNvPr>
@@ -12402,8 +13151,8 @@
         </p:nvSpPr>
         <p:spPr>
           <a:xfrm xmlns:a="http://schemas.openxmlformats.org/drawingml/2006/main">
-            <a:off x="285750" y="9715500"/>
-            <a:ext cx="13620750" cy="333375"/>
+            <a:off x="285750" y="10191750"/>
+            <a:ext cx="13620750" cy="238125"/>
           </a:xfrm>
           <a:prstGeom xmlns:a="http://schemas.openxmlformats.org/drawingml/2006/main" prst="rect">
             <a:avLst/>
@@ -12417,7 +13166,7 @@
           <a:bodyPr xmlns:a="http://schemas.openxmlformats.org/drawingml/2006/main" lIns="0" tIns="0" rIns="0" bIns="0"/>
           <a:lstStyle xmlns:a="http://schemas.openxmlformats.org/drawingml/2006/main">
             <a:defPPr>
-              <a:defRPr sz="1275" b="0">
+              <a:defRPr sz="1200" b="0">
                 <a:solidFill>
                   <a:srgbClr val="586471"/>
                 </a:solidFill>
@@ -12427,7 +13176,7 @@
               </a:defRPr>
             </a:defPPr>
             <a:lvl1pPr>
-              <a:defRPr sz="1275" b="0">
+              <a:defRPr sz="1200" b="0">
                 <a:solidFill>
                   <a:srgbClr val="586471"/>
                 </a:solidFill>
@@ -12437,7 +13186,7 @@
               </a:defRPr>
             </a:lvl1pPr>
             <a:lvl2pPr>
-              <a:defRPr sz="1275" b="0">
+              <a:defRPr sz="1200" b="0">
                 <a:solidFill>
                   <a:srgbClr val="586471"/>
                 </a:solidFill>
@@ -12447,7 +13196,7 @@
               </a:defRPr>
             </a:lvl2pPr>
             <a:lvl3pPr>
-              <a:defRPr sz="1275" b="0">
+              <a:defRPr sz="1200" b="0">
                 <a:solidFill>
                   <a:srgbClr val="586471"/>
                 </a:solidFill>
@@ -12457,7 +13206,7 @@
               </a:defRPr>
             </a:lvl3pPr>
             <a:lvl4pPr>
-              <a:defRPr sz="1275" b="0">
+              <a:defRPr sz="1200" b="0">
                 <a:solidFill>
                   <a:srgbClr val="586471"/>
                 </a:solidFill>
@@ -12467,7 +13216,7 @@
               </a:defRPr>
             </a:lvl4pPr>
             <a:lvl5pPr>
-              <a:defRPr sz="1275" b="0">
+              <a:defRPr sz="1200" b="0">
                 <a:solidFill>
                   <a:srgbClr val="586471"/>
                 </a:solidFill>
@@ -12477,7 +13226,7 @@
               </a:defRPr>
             </a:lvl5pPr>
             <a:lvl6pPr>
-              <a:defRPr sz="1275" b="0">
+              <a:defRPr sz="1200" b="0">
                 <a:solidFill>
                   <a:srgbClr val="586471"/>
                 </a:solidFill>
@@ -12487,7 +13236,7 @@
               </a:defRPr>
             </a:lvl6pPr>
             <a:lvl7pPr>
-              <a:defRPr sz="1275" b="0">
+              <a:defRPr sz="1200" b="0">
                 <a:solidFill>
                   <a:srgbClr val="586471"/>
                 </a:solidFill>
@@ -12497,7 +13246,7 @@
               </a:defRPr>
             </a:lvl7pPr>
             <a:lvl8pPr>
-              <a:defRPr sz="1275" b="0">
+              <a:defRPr sz="1200" b="0">
                 <a:solidFill>
                   <a:srgbClr val="586471"/>
                 </a:solidFill>
@@ -12507,7 +13256,7 @@
               </a:defRPr>
             </a:lvl8pPr>
             <a:lvl9pPr>
-              <a:defRPr sz="1275" b="0">
+              <a:defRPr sz="1200" b="0">
                 <a:solidFill>
                   <a:srgbClr val="586471"/>
                 </a:solidFill>
@@ -12519,7 +13268,7 @@
           </a:lstStyle>
           <a:p xmlns:a="http://schemas.openxmlformats.org/drawingml/2006/main">
             <a:pPr>
-              <a:defRPr sz="1275" b="0">
+              <a:defRPr sz="1200" b="0">
                 <a:solidFill>
                   <a:srgbClr val="586471"/>
                 </a:solidFill>
@@ -12529,7 +13278,7 @@
               </a:defRPr>
             </a:pPr>
             <a:r>
-              <a:rPr sz="1275" b="0">
+              <a:rPr sz="1200" b="0">
                 <a:solidFill>
                   <a:srgbClr val="586471"/>
                 </a:solidFill>
@@ -12537,7 +13286,7 @@
                 <a:ea typeface="Arial"/>
                 <a:cs typeface="Arial"/>
               </a:rPr>
-              <a:t>Precondition 0: maintained Research Configuration. Supplemental exchange 9: F.5 reports Service Status to the maintainer.</a:t>
+              <a:t>Gray exchanges 0 and 9 are maintained control/status context. Blue and green exchanges form the nominal user trace.</a:t>
             </a:r>
           </a:p>
         </p:txBody>
@@ -12545,7 +13294,7 @@
     </p:spTree>
     <p:extLst>
       <p:ext uri="{BB962C8B-B14F-4D97-AF65-F5344CB8AC3E}">
-        <p14:creationId xmlns:p14="http://schemas.microsoft.com/office/powerpoint/2010/main" val="397561975"/>
+        <p14:creationId xmlns:p14="http://schemas.microsoft.com/office/powerpoint/2010/main" val="1636196180"/>
       </p:ext>
     </p:extLst>
   </p:cSld>

</xml_diff>